<commit_message>
docs: presentation script with timing and cut priority
</commit_message>
<xml_diff>
--- a/aidlc-docs/deliverables/발표덱.pptx
+++ b/aidlc-docs/deliverables/발표덱.pptx
@@ -114,372 +114,6 @@
     </a:lvl9pPr>
   </p:defaultTextStyle>
 </p:presentation>
-</file>
-
-<file path=ppt/charts/chart1.xml><?xml version="1.0" encoding="utf-8"?>
-<c:chartSpace xmlns:c="http://schemas.openxmlformats.org/drawingml/2006/chart" xmlns:a="http://schemas.openxmlformats.org/drawingml/2006/main" xmlns:r="http://schemas.openxmlformats.org/officeDocument/2006/relationships">
-  <c:date1904 val="0"/>
-  <c:roundedCorners val="1"/>
-  <c:chart>
-    <c:autoTitleDeleted val="1"/>
-    <c:plotArea>
-      <c:layout/>
-      <c:barChart>
-        <c:barDir val="bar"/>
-        <c:grouping val="clustered"/>
-        <c:varyColors val="0"/>
-        <c:ser>
-          <c:idx val="0"/>
-          <c:order val="0"/>
-          <c:tx>
-            <c:strRef>
-              <c:f>Sheet1!$B$1</c:f>
-              <c:strCache>
-                <c:ptCount val="1"/>
-                <c:pt idx="0">
-                  <c:v>일반 프롬프트</c:v>
-                </c:pt>
-              </c:strCache>
-            </c:strRef>
-          </c:tx>
-          <c:spPr>
-            <a:solidFill>
-              <a:srgbClr val="B9C2D0"/>
-            </a:solidFill>
-            <a:effectLst/>
-          </c:spPr>
-          <c:invertIfNegative val="0"/>
-          <c:dLbls>
-            <c:numFmt formatCode="#,##0" sourceLinked="0"/>
-            <c:txPr>
-              <a:bodyPr/>
-              <a:lstStyle/>
-              <a:p>
-                <a:pPr>
-                  <a:defRPr b="0" i="0" strike="noStrike" sz="1000" u="none">
-                    <a:solidFill>
-                      <a:srgbClr val="0B1220"/>
-                    </a:solidFill>
-                    <a:latin typeface="Arial"/>
-                  </a:defRPr>
-                </a:pPr>
-              </a:p>
-            </c:txPr>
-            <c:showLegendKey val="0"/>
-            <c:showVal val="1"/>
-            <c:showCatName val="0"/>
-            <c:showSerName val="0"/>
-            <c:showPercent val="0"/>
-            <c:showBubbleSize val="0"/>
-            <c:showLeaderLines val="0"/>
-          </c:dLbls>
-          <c:cat>
-            <c:multiLvlStrRef>
-              <c:f>Sheet1!$A$2:$A$6</c:f>
-              <c:multiLvlStrCache>
-                <c:ptCount val="5"/>
-                <c:lvl>
-                  <c:pt idx="0">
-                    <c:v>어휘 재현</c:v>
-                  </c:pt>
-                  <c:pt idx="1">
-                    <c:v>문장 리듬</c:v>
-                  </c:pt>
-                  <c:pt idx="2">
-                    <c:v>용어 표기</c:v>
-                  </c:pt>
-                  <c:pt idx="3">
-                    <c:v>자사 근거</c:v>
-                  </c:pt>
-                  <c:pt idx="4">
-                    <c:v>범용 표지 없음</c:v>
-                  </c:pt>
-                </c:lvl>
-              </c:multiLvlStrCache>
-            </c:multiLvlStrRef>
-          </c:cat>
-          <c:val>
-            <c:numRef>
-              <c:f>Sheet1!$B$2:$B$6</c:f>
-              <c:numCache>
-                <c:formatCode>General</c:formatCode>
-                <c:ptCount val="5"/>
-                <c:pt idx="0">
-                  <c:v>100</c:v>
-                </c:pt>
-                <c:pt idx="1">
-                  <c:v>67</c:v>
-                </c:pt>
-                <c:pt idx="2">
-                  <c:v>80</c:v>
-                </c:pt>
-                <c:pt idx="3">
-                  <c:v>53</c:v>
-                </c:pt>
-                <c:pt idx="4">
-                  <c:v>100</c:v>
-                </c:pt>
-              </c:numCache>
-            </c:numRef>
-          </c:val>
-        </c:ser>
-        <c:ser>
-          <c:idx val="1"/>
-          <c:order val="1"/>
-          <c:tx>
-            <c:strRef>
-              <c:f>Sheet1!$C$1</c:f>
-              <c:strCache>
-                <c:ptCount val="1"/>
-                <c:pt idx="0">
-                  <c:v>Voice Engine</c:v>
-                </c:pt>
-              </c:strCache>
-            </c:strRef>
-          </c:tx>
-          <c:spPr>
-            <a:solidFill>
-              <a:srgbClr val="1A61EA"/>
-            </a:solidFill>
-            <a:effectLst/>
-          </c:spPr>
-          <c:invertIfNegative val="0"/>
-          <c:dLbls>
-            <c:numFmt formatCode="#,##0" sourceLinked="0"/>
-            <c:txPr>
-              <a:bodyPr/>
-              <a:lstStyle/>
-              <a:p>
-                <a:pPr>
-                  <a:defRPr b="0" i="0" strike="noStrike" sz="1000" u="none">
-                    <a:solidFill>
-                      <a:srgbClr val="0B1220"/>
-                    </a:solidFill>
-                    <a:latin typeface="Arial"/>
-                  </a:defRPr>
-                </a:pPr>
-              </a:p>
-            </c:txPr>
-            <c:showLegendKey val="0"/>
-            <c:showVal val="1"/>
-            <c:showCatName val="0"/>
-            <c:showSerName val="0"/>
-            <c:showPercent val="0"/>
-            <c:showBubbleSize val="0"/>
-            <c:showLeaderLines val="0"/>
-          </c:dLbls>
-          <c:cat>
-            <c:multiLvlStrRef>
-              <c:f>Sheet1!$A$2:$A$6</c:f>
-              <c:multiLvlStrCache>
-                <c:ptCount val="5"/>
-                <c:lvl>
-                  <c:pt idx="0">
-                    <c:v>어휘 재현</c:v>
-                  </c:pt>
-                  <c:pt idx="1">
-                    <c:v>문장 리듬</c:v>
-                  </c:pt>
-                  <c:pt idx="2">
-                    <c:v>용어 표기</c:v>
-                  </c:pt>
-                  <c:pt idx="3">
-                    <c:v>자사 근거</c:v>
-                  </c:pt>
-                  <c:pt idx="4">
-                    <c:v>범용 표지 없음</c:v>
-                  </c:pt>
-                </c:lvl>
-              </c:multiLvlStrCache>
-            </c:multiLvlStrRef>
-          </c:cat>
-          <c:val>
-            <c:numRef>
-              <c:f>Sheet1!$C$2:$C$6</c:f>
-              <c:numCache>
-                <c:formatCode>General</c:formatCode>
-                <c:ptCount val="5"/>
-                <c:pt idx="0">
-                  <c:v>100</c:v>
-                </c:pt>
-                <c:pt idx="1">
-                  <c:v>80</c:v>
-                </c:pt>
-                <c:pt idx="2">
-                  <c:v>100</c:v>
-                </c:pt>
-                <c:pt idx="3">
-                  <c:v>98</c:v>
-                </c:pt>
-                <c:pt idx="4">
-                  <c:v>100</c:v>
-                </c:pt>
-              </c:numCache>
-            </c:numRef>
-          </c:val>
-        </c:ser>
-        <c:dLbls>
-          <c:numFmt formatCode="#,##0" sourceLinked="0"/>
-          <c:txPr>
-            <a:bodyPr/>
-            <a:lstStyle/>
-            <a:p>
-              <a:pPr>
-                <a:defRPr b="0" i="0" strike="noStrike" sz="1000" u="none">
-                  <a:solidFill>
-                    <a:srgbClr val="0B1220"/>
-                  </a:solidFill>
-                  <a:latin typeface="Arial"/>
-                </a:defRPr>
-              </a:pPr>
-            </a:p>
-          </c:txPr>
-          <c:showLegendKey val="0"/>
-          <c:showVal val="1"/>
-          <c:showCatName val="0"/>
-          <c:showSerName val="0"/>
-          <c:showPercent val="0"/>
-          <c:showBubbleSize val="0"/>
-          <c:showLeaderLines val="0"/>
-        </c:dLbls>
-        <c:gapWidth val="150"/>
-        <c:overlap val="0"/>
-        <c:axId val="2094734554"/>
-        <c:axId val="2094734552"/>
-        <c:axId val="2094734556"/>
-      </c:barChart>
-      <c:catAx>
-        <c:axId val="2094734554"/>
-        <c:scaling>
-          <c:orientation val="minMax"/>
-        </c:scaling>
-        <c:delete val="0"/>
-        <c:axPos val="l"/>
-        <c:numFmt formatCode="General" sourceLinked="1"/>
-        <c:majorTickMark val="out"/>
-        <c:minorTickMark val="none"/>
-        <c:tickLblPos val="nextTo"/>
-        <c:spPr>
-          <a:ln w="12700" cap="flat">
-            <a:solidFill>
-              <a:srgbClr val="888888"/>
-            </a:solidFill>
-            <a:prstDash val="solid"/>
-            <a:round/>
-          </a:ln>
-        </c:spPr>
-        <c:txPr>
-          <a:bodyPr/>
-          <a:lstStyle/>
-          <a:p>
-            <a:pPr>
-              <a:defRPr sz="1100" b="0" i="0" u="none" strike="noStrike">
-                <a:solidFill>
-                  <a:srgbClr val="6E7A8A"/>
-                </a:solidFill>
-                <a:latin typeface="Arial"/>
-              </a:defRPr>
-            </a:pPr>
-            <a:endParaRPr lang="en-US"/>
-          </a:p>
-        </c:txPr>
-        <c:crossAx val="2094734552"/>
-        <c:crosses val="autoZero"/>
-        <c:auto val="1"/>
-        <c:lblAlgn val="ctr"/>
-        <c:noMultiLvlLbl val="1"/>
-      </c:catAx>
-      <c:valAx>
-        <c:axId val="2094734552"/>
-        <c:scaling>
-          <c:orientation val="minMax"/>
-          <c:max val="110"/>
-        </c:scaling>
-        <c:delete val="0"/>
-        <c:axPos val="b"/>
-        <c:majorGridlines>
-          <c:spPr>
-            <a:ln w="12700" cap="flat">
-              <a:solidFill>
-                <a:srgbClr val="E6E9EF"/>
-              </a:solidFill>
-              <a:prstDash val="solid"/>
-              <a:round/>
-            </a:ln>
-          </c:spPr>
-        </c:majorGridlines>
-        <c:numFmt formatCode="General" sourceLinked="0"/>
-        <c:majorTickMark val="out"/>
-        <c:minorTickMark val="none"/>
-        <c:tickLblPos val="low"/>
-        <c:spPr>
-          <a:ln w="12700" cap="flat">
-            <a:solidFill>
-              <a:srgbClr val="888888"/>
-            </a:solidFill>
-            <a:prstDash val="solid"/>
-            <a:round/>
-          </a:ln>
-        </c:spPr>
-        <c:txPr>
-          <a:bodyPr/>
-          <a:lstStyle/>
-          <a:p>
-            <a:pPr>
-              <a:defRPr sz="1000" b="0" i="0" u="none" strike="noStrike">
-                <a:solidFill>
-                  <a:srgbClr val="6E7A8A"/>
-                </a:solidFill>
-                <a:latin typeface="Arial"/>
-              </a:defRPr>
-            </a:pPr>
-            <a:endParaRPr lang="en-US"/>
-          </a:p>
-        </c:txPr>
-        <c:crossAx val="2094734554"/>
-        <c:crosses val="autoZero"/>
-        <c:crossBetween val="between"/>
-      </c:valAx>
-      <c:spPr>
-        <a:noFill/>
-        <a:ln>
-          <a:noFill/>
-        </a:ln>
-        <a:effectLst/>
-      </c:spPr>
-    </c:plotArea>
-    <c:legend>
-      <c:legendPos val="t"/>
-      <c:overlay val="0"/>
-      <c:txPr>
-        <a:bodyPr/>
-        <a:lstStyle/>
-        <a:p>
-          <a:pPr>
-            <a:defRPr sz="1100">
-              <a:solidFill>
-                <a:srgbClr val="6E7A8A"/>
-              </a:solidFill>
-            </a:defRPr>
-          </a:pPr>
-          <a:endParaRPr lang="en-US"/>
-        </a:p>
-      </c:txPr>
-    </c:legend>
-    <c:plotVisOnly val="1"/>
-    <c:dispBlanksAs val="span"/>
-  </c:chart>
-  <c:spPr>
-    <a:noFill/>
-    <a:ln>
-      <a:noFill/>
-    </a:ln>
-    <a:effectLst/>
-  </c:spPr>
-  <c:externalData r:id="rId1">
-    <c:autoUpdate val="0"/>
-  </c:externalData>
-</c:chartSpace>
 </file>
 
 <file path=ppt/notesMasters/notesMaster1.xml><?xml version="1.0" encoding="utf-8"?>
@@ -1405,7 +1039,7 @@
           <a:p>
             <a:r>
               <a:rPr lang="en-US" dirty="0"/>
-              <a:t>45초. 자사 근거 53 대 98만 짚습니다. 점수 출처 질문이 나오기 전에 오른쪽 카드로 먼저 답합니다.</a:t>
+              <a:t>45초. 두 글을 소리 내어 비교하지 말고, 왼쪽 첫 문장과 오른쪽 첫 문장만 읽습니다. 아래 네 칸이 근거입니다.</a:t>
             </a:r>
             <a:endParaRPr lang="en-US" dirty="0"/>
           </a:p>
@@ -1493,7 +1127,7 @@
           <a:p>
             <a:r>
               <a:rPr lang="en-US" dirty="0"/>
-              <a:t>25초. 마지막 문장을 천천히 읽고 다음 장으로 넘어갑니다.</a:t>
+              <a:t>35초. 왼쪽은 훑고, 오른쪽 상단 관문만 또박또박 말합니다. 폐기 사례는 시간이 없으면 생략하고 질문 때 씁니다.</a:t>
             </a:r>
             <a:endParaRPr lang="en-US" dirty="0"/>
           </a:p>
@@ -5308,7 +4942,7 @@
                 <a:ea typeface="Calibri" pitchFamily="34" charset="-122"/>
                 <a:cs typeface="Calibri" pitchFamily="34" charset="-120"/>
               </a:rPr>
-              <a:t>왜 그냥 범용 LLM을 쓰지 않는가</a:t>
+              <a:t>같은 모델에 같은 주제를 넣었습니다</a:t>
             </a:r>
             <a:endParaRPr lang="en-US" sz="3000" dirty="0"/>
           </a:p>
@@ -5347,7 +4981,7 @@
                 <a:ea typeface="Calibri" pitchFamily="34" charset="-122"/>
                 <a:cs typeface="Calibri" pitchFamily="34" charset="-120"/>
               </a:rPr>
-              <a:t>같은 모델(gemini-3.6-flash), 같은 주제. 바뀐 것은 문체·학습된 규칙·실데이터 근거 셋뿐입니다</a:t>
+              <a:t>gemini-3.6-flash · 주제: "인재 채용 전략"을 찾는 실무자를 위한 실행 가이드 · 바뀐 것은 문체·학습된 규칙·실데이터 근거뿐입니다</a:t>
             </a:r>
             <a:endParaRPr lang="en-US" sz="1400" dirty="0"/>
           </a:p>
@@ -5361,12 +4995,12 @@
         </p:nvSpPr>
         <p:spPr>
           <a:xfrm>
-            <a:off x="777240" y="2057400"/>
-            <a:ext cx="5029200" cy="1371600"/>
+            <a:off x="777240" y="1874520"/>
+            <a:ext cx="5120640" cy="3246120"/>
           </a:xfrm>
           <a:prstGeom prst="roundRect">
             <a:avLst>
-              <a:gd name="adj" fmla="val 5333"/>
+              <a:gd name="adj" fmla="val 2254"/>
             </a:avLst>
           </a:prstGeom>
           <a:solidFill>
@@ -5388,24 +5022,38 @@
         </p:nvSpPr>
         <p:spPr>
           <a:xfrm>
-            <a:off x="1097280" y="2267712"/>
-            <a:ext cx="3657600" cy="256032"/>
-          </a:xfrm>
-          <a:prstGeom prst="rect">
-            <a:avLst/>
-          </a:prstGeom>
-          <a:noFill/>
-          <a:ln/>
-        </p:spPr>
-        <p:txBody>
-          <a:bodyPr wrap="square" lIns="0" tIns="0" rIns="0" bIns="0" rtlCol="0" anchor="ctr"/>
-          <a:lstStyle/>
-          <a:p>
-            <a:pPr indent="0" marL="0">
-              <a:buNone/>
-            </a:pPr>
-            <a:r>
-              <a:rPr lang="en-US" sz="1250" dirty="0">
+            <a:off x="1051560" y="2048256"/>
+            <a:ext cx="4572000" cy="256032"/>
+          </a:xfrm>
+          <a:prstGeom prst="rect">
+            <a:avLst/>
+          </a:prstGeom>
+          <a:noFill/>
+          <a:ln/>
+        </p:spPr>
+        <p:txBody>
+          <a:bodyPr wrap="square" lIns="0" tIns="0" rIns="0" bIns="0" rtlCol="0" anchor="ctr"/>
+          <a:lstStyle/>
+          <a:p>
+            <a:pPr indent="0" marL="0">
+              <a:buNone/>
+            </a:pPr>
+            <a:r>
+              <a:rPr lang="en-US" sz="1300" b="1" dirty="0">
+                <a:solidFill>
+                  <a:srgbClr val="0B1220"/>
+                </a:solidFill>
+                <a:latin typeface="Calibri" pitchFamily="34" charset="0"/>
+                <a:ea typeface="Calibri" pitchFamily="34" charset="-122"/>
+                <a:cs typeface="Calibri" pitchFamily="34" charset="-120"/>
+              </a:rPr>
+              <a:t>일반 프롬프트</a:t>
+            </a:r>
+            <a:pPr indent="0" marL="0">
+              <a:buNone/>
+            </a:pPr>
+            <a:r>
+              <a:rPr lang="en-US" sz="1150" dirty="0">
                 <a:solidFill>
                   <a:srgbClr val="6E7A8A"/>
                 </a:solidFill>
@@ -5413,9 +5061,9 @@
                 <a:ea typeface="Calibri" pitchFamily="34" charset="-122"/>
                 <a:cs typeface="Calibri" pitchFamily="34" charset="-120"/>
               </a:rPr>
-              <a:t>일반 프롬프트</a:t>
-            </a:r>
-            <a:endParaRPr lang="en-US" sz="1250" dirty="0"/>
+              <a:t>   주제만 전달</a:t>
+            </a:r>
+            <a:endParaRPr lang="en-US" sz="1300" dirty="0"/>
           </a:p>
         </p:txBody>
       </p:sp>
@@ -5427,48 +5075,173 @@
         </p:nvSpPr>
         <p:spPr>
           <a:xfrm>
-            <a:off x="1097280" y="2606040"/>
-            <a:ext cx="4572000" cy="548640"/>
-          </a:xfrm>
-          <a:prstGeom prst="rect">
-            <a:avLst/>
-          </a:prstGeom>
-          <a:noFill/>
-          <a:ln/>
-        </p:spPr>
-        <p:txBody>
-          <a:bodyPr wrap="square" lIns="0" tIns="0" rIns="0" bIns="0" rtlCol="0" anchor="ctr"/>
-          <a:lstStyle/>
-          <a:p>
-            <a:pPr indent="0" marL="0">
-              <a:buNone/>
-            </a:pPr>
-            <a:r>
-              <a:rPr lang="en-US" sz="3400" b="1" dirty="0">
-                <a:solidFill>
-                  <a:srgbClr val="0B1220"/>
-                </a:solidFill>
-                <a:latin typeface="Calibri" pitchFamily="34" charset="0"/>
-                <a:ea typeface="Calibri" pitchFamily="34" charset="-122"/>
-                <a:cs typeface="Calibri" pitchFamily="34" charset="-120"/>
-              </a:rPr>
-              <a:t>83</a:t>
-            </a:r>
-            <a:pPr indent="0" marL="0">
-              <a:buNone/>
-            </a:pPr>
-            <a:r>
-              <a:rPr lang="en-US" sz="1350" dirty="0">
-                <a:solidFill>
-                  <a:srgbClr val="6E7A8A"/>
-                </a:solidFill>
-                <a:latin typeface="Calibri" pitchFamily="34" charset="0"/>
-                <a:ea typeface="Calibri" pitchFamily="34" charset="-122"/>
-                <a:cs typeface="Calibri" pitchFamily="34" charset="-120"/>
-              </a:rPr>
-              <a:t>점 · 5,188자 · 자사 언급 0회</a:t>
-            </a:r>
-            <a:endParaRPr lang="en-US" sz="3400" dirty="0"/>
+            <a:off x="1051560" y="2395728"/>
+            <a:ext cx="4572000" cy="2560320"/>
+          </a:xfrm>
+          <a:prstGeom prst="rect">
+            <a:avLst/>
+          </a:prstGeom>
+          <a:noFill/>
+          <a:ln/>
+        </p:spPr>
+        <p:txBody>
+          <a:bodyPr wrap="square" lIns="0" tIns="0" rIns="0" bIns="0" rtlCol="0" anchor="ctr"/>
+          <a:lstStyle/>
+          <a:p>
+            <a:pPr indent="0" marL="0">
+              <a:lnSpc>
+                <a:spcPts val="1500"/>
+              </a:lnSpc>
+              <a:buNone/>
+            </a:pPr>
+            <a:r>
+              <a:rPr lang="en-US" sz="1050" dirty="0">
+                <a:solidFill>
+                  <a:srgbClr val="5A6675"/>
+                </a:solidFill>
+                <a:latin typeface="Calibri" pitchFamily="34" charset="0"/>
+                <a:ea typeface="Calibri" pitchFamily="34" charset="-122"/>
+                <a:cs typeface="Calibri" pitchFamily="34" charset="-120"/>
+              </a:rPr>
+              <a:t># 인재 채용 전략을 찾는 실무자를 위한 실행 가이드</a:t>
+            </a:r>
+            <a:endParaRPr lang="en-US" sz="1050" dirty="0"/>
+          </a:p>
+          <a:p>
+            <a:pPr indent="0" marL="0">
+              <a:lnSpc>
+                <a:spcPts val="1500"/>
+              </a:lnSpc>
+              <a:buNone/>
+            </a:pPr>
+            <a:endParaRPr lang="en-US" sz="1050" dirty="0"/>
+          </a:p>
+          <a:p>
+            <a:pPr indent="0" marL="0">
+              <a:lnSpc>
+                <a:spcPts val="1500"/>
+              </a:lnSpc>
+              <a:buNone/>
+            </a:pPr>
+            <a:r>
+              <a:rPr lang="en-US" sz="1050" dirty="0">
+                <a:solidFill>
+                  <a:srgbClr val="5A6675"/>
+                </a:solidFill>
+                <a:latin typeface="Calibri" pitchFamily="34" charset="0"/>
+                <a:ea typeface="Calibri" pitchFamily="34" charset="-122"/>
+                <a:cs typeface="Calibri" pitchFamily="34" charset="-120"/>
+              </a:rPr>
+              <a:t>인재 확보는 기업 성장의 핵심이지만, “좋은 사람을 어떻게 찾고, 어떻게 유지할까?” 라는 질문에 대한 답은 늘 복잡합니다. 이번 포스트에서는 **실무자가 바로 적용할 수 있는 구체적인 채용 전략**을 단계별로 정리했습니다.</a:t>
+            </a:r>
+            <a:endParaRPr lang="en-US" sz="1050" dirty="0"/>
+          </a:p>
+          <a:p>
+            <a:pPr indent="0" marL="0">
+              <a:lnSpc>
+                <a:spcPts val="1500"/>
+              </a:lnSpc>
+              <a:buNone/>
+            </a:pPr>
+            <a:endParaRPr lang="en-US" sz="1050" dirty="0"/>
+          </a:p>
+          <a:p>
+            <a:pPr indent="0" marL="0">
+              <a:lnSpc>
+                <a:spcPts val="1500"/>
+              </a:lnSpc>
+              <a:buNone/>
+            </a:pPr>
+            <a:r>
+              <a:rPr lang="en-US" sz="1050" dirty="0">
+                <a:solidFill>
+                  <a:srgbClr val="5A6675"/>
+                </a:solidFill>
+                <a:latin typeface="Calibri" pitchFamily="34" charset="0"/>
+                <a:ea typeface="Calibri" pitchFamily="34" charset="-122"/>
+                <a:cs typeface="Calibri" pitchFamily="34" charset="-120"/>
+              </a:rPr>
+              <a:t>## 1️⃣ 채용 목표와 KPI 정의하기</a:t>
+            </a:r>
+            <a:endParaRPr lang="en-US" sz="1050" dirty="0"/>
+          </a:p>
+          <a:p>
+            <a:pPr indent="0" marL="0">
+              <a:lnSpc>
+                <a:spcPts val="1500"/>
+              </a:lnSpc>
+              <a:buNone/>
+            </a:pPr>
+            <a:endParaRPr lang="en-US" sz="1050" dirty="0"/>
+          </a:p>
+          <a:p>
+            <a:pPr indent="0" marL="0">
+              <a:lnSpc>
+                <a:spcPts val="1500"/>
+              </a:lnSpc>
+              <a:buNone/>
+            </a:pPr>
+            <a:r>
+              <a:rPr lang="en-US" sz="1050" dirty="0">
+                <a:solidFill>
+                  <a:srgbClr val="5A6675"/>
+                </a:solidFill>
+                <a:latin typeface="Calibri" pitchFamily="34" charset="0"/>
+                <a:ea typeface="Calibri" pitchFamily="34" charset="-122"/>
+                <a:cs typeface="Calibri" pitchFamily="34" charset="-120"/>
+              </a:rPr>
+              <a:t>| 단계 | 핵심 질문 | 구체적인 산출물 |</a:t>
+            </a:r>
+            <a:endParaRPr lang="en-US" sz="1050" dirty="0"/>
+          </a:p>
+          <a:p>
+            <a:pPr indent="0" marL="0">
+              <a:lnSpc>
+                <a:spcPts val="1500"/>
+              </a:lnSpc>
+              <a:buNone/>
+            </a:pPr>
+            <a:r>
+              <a:rPr lang="en-US" sz="1050" dirty="0">
+                <a:solidFill>
+                  <a:srgbClr val="5A6675"/>
+                </a:solidFill>
+                <a:latin typeface="Calibri" pitchFamily="34" charset="0"/>
+                <a:ea typeface="Calibri" pitchFamily="34" charset="-122"/>
+                <a:cs typeface="Calibri" pitchFamily="34" charset="-120"/>
+              </a:rPr>
+              <a:t>| 1-1 | 우리 조직이 채용해야 할 인재는 누구인가? | 포지션 정의서 |</a:t>
+            </a:r>
+            <a:endParaRPr lang="en-US" sz="1050" dirty="0"/>
+          </a:p>
+          <a:p>
+            <a:pPr indent="0" marL="0">
+              <a:lnSpc>
+                <a:spcPts val="1500"/>
+              </a:lnSpc>
+              <a:buNone/>
+            </a:pPr>
+            <a:endParaRPr lang="en-US" sz="1050" dirty="0"/>
+          </a:p>
+          <a:p>
+            <a:pPr indent="0" marL="0">
+              <a:lnSpc>
+                <a:spcPts val="1500"/>
+              </a:lnSpc>
+              <a:buNone/>
+            </a:pPr>
+            <a:r>
+              <a:rPr lang="en-US" sz="1050" dirty="0">
+                <a:solidFill>
+                  <a:srgbClr val="5A6675"/>
+                </a:solidFill>
+                <a:latin typeface="Calibri" pitchFamily="34" charset="0"/>
+                <a:ea typeface="Calibri" pitchFamily="34" charset="-122"/>
+                <a:cs typeface="Calibri" pitchFamily="34" charset="-120"/>
+              </a:rPr>
+              <a:t>&gt; Tip: KPI는 SMART 원칙에 맞춰 설정하면 …</a:t>
+            </a:r>
+            <a:endParaRPr lang="en-US" sz="1050" dirty="0"/>
           </a:p>
         </p:txBody>
       </p:sp>
@@ -5480,12 +5253,12 @@
         </p:nvSpPr>
         <p:spPr>
           <a:xfrm>
-            <a:off x="6217920" y="2057400"/>
-            <a:ext cx="5029200" cy="1371600"/>
+            <a:off x="6217920" y="1874520"/>
+            <a:ext cx="5120640" cy="3246120"/>
           </a:xfrm>
           <a:prstGeom prst="roundRect">
             <a:avLst>
-              <a:gd name="adj" fmla="val 5333"/>
+              <a:gd name="adj" fmla="val 2254"/>
             </a:avLst>
           </a:prstGeom>
           <a:solidFill>
@@ -5507,24 +5280,24 @@
         </p:nvSpPr>
         <p:spPr>
           <a:xfrm>
-            <a:off x="6537960" y="2267712"/>
-            <a:ext cx="3657600" cy="256032"/>
-          </a:xfrm>
-          <a:prstGeom prst="rect">
-            <a:avLst/>
-          </a:prstGeom>
-          <a:noFill/>
-          <a:ln/>
-        </p:spPr>
-        <p:txBody>
-          <a:bodyPr wrap="square" lIns="0" tIns="0" rIns="0" bIns="0" rtlCol="0" anchor="ctr"/>
-          <a:lstStyle/>
-          <a:p>
-            <a:pPr indent="0" marL="0">
-              <a:buNone/>
-            </a:pPr>
-            <a:r>
-              <a:rPr lang="en-US" sz="1250" dirty="0">
+            <a:off x="6492240" y="2048256"/>
+            <a:ext cx="4572000" cy="256032"/>
+          </a:xfrm>
+          <a:prstGeom prst="rect">
+            <a:avLst/>
+          </a:prstGeom>
+          <a:noFill/>
+          <a:ln/>
+        </p:spPr>
+        <p:txBody>
+          <a:bodyPr wrap="square" lIns="0" tIns="0" rIns="0" bIns="0" rtlCol="0" anchor="ctr"/>
+          <a:lstStyle/>
+          <a:p>
+            <a:pPr indent="0" marL="0">
+              <a:buNone/>
+            </a:pPr>
+            <a:r>
+              <a:rPr lang="en-US" sz="1300" b="1" dirty="0">
                 <a:solidFill>
                   <a:srgbClr val="1A61EA"/>
                 </a:solidFill>
@@ -5534,7 +5307,21 @@
               </a:rPr>
               <a:t>Voice Engine</a:t>
             </a:r>
-            <a:endParaRPr lang="en-US" sz="1250" dirty="0"/>
+            <a:pPr indent="0" marL="0">
+              <a:buNone/>
+            </a:pPr>
+            <a:r>
+              <a:rPr lang="en-US" sz="1150" dirty="0">
+                <a:solidFill>
+                  <a:srgbClr val="6E7A8A"/>
+                </a:solidFill>
+                <a:latin typeface="Calibri" pitchFamily="34" charset="0"/>
+                <a:ea typeface="Calibri" pitchFamily="34" charset="-122"/>
+                <a:cs typeface="Calibri" pitchFamily="34" charset="-120"/>
+              </a:rPr>
+              <a:t>   문체 · 규칙 · 근거 주입</a:t>
+            </a:r>
+            <a:endParaRPr lang="en-US" sz="1300" dirty="0"/>
           </a:p>
         </p:txBody>
       </p:sp>
@@ -5546,81 +5333,132 @@
         </p:nvSpPr>
         <p:spPr>
           <a:xfrm>
-            <a:off x="6537960" y="2606040"/>
-            <a:ext cx="4572000" cy="548640"/>
-          </a:xfrm>
-          <a:prstGeom prst="rect">
-            <a:avLst/>
-          </a:prstGeom>
-          <a:noFill/>
-          <a:ln/>
-        </p:spPr>
-        <p:txBody>
-          <a:bodyPr wrap="square" lIns="0" tIns="0" rIns="0" bIns="0" rtlCol="0" anchor="ctr"/>
-          <a:lstStyle/>
-          <a:p>
-            <a:pPr indent="0" marL="0">
-              <a:buNone/>
-            </a:pPr>
-            <a:r>
-              <a:rPr lang="en-US" sz="3400" b="1" dirty="0">
-                <a:solidFill>
-                  <a:srgbClr val="1A61EA"/>
-                </a:solidFill>
-                <a:latin typeface="Calibri" pitchFamily="34" charset="0"/>
-                <a:ea typeface="Calibri" pitchFamily="34" charset="-122"/>
-                <a:cs typeface="Calibri" pitchFamily="34" charset="-120"/>
-              </a:rPr>
-              <a:t>96</a:t>
-            </a:r>
-            <a:pPr indent="0" marL="0">
-              <a:buNone/>
-            </a:pPr>
-            <a:r>
-              <a:rPr lang="en-US" sz="1350" dirty="0">
-                <a:solidFill>
-                  <a:srgbClr val="6E7A8A"/>
-                </a:solidFill>
-                <a:latin typeface="Calibri" pitchFamily="34" charset="0"/>
-                <a:ea typeface="Calibri" pitchFamily="34" charset="-122"/>
-                <a:cs typeface="Calibri" pitchFamily="34" charset="-120"/>
-              </a:rPr>
-              <a:t>점 · 1,196자 · 자사 언급 3회</a:t>
-            </a:r>
-            <a:endParaRPr lang="en-US" sz="3400" dirty="0"/>
-          </a:p>
-        </p:txBody>
-      </p:sp>
-      <p:graphicFrame>
-        <p:nvGraphicFramePr>
-          <p:cNvPr id="11" name="Chart 0" descr=""/>
-          <p:cNvGraphicFramePr/>
-          <p:nvPr/>
-        </p:nvGraphicFramePr>
-        <p:xfrm>
-          <a:off x="777240" y="3611880"/>
-          <a:ext cx="6766560" cy="2514600"/>
-        </p:xfrm>
-        <a:graphic xmlns:a="http://schemas.openxmlformats.org/drawingml/2006/main">
-          <a:graphicData uri="http://schemas.openxmlformats.org/drawingml/2006/chart">
-            <c:chart xmlns:c="http://schemas.openxmlformats.org/drawingml/2006/chart" r:id="rId1"/>
-          </a:graphicData>
-        </a:graphic>
-      </p:graphicFrame>
-      <p:sp>
-        <p:nvSpPr>
-          <p:cNvPr id="12" name="Shape 9"/>
+            <a:off x="6492240" y="2395728"/>
+            <a:ext cx="4572000" cy="2560320"/>
+          </a:xfrm>
+          <a:prstGeom prst="rect">
+            <a:avLst/>
+          </a:prstGeom>
+          <a:noFill/>
+          <a:ln/>
+        </p:spPr>
+        <p:txBody>
+          <a:bodyPr wrap="square" lIns="0" tIns="0" rIns="0" bIns="0" rtlCol="0" anchor="ctr"/>
+          <a:lstStyle/>
+          <a:p>
+            <a:pPr indent="0" marL="0">
+              <a:lnSpc>
+                <a:spcPts val="1500"/>
+              </a:lnSpc>
+              <a:buNone/>
+            </a:pPr>
+            <a:r>
+              <a:rPr lang="en-US" sz="1050" dirty="0">
+                <a:solidFill>
+                  <a:srgbClr val="0B1220"/>
+                </a:solidFill>
+                <a:latin typeface="Calibri" pitchFamily="34" charset="0"/>
+                <a:ea typeface="Calibri" pitchFamily="34" charset="-122"/>
+                <a:cs typeface="Calibri" pitchFamily="34" charset="-120"/>
+              </a:rPr>
+              <a:t>IT 기업 A사는 검증되지 않은 이력서만 보고 개발자를 채용했다가 조기 퇴사 문제를 겪었습니다. 실무에 필요한 실제 기술 역량을 입사 전에 파악하기 어려웠기 때문입니다.</a:t>
+            </a:r>
+            <a:endParaRPr lang="en-US" sz="1050" dirty="0"/>
+          </a:p>
+          <a:p>
+            <a:pPr indent="0" marL="0">
+              <a:lnSpc>
+                <a:spcPts val="1500"/>
+              </a:lnSpc>
+              <a:buNone/>
+            </a:pPr>
+            <a:endParaRPr lang="en-US" sz="1050" dirty="0"/>
+          </a:p>
+          <a:p>
+            <a:pPr indent="0" marL="0">
+              <a:lnSpc>
+                <a:spcPts val="1500"/>
+              </a:lnSpc>
+              <a:buNone/>
+            </a:pPr>
+            <a:r>
+              <a:rPr lang="en-US" sz="1050" dirty="0">
+                <a:solidFill>
+                  <a:srgbClr val="0B1220"/>
+                </a:solidFill>
+                <a:latin typeface="Calibri" pitchFamily="34" charset="0"/>
+                <a:ea typeface="Calibri" pitchFamily="34" charset="-122"/>
+                <a:cs typeface="Calibri" pitchFamily="34" charset="-120"/>
+              </a:rPr>
+              <a:t>최근 포털에서 인재 채용 전략 관련 검색 노출 221회가 발생했으나 평균순위 20.6위로 실질적인 해결책을 찾지 못한 채용 담당자가 많습니다.</a:t>
+            </a:r>
+            <a:endParaRPr lang="en-US" sz="1050" dirty="0"/>
+          </a:p>
+          <a:p>
+            <a:pPr indent="0" marL="0">
+              <a:lnSpc>
+                <a:spcPts val="1500"/>
+              </a:lnSpc>
+              <a:buNone/>
+            </a:pPr>
+            <a:endParaRPr lang="en-US" sz="1050" dirty="0"/>
+          </a:p>
+          <a:p>
+            <a:pPr indent="0" marL="0">
+              <a:lnSpc>
+                <a:spcPts val="1500"/>
+              </a:lnSpc>
+              <a:buNone/>
+            </a:pPr>
+            <a:r>
+              <a:rPr lang="en-US" sz="1050" dirty="0">
+                <a:solidFill>
+                  <a:srgbClr val="0B1220"/>
+                </a:solidFill>
+                <a:latin typeface="Calibri" pitchFamily="34" charset="0"/>
+                <a:ea typeface="Calibri" pitchFamily="34" charset="-122"/>
+                <a:cs typeface="Calibri" pitchFamily="34" charset="-120"/>
+              </a:rPr>
+              <a:t>### 서류 검증을 넘어선 실제 역량 중심의 평가 설계</a:t>
+            </a:r>
+            <a:endParaRPr lang="en-US" sz="1050" dirty="0"/>
+          </a:p>
+          <a:p>
+            <a:pPr indent="0" marL="0">
+              <a:lnSpc>
+                <a:spcPts val="1500"/>
+              </a:lnSpc>
+              <a:buNone/>
+            </a:pPr>
+            <a:r>
+              <a:rPr lang="en-US" sz="1050" dirty="0">
+                <a:solidFill>
+                  <a:srgbClr val="0B1220"/>
+                </a:solidFill>
+                <a:latin typeface="Calibri" pitchFamily="34" charset="0"/>
+                <a:ea typeface="Calibri" pitchFamily="34" charset="-122"/>
+                <a:cs typeface="Calibri" pitchFamily="34" charset="-120"/>
+              </a:rPr>
+              <a:t>코드프레소의 SkillCertify는 지원자가 실제 개발 환경에서 코드를 작성하고 문제를 해결하는 과정을 다각도로 평가합니다. …</a:t>
+            </a:r>
+            <a:endParaRPr lang="en-US" sz="1050" dirty="0"/>
+          </a:p>
+        </p:txBody>
+      </p:sp>
+      <p:sp>
+        <p:nvSpPr>
+          <p:cNvPr id="11" name="Shape 9"/>
           <p:cNvSpPr/>
           <p:nvPr/>
         </p:nvSpPr>
         <p:spPr>
           <a:xfrm>
-            <a:off x="7818120" y="3611880"/>
-            <a:ext cx="3429000" cy="2514600"/>
+            <a:off x="777240" y="5285232"/>
+            <a:ext cx="2514600" cy="841248"/>
           </a:xfrm>
           <a:prstGeom prst="roundRect">
             <a:avLst>
-              <a:gd name="adj" fmla="val 2909"/>
+              <a:gd name="adj" fmla="val 8696"/>
             </a:avLst>
           </a:prstGeom>
           <a:solidFill>
@@ -5636,109 +5474,504 @@
       </p:sp>
       <p:sp>
         <p:nvSpPr>
-          <p:cNvPr id="13" name="Text 10"/>
-          <p:cNvSpPr txBox="1"/>
-          <p:nvPr/>
-        </p:nvSpPr>
-        <p:spPr>
-          <a:xfrm>
-            <a:off x="8092440" y="3822192"/>
-            <a:ext cx="2926080" cy="274320"/>
-          </a:xfrm>
-          <a:prstGeom prst="rect">
-            <a:avLst/>
-          </a:prstGeom>
-          <a:noFill/>
-          <a:ln/>
-        </p:spPr>
-        <p:txBody>
-          <a:bodyPr wrap="square" lIns="0" tIns="0" rIns="0" bIns="0" rtlCol="0" anchor="ctr"/>
-          <a:lstStyle/>
-          <a:p>
-            <a:pPr indent="0" marL="0">
-              <a:buNone/>
-            </a:pPr>
-            <a:r>
-              <a:rPr lang="en-US" sz="1400" b="1" dirty="0">
-                <a:solidFill>
-                  <a:srgbClr val="0B1220"/>
-                </a:solidFill>
-                <a:latin typeface="Calibri" pitchFamily="34" charset="0"/>
-                <a:ea typeface="Calibri" pitchFamily="34" charset="-122"/>
-                <a:cs typeface="Calibri" pitchFamily="34" charset="-120"/>
-              </a:rPr>
-              <a:t>점수는 어디서 왔는가</a:t>
-            </a:r>
-            <a:endParaRPr lang="en-US" sz="1400" dirty="0"/>
-          </a:p>
-        </p:txBody>
-      </p:sp>
-      <p:sp>
-        <p:nvSpPr>
-          <p:cNvPr id="14" name="Text 11"/>
-          <p:cNvSpPr txBox="1"/>
-          <p:nvPr/>
-        </p:nvSpPr>
-        <p:spPr>
-          <a:xfrm>
-            <a:off x="8092440" y="4160520"/>
-            <a:ext cx="2926080" cy="1828800"/>
-          </a:xfrm>
-          <a:prstGeom prst="rect">
-            <a:avLst/>
-          </a:prstGeom>
-          <a:noFill/>
-          <a:ln/>
-        </p:spPr>
-        <p:txBody>
-          <a:bodyPr wrap="square" lIns="0" tIns="0" rIns="0" bIns="0" rtlCol="0" anchor="ctr"/>
-          <a:lstStyle/>
-          <a:p>
-            <a:pPr indent="0" marL="0">
-              <a:lnSpc>
-                <a:spcPts val="1600"/>
-              </a:lnSpc>
+          <p:cNvPr id="12" name="Text 10"/>
+          <p:cNvSpPr txBox="1"/>
+          <p:nvPr/>
+        </p:nvSpPr>
+        <p:spPr>
+          <a:xfrm>
+            <a:off x="978408" y="5394960"/>
+            <a:ext cx="2194560" cy="219456"/>
+          </a:xfrm>
+          <a:prstGeom prst="rect">
+            <a:avLst/>
+          </a:prstGeom>
+          <a:noFill/>
+          <a:ln/>
+        </p:spPr>
+        <p:txBody>
+          <a:bodyPr wrap="square" lIns="0" tIns="0" rIns="0" bIns="0" rtlCol="0" anchor="ctr"/>
+          <a:lstStyle/>
+          <a:p>
+            <a:pPr indent="0" marL="0">
+              <a:buNone/>
+            </a:pPr>
+            <a:r>
+              <a:rPr lang="en-US" sz="1050" dirty="0">
+                <a:solidFill>
+                  <a:srgbClr val="6E7A8A"/>
+                </a:solidFill>
+                <a:latin typeface="Calibri" pitchFamily="34" charset="0"/>
+                <a:ea typeface="Calibri" pitchFamily="34" charset="-122"/>
+                <a:cs typeface="Calibri" pitchFamily="34" charset="-120"/>
+              </a:rPr>
+              <a:t>도입부</a:t>
+            </a:r>
+            <a:endParaRPr lang="en-US" sz="1050" dirty="0"/>
+          </a:p>
+        </p:txBody>
+      </p:sp>
+      <p:sp>
+        <p:nvSpPr>
+          <p:cNvPr id="13" name="Text 11"/>
+          <p:cNvSpPr txBox="1"/>
+          <p:nvPr/>
+        </p:nvSpPr>
+        <p:spPr>
+          <a:xfrm>
+            <a:off x="978408" y="5650992"/>
+            <a:ext cx="2194560" cy="384048"/>
+          </a:xfrm>
+          <a:prstGeom prst="rect">
+            <a:avLst/>
+          </a:prstGeom>
+          <a:noFill/>
+          <a:ln/>
+        </p:spPr>
+        <p:txBody>
+          <a:bodyPr wrap="square" lIns="0" tIns="0" rIns="0" bIns="0" rtlCol="0" anchor="ctr"/>
+          <a:lstStyle/>
+          <a:p>
+            <a:pPr indent="0" marL="0">
               <a:buNone/>
             </a:pPr>
             <a:r>
               <a:rPr lang="en-US" sz="1100" dirty="0">
                 <a:solidFill>
-                  <a:srgbClr val="38445A"/>
-                </a:solidFill>
-                <a:latin typeface="Calibri" pitchFamily="34" charset="0"/>
-                <a:ea typeface="Calibri" pitchFamily="34" charset="-122"/>
-                <a:cs typeface="Calibri" pitchFamily="34" charset="-120"/>
-              </a:rPr>
-              <a:t>코드프레소가 실제 발행한 글 46편에서 역산한 기준입니다. 문장 평균 46.9자, 어미 전환률 10.4%, 브랜드 언급 1.09회/1,000자 모두 그 46편의 실측값입니다.</a:t>
+                  <a:srgbClr val="9AA5B4"/>
+                </a:solidFill>
+                <a:latin typeface="Calibri" pitchFamily="34" charset="0"/>
+                <a:ea typeface="Calibri" pitchFamily="34" charset="-122"/>
+                <a:cs typeface="Calibri" pitchFamily="34" charset="-120"/>
+              </a:rPr>
+              <a:t>일반론과 목차</a:t>
+            </a:r>
+            <a:pPr indent="0" marL="0">
+              <a:buNone/>
+            </a:pPr>
+            <a:r>
+              <a:rPr lang="en-US" sz="1100" dirty="0">
+                <a:solidFill>
+                  <a:srgbClr val="C3CAD6"/>
+                </a:solidFill>
+                <a:latin typeface="Calibri" pitchFamily="34" charset="0"/>
+                <a:ea typeface="Calibri" pitchFamily="34" charset="-122"/>
+                <a:cs typeface="Calibri" pitchFamily="34" charset="-120"/>
+              </a:rPr>
+              <a:t>   →   </a:t>
+            </a:r>
+            <a:pPr indent="0" marL="0">
+              <a:buNone/>
+            </a:pPr>
+            <a:r>
+              <a:rPr lang="en-US" sz="1100" b="1" dirty="0">
+                <a:solidFill>
+                  <a:srgbClr val="1A61EA"/>
+                </a:solidFill>
+                <a:latin typeface="Calibri" pitchFamily="34" charset="0"/>
+                <a:ea typeface="Calibri" pitchFamily="34" charset="-122"/>
+                <a:cs typeface="Calibri" pitchFamily="34" charset="-120"/>
+              </a:rPr>
+              <a:t>고객사 사례</a:t>
             </a:r>
             <a:endParaRPr lang="en-US" sz="1100" dirty="0"/>
           </a:p>
-          <a:p>
-            <a:pPr indent="0" marL="0">
-              <a:lnSpc>
-                <a:spcPts val="1600"/>
-              </a:lnSpc>
-              <a:buNone/>
-            </a:pPr>
+        </p:txBody>
+      </p:sp>
+      <p:sp>
+        <p:nvSpPr>
+          <p:cNvPr id="14" name="Shape 12"/>
+          <p:cNvSpPr/>
+          <p:nvPr/>
+        </p:nvSpPr>
+        <p:spPr>
+          <a:xfrm>
+            <a:off x="3474720" y="5285232"/>
+            <a:ext cx="2514600" cy="841248"/>
+          </a:xfrm>
+          <a:prstGeom prst="roundRect">
+            <a:avLst>
+              <a:gd name="adj" fmla="val 8696"/>
+            </a:avLst>
+          </a:prstGeom>
+          <a:solidFill>
+            <a:srgbClr val="FFFFFF"/>
+          </a:solidFill>
+          <a:ln w="12700">
+            <a:solidFill>
+              <a:srgbClr val="E6E9EF"/>
+            </a:solidFill>
+            <a:prstDash val="solid"/>
+          </a:ln>
+        </p:spPr>
+      </p:sp>
+      <p:sp>
+        <p:nvSpPr>
+          <p:cNvPr id="15" name="Text 13"/>
+          <p:cNvSpPr txBox="1"/>
+          <p:nvPr/>
+        </p:nvSpPr>
+        <p:spPr>
+          <a:xfrm>
+            <a:off x="3675888" y="5394960"/>
+            <a:ext cx="2194560" cy="219456"/>
+          </a:xfrm>
+          <a:prstGeom prst="rect">
+            <a:avLst/>
+          </a:prstGeom>
+          <a:noFill/>
+          <a:ln/>
+        </p:spPr>
+        <p:txBody>
+          <a:bodyPr wrap="square" lIns="0" tIns="0" rIns="0" bIns="0" rtlCol="0" anchor="ctr"/>
+          <a:lstStyle/>
+          <a:p>
+            <a:pPr indent="0" marL="0">
+              <a:buNone/>
+            </a:pPr>
+            <a:r>
+              <a:rPr lang="en-US" sz="1050" dirty="0">
+                <a:solidFill>
+                  <a:srgbClr val="6E7A8A"/>
+                </a:solidFill>
+                <a:latin typeface="Calibri" pitchFamily="34" charset="0"/>
+                <a:ea typeface="Calibri" pitchFamily="34" charset="-122"/>
+                <a:cs typeface="Calibri" pitchFamily="34" charset="-120"/>
+              </a:rPr>
+              <a:t>수치</a:t>
+            </a:r>
+            <a:endParaRPr lang="en-US" sz="1050" dirty="0"/>
+          </a:p>
+        </p:txBody>
+      </p:sp>
+      <p:sp>
+        <p:nvSpPr>
+          <p:cNvPr id="16" name="Text 14"/>
+          <p:cNvSpPr txBox="1"/>
+          <p:nvPr/>
+        </p:nvSpPr>
+        <p:spPr>
+          <a:xfrm>
+            <a:off x="3675888" y="5650992"/>
+            <a:ext cx="2194560" cy="384048"/>
+          </a:xfrm>
+          <a:prstGeom prst="rect">
+            <a:avLst/>
+          </a:prstGeom>
+          <a:noFill/>
+          <a:ln/>
+        </p:spPr>
+        <p:txBody>
+          <a:bodyPr wrap="square" lIns="0" tIns="0" rIns="0" bIns="0" rtlCol="0" anchor="ctr"/>
+          <a:lstStyle/>
+          <a:p>
+            <a:pPr indent="0" marL="0">
+              <a:buNone/>
+            </a:pPr>
+            <a:r>
+              <a:rPr lang="en-US" sz="1100" dirty="0">
+                <a:solidFill>
+                  <a:srgbClr val="9AA5B4"/>
+                </a:solidFill>
+                <a:latin typeface="Calibri" pitchFamily="34" charset="0"/>
+                <a:ea typeface="Calibri" pitchFamily="34" charset="-122"/>
+                <a:cs typeface="Calibri" pitchFamily="34" charset="-120"/>
+              </a:rPr>
+              <a:t>없음</a:t>
+            </a:r>
+            <a:pPr indent="0" marL="0">
+              <a:buNone/>
+            </a:pPr>
+            <a:r>
+              <a:rPr lang="en-US" sz="1100" dirty="0">
+                <a:solidFill>
+                  <a:srgbClr val="C3CAD6"/>
+                </a:solidFill>
+                <a:latin typeface="Calibri" pitchFamily="34" charset="0"/>
+                <a:ea typeface="Calibri" pitchFamily="34" charset="-122"/>
+                <a:cs typeface="Calibri" pitchFamily="34" charset="-120"/>
+              </a:rPr>
+              <a:t>   →   </a:t>
+            </a:r>
+            <a:pPr indent="0" marL="0">
+              <a:buNone/>
+            </a:pPr>
+            <a:r>
+              <a:rPr lang="en-US" sz="1100" b="1" dirty="0">
+                <a:solidFill>
+                  <a:srgbClr val="1A61EA"/>
+                </a:solidFill>
+                <a:latin typeface="Calibri" pitchFamily="34" charset="0"/>
+                <a:ea typeface="Calibri" pitchFamily="34" charset="-122"/>
+                <a:cs typeface="Calibri" pitchFamily="34" charset="-120"/>
+              </a:rPr>
+              <a:t>검색 노출 221회 · 20.6위</a:t>
+            </a:r>
             <a:endParaRPr lang="en-US" sz="1100" dirty="0"/>
           </a:p>
-          <a:p>
-            <a:pPr indent="0" marL="0">
-              <a:lnSpc>
-                <a:spcPts val="1600"/>
-              </a:lnSpc>
+        </p:txBody>
+      </p:sp>
+      <p:sp>
+        <p:nvSpPr>
+          <p:cNvPr id="17" name="Shape 15"/>
+          <p:cNvSpPr/>
+          <p:nvPr/>
+        </p:nvSpPr>
+        <p:spPr>
+          <a:xfrm>
+            <a:off x="6172200" y="5285232"/>
+            <a:ext cx="2514600" cy="841248"/>
+          </a:xfrm>
+          <a:prstGeom prst="roundRect">
+            <a:avLst>
+              <a:gd name="adj" fmla="val 8696"/>
+            </a:avLst>
+          </a:prstGeom>
+          <a:solidFill>
+            <a:srgbClr val="FFFFFF"/>
+          </a:solidFill>
+          <a:ln w="12700">
+            <a:solidFill>
+              <a:srgbClr val="E6E9EF"/>
+            </a:solidFill>
+            <a:prstDash val="solid"/>
+          </a:ln>
+        </p:spPr>
+      </p:sp>
+      <p:sp>
+        <p:nvSpPr>
+          <p:cNvPr id="18" name="Text 16"/>
+          <p:cNvSpPr txBox="1"/>
+          <p:nvPr/>
+        </p:nvSpPr>
+        <p:spPr>
+          <a:xfrm>
+            <a:off x="6373368" y="5394960"/>
+            <a:ext cx="2194560" cy="219456"/>
+          </a:xfrm>
+          <a:prstGeom prst="rect">
+            <a:avLst/>
+          </a:prstGeom>
+          <a:noFill/>
+          <a:ln/>
+        </p:spPr>
+        <p:txBody>
+          <a:bodyPr wrap="square" lIns="0" tIns="0" rIns="0" bIns="0" rtlCol="0" anchor="ctr"/>
+          <a:lstStyle/>
+          <a:p>
+            <a:pPr indent="0" marL="0">
+              <a:buNone/>
+            </a:pPr>
+            <a:r>
+              <a:rPr lang="en-US" sz="1050" dirty="0">
+                <a:solidFill>
+                  <a:srgbClr val="6E7A8A"/>
+                </a:solidFill>
+                <a:latin typeface="Calibri" pitchFamily="34" charset="0"/>
+                <a:ea typeface="Calibri" pitchFamily="34" charset="-122"/>
+                <a:cs typeface="Calibri" pitchFamily="34" charset="-120"/>
+              </a:rPr>
+              <a:t>회사 이름</a:t>
+            </a:r>
+            <a:endParaRPr lang="en-US" sz="1050" dirty="0"/>
+          </a:p>
+        </p:txBody>
+      </p:sp>
+      <p:sp>
+        <p:nvSpPr>
+          <p:cNvPr id="19" name="Text 17"/>
+          <p:cNvSpPr txBox="1"/>
+          <p:nvPr/>
+        </p:nvSpPr>
+        <p:spPr>
+          <a:xfrm>
+            <a:off x="6373368" y="5650992"/>
+            <a:ext cx="2194560" cy="384048"/>
+          </a:xfrm>
+          <a:prstGeom prst="rect">
+            <a:avLst/>
+          </a:prstGeom>
+          <a:noFill/>
+          <a:ln/>
+        </p:spPr>
+        <p:txBody>
+          <a:bodyPr wrap="square" lIns="0" tIns="0" rIns="0" bIns="0" rtlCol="0" anchor="ctr"/>
+          <a:lstStyle/>
+          <a:p>
+            <a:pPr indent="0" marL="0">
               <a:buNone/>
             </a:pPr>
             <a:r>
               <a:rPr lang="en-US" sz="1100" dirty="0">
                 <a:solidFill>
-                  <a:srgbClr val="38445A"/>
-                </a:solidFill>
-                <a:latin typeface="Calibri" pitchFamily="34" charset="0"/>
-                <a:ea typeface="Calibri" pitchFamily="34" charset="-122"/>
-                <a:cs typeface="Calibri" pitchFamily="34" charset="-120"/>
-              </a:rPr>
-              <a:t>기준을 고칠 때마다 46편을 다시 채점해 중앙값 92점이 유지되어야 채택합니다. 네 차례 폐기·수정했고 기록이 남아 있습니다.</a:t>
+                  <a:srgbClr val="9AA5B4"/>
+                </a:solidFill>
+                <a:latin typeface="Calibri" pitchFamily="34" charset="0"/>
+                <a:ea typeface="Calibri" pitchFamily="34" charset="-122"/>
+                <a:cs typeface="Calibri" pitchFamily="34" charset="-120"/>
+              </a:rPr>
+              <a:t>0회</a:t>
+            </a:r>
+            <a:pPr indent="0" marL="0">
+              <a:buNone/>
+            </a:pPr>
+            <a:r>
+              <a:rPr lang="en-US" sz="1100" dirty="0">
+                <a:solidFill>
+                  <a:srgbClr val="C3CAD6"/>
+                </a:solidFill>
+                <a:latin typeface="Calibri" pitchFamily="34" charset="0"/>
+                <a:ea typeface="Calibri" pitchFamily="34" charset="-122"/>
+                <a:cs typeface="Calibri" pitchFamily="34" charset="-120"/>
+              </a:rPr>
+              <a:t>   →   </a:t>
+            </a:r>
+            <a:pPr indent="0" marL="0">
+              <a:buNone/>
+            </a:pPr>
+            <a:r>
+              <a:rPr lang="en-US" sz="1100" b="1" dirty="0">
+                <a:solidFill>
+                  <a:srgbClr val="1A61EA"/>
+                </a:solidFill>
+                <a:latin typeface="Calibri" pitchFamily="34" charset="0"/>
+                <a:ea typeface="Calibri" pitchFamily="34" charset="-122"/>
+                <a:cs typeface="Calibri" pitchFamily="34" charset="-120"/>
+              </a:rPr>
+              <a:t>3회 · SkillCertify 언급</a:t>
+            </a:r>
+            <a:endParaRPr lang="en-US" sz="1100" dirty="0"/>
+          </a:p>
+        </p:txBody>
+      </p:sp>
+      <p:sp>
+        <p:nvSpPr>
+          <p:cNvPr id="20" name="Shape 18"/>
+          <p:cNvSpPr/>
+          <p:nvPr/>
+        </p:nvSpPr>
+        <p:spPr>
+          <a:xfrm>
+            <a:off x="8869680" y="5285232"/>
+            <a:ext cx="2514600" cy="841248"/>
+          </a:xfrm>
+          <a:prstGeom prst="roundRect">
+            <a:avLst>
+              <a:gd name="adj" fmla="val 8696"/>
+            </a:avLst>
+          </a:prstGeom>
+          <a:solidFill>
+            <a:srgbClr val="FFFFFF"/>
+          </a:solidFill>
+          <a:ln w="12700">
+            <a:solidFill>
+              <a:srgbClr val="E6E9EF"/>
+            </a:solidFill>
+            <a:prstDash val="solid"/>
+          </a:ln>
+        </p:spPr>
+      </p:sp>
+      <p:sp>
+        <p:nvSpPr>
+          <p:cNvPr id="21" name="Text 19"/>
+          <p:cNvSpPr txBox="1"/>
+          <p:nvPr/>
+        </p:nvSpPr>
+        <p:spPr>
+          <a:xfrm>
+            <a:off x="9070848" y="5394960"/>
+            <a:ext cx="2194560" cy="219456"/>
+          </a:xfrm>
+          <a:prstGeom prst="rect">
+            <a:avLst/>
+          </a:prstGeom>
+          <a:noFill/>
+          <a:ln/>
+        </p:spPr>
+        <p:txBody>
+          <a:bodyPr wrap="square" lIns="0" tIns="0" rIns="0" bIns="0" rtlCol="0" anchor="ctr"/>
+          <a:lstStyle/>
+          <a:p>
+            <a:pPr indent="0" marL="0">
+              <a:buNone/>
+            </a:pPr>
+            <a:r>
+              <a:rPr lang="en-US" sz="1050" dirty="0">
+                <a:solidFill>
+                  <a:srgbClr val="6E7A8A"/>
+                </a:solidFill>
+                <a:latin typeface="Calibri" pitchFamily="34" charset="0"/>
+                <a:ea typeface="Calibri" pitchFamily="34" charset="-122"/>
+                <a:cs typeface="Calibri" pitchFamily="34" charset="-120"/>
+              </a:rPr>
+              <a:t>분량</a:t>
+            </a:r>
+            <a:endParaRPr lang="en-US" sz="1050" dirty="0"/>
+          </a:p>
+        </p:txBody>
+      </p:sp>
+      <p:sp>
+        <p:nvSpPr>
+          <p:cNvPr id="22" name="Text 20"/>
+          <p:cNvSpPr txBox="1"/>
+          <p:nvPr/>
+        </p:nvSpPr>
+        <p:spPr>
+          <a:xfrm>
+            <a:off x="9070848" y="5650992"/>
+            <a:ext cx="2194560" cy="384048"/>
+          </a:xfrm>
+          <a:prstGeom prst="rect">
+            <a:avLst/>
+          </a:prstGeom>
+          <a:noFill/>
+          <a:ln/>
+        </p:spPr>
+        <p:txBody>
+          <a:bodyPr wrap="square" lIns="0" tIns="0" rIns="0" bIns="0" rtlCol="0" anchor="ctr"/>
+          <a:lstStyle/>
+          <a:p>
+            <a:pPr indent="0" marL="0">
+              <a:buNone/>
+            </a:pPr>
+            <a:r>
+              <a:rPr lang="en-US" sz="1100" dirty="0">
+                <a:solidFill>
+                  <a:srgbClr val="9AA5B4"/>
+                </a:solidFill>
+                <a:latin typeface="Calibri" pitchFamily="34" charset="0"/>
+                <a:ea typeface="Calibri" pitchFamily="34" charset="-122"/>
+                <a:cs typeface="Calibri" pitchFamily="34" charset="-120"/>
+              </a:rPr>
+              <a:t>5,188자</a:t>
+            </a:r>
+            <a:pPr indent="0" marL="0">
+              <a:buNone/>
+            </a:pPr>
+            <a:r>
+              <a:rPr lang="en-US" sz="1100" dirty="0">
+                <a:solidFill>
+                  <a:srgbClr val="C3CAD6"/>
+                </a:solidFill>
+                <a:latin typeface="Calibri" pitchFamily="34" charset="0"/>
+                <a:ea typeface="Calibri" pitchFamily="34" charset="-122"/>
+                <a:cs typeface="Calibri" pitchFamily="34" charset="-120"/>
+              </a:rPr>
+              <a:t>   →   </a:t>
+            </a:r>
+            <a:pPr indent="0" marL="0">
+              <a:buNone/>
+            </a:pPr>
+            <a:r>
+              <a:rPr lang="en-US" sz="1100" b="1" dirty="0">
+                <a:solidFill>
+                  <a:srgbClr val="1A61EA"/>
+                </a:solidFill>
+                <a:latin typeface="Calibri" pitchFamily="34" charset="0"/>
+                <a:ea typeface="Calibri" pitchFamily="34" charset="-122"/>
+                <a:cs typeface="Calibri" pitchFamily="34" charset="-120"/>
+              </a:rPr>
+              <a:t>1,196자</a:t>
             </a:r>
             <a:endParaRPr lang="en-US" sz="1100" dirty="0"/>
           </a:p>
@@ -5809,7 +6042,7 @@
                 <a:ea typeface="Calibri" pitchFamily="34" charset="-122"/>
                 <a:cs typeface="Calibri" pitchFamily="34" charset="-120"/>
               </a:rPr>
-              <a:t>차이</a:t>
+              <a:t>검증</a:t>
             </a:r>
             <a:endParaRPr lang="en-US" sz="1100" dirty="0"/>
           </a:p>
@@ -5848,7 +6081,7 @@
                 <a:ea typeface="Calibri" pitchFamily="34" charset="-122"/>
                 <a:cs typeface="Calibri" pitchFamily="34" charset="-120"/>
               </a:rPr>
-              <a:t>범용 LLM은 사람이 기억해서 써야 하는 도구입니다</a:t>
+              <a:t>점수 채택 기준</a:t>
             </a:r>
             <a:endParaRPr lang="en-US" sz="3000" dirty="0"/>
           </a:p>
@@ -5862,24 +6095,24 @@
         </p:nvSpPr>
         <p:spPr>
           <a:xfrm>
-            <a:off x="2331720" y="2011680"/>
-            <a:ext cx="4114800" cy="256032"/>
-          </a:xfrm>
-          <a:prstGeom prst="rect">
-            <a:avLst/>
-          </a:prstGeom>
-          <a:noFill/>
-          <a:ln/>
-        </p:spPr>
-        <p:txBody>
-          <a:bodyPr wrap="square" lIns="0" tIns="0" rIns="0" bIns="0" rtlCol="0" anchor="ctr"/>
-          <a:lstStyle/>
-          <a:p>
-            <a:pPr indent="0" marL="0">
-              <a:buNone/>
-            </a:pPr>
-            <a:r>
-              <a:rPr lang="en-US" sz="1200" b="1" dirty="0">
+            <a:off x="777240" y="1243584"/>
+            <a:ext cx="10241280" cy="365760"/>
+          </a:xfrm>
+          <a:prstGeom prst="rect">
+            <a:avLst/>
+          </a:prstGeom>
+          <a:noFill/>
+          <a:ln/>
+        </p:spPr>
+        <p:txBody>
+          <a:bodyPr wrap="square" lIns="0" tIns="0" rIns="0" bIns="0" rtlCol="0" anchor="ctr"/>
+          <a:lstStyle/>
+          <a:p>
+            <a:pPr indent="0" marL="0">
+              <a:buNone/>
+            </a:pPr>
+            <a:r>
+              <a:rPr lang="en-US" sz="1400" dirty="0">
                 <a:solidFill>
                   <a:srgbClr val="6E7A8A"/>
                 </a:solidFill>
@@ -5887,9 +6120,9 @@
                 <a:ea typeface="Calibri" pitchFamily="34" charset="-122"/>
                 <a:cs typeface="Calibri" pitchFamily="34" charset="-120"/>
               </a:rPr>
-              <a:t>범용 LLM</a:t>
-            </a:r>
-            <a:endParaRPr lang="en-US" sz="1200" dirty="0"/>
+              <a:t>이 점수는 저희가 정한 이상적인 글이 아니라, 코드프레소가 실제 발행한 글 46편에서 역산한 기준입니다</a:t>
+            </a:r>
+            <a:endParaRPr lang="en-US" sz="1400" dirty="0"/>
           </a:p>
         </p:txBody>
       </p:sp>
@@ -5901,63 +6134,24 @@
         </p:nvSpPr>
         <p:spPr>
           <a:xfrm>
-            <a:off x="7040880" y="2011680"/>
-            <a:ext cx="4114800" cy="256032"/>
-          </a:xfrm>
-          <a:prstGeom prst="rect">
-            <a:avLst/>
-          </a:prstGeom>
-          <a:noFill/>
-          <a:ln/>
-        </p:spPr>
-        <p:txBody>
-          <a:bodyPr wrap="square" lIns="0" tIns="0" rIns="0" bIns="0" rtlCol="0" anchor="ctr"/>
-          <a:lstStyle/>
-          <a:p>
-            <a:pPr indent="0" marL="0">
-              <a:buNone/>
-            </a:pPr>
-            <a:r>
-              <a:rPr lang="en-US" sz="1200" b="1" dirty="0">
-                <a:solidFill>
-                  <a:srgbClr val="1A61EA"/>
-                </a:solidFill>
-                <a:latin typeface="Calibri" pitchFamily="34" charset="0"/>
-                <a:ea typeface="Calibri" pitchFamily="34" charset="-122"/>
-                <a:cs typeface="Calibri" pitchFamily="34" charset="-120"/>
-              </a:rPr>
-              <a:t>Marketing Pulse</a:t>
-            </a:r>
-            <a:endParaRPr lang="en-US" sz="1200" dirty="0"/>
-          </a:p>
-        </p:txBody>
-      </p:sp>
-      <p:sp>
-        <p:nvSpPr>
-          <p:cNvPr id="6" name="Text 4"/>
-          <p:cNvSpPr txBox="1"/>
-          <p:nvPr/>
-        </p:nvSpPr>
-        <p:spPr>
-          <a:xfrm>
-            <a:off x="777240" y="2633472"/>
-            <a:ext cx="1371600" cy="274320"/>
-          </a:xfrm>
-          <a:prstGeom prst="rect">
-            <a:avLst/>
-          </a:prstGeom>
-          <a:noFill/>
-          <a:ln/>
-        </p:spPr>
-        <p:txBody>
-          <a:bodyPr wrap="square" lIns="0" tIns="0" rIns="0" bIns="0" rtlCol="0" anchor="ctr"/>
-          <a:lstStyle/>
-          <a:p>
-            <a:pPr indent="0" marL="0">
-              <a:buNone/>
-            </a:pPr>
-            <a:r>
-              <a:rPr lang="en-US" sz="1500" b="1" dirty="0">
+            <a:off x="777240" y="1965960"/>
+            <a:ext cx="5486400" cy="274320"/>
+          </a:xfrm>
+          <a:prstGeom prst="rect">
+            <a:avLst/>
+          </a:prstGeom>
+          <a:noFill/>
+          <a:ln/>
+        </p:spPr>
+        <p:txBody>
+          <a:bodyPr wrap="square" lIns="0" tIns="0" rIns="0" bIns="0" rtlCol="0" anchor="ctr"/>
+          <a:lstStyle/>
+          <a:p>
+            <a:pPr indent="0" marL="0">
+              <a:buNone/>
+            </a:pPr>
+            <a:r>
+              <a:rPr lang="en-US" sz="1400" b="1" dirty="0">
                 <a:solidFill>
                   <a:srgbClr val="0B1220"/>
                 </a:solidFill>
@@ -5965,26 +6159,26 @@
                 <a:ea typeface="Calibri" pitchFamily="34" charset="-122"/>
                 <a:cs typeface="Calibri" pitchFamily="34" charset="-120"/>
               </a:rPr>
-              <a:t>근거</a:t>
-            </a:r>
-            <a:endParaRPr lang="en-US" sz="1500" dirty="0"/>
-          </a:p>
-        </p:txBody>
-      </p:sp>
-      <p:sp>
-        <p:nvSpPr>
-          <p:cNvPr id="7" name="Shape 5"/>
+              <a:t>기준값은 전부 그 46편의 실측값입니다</a:t>
+            </a:r>
+            <a:endParaRPr lang="en-US" sz="1400" dirty="0"/>
+          </a:p>
+        </p:txBody>
+      </p:sp>
+      <p:sp>
+        <p:nvSpPr>
+          <p:cNvPr id="6" name="Shape 4"/>
           <p:cNvSpPr/>
           <p:nvPr/>
         </p:nvSpPr>
         <p:spPr>
           <a:xfrm>
-            <a:off x="2240280" y="2377440"/>
-            <a:ext cx="4480560" cy="859536"/>
+            <a:off x="777240" y="2359152"/>
+            <a:ext cx="5120640" cy="548640"/>
           </a:xfrm>
           <a:prstGeom prst="roundRect">
             <a:avLst>
-              <a:gd name="adj" fmla="val 8511"/>
+              <a:gd name="adj" fmla="val 13333"/>
             </a:avLst>
           </a:prstGeom>
           <a:solidFill>
@@ -6000,40 +6194,79 @@
       </p:sp>
       <p:sp>
         <p:nvSpPr>
+          <p:cNvPr id="7" name="Text 5"/>
+          <p:cNvSpPr txBox="1"/>
+          <p:nvPr/>
+        </p:nvSpPr>
+        <p:spPr>
+          <a:xfrm>
+            <a:off x="1033272" y="2505456"/>
+            <a:ext cx="3108960" cy="256032"/>
+          </a:xfrm>
+          <a:prstGeom prst="rect">
+            <a:avLst/>
+          </a:prstGeom>
+          <a:noFill/>
+          <a:ln/>
+        </p:spPr>
+        <p:txBody>
+          <a:bodyPr wrap="square" lIns="0" tIns="0" rIns="0" bIns="0" rtlCol="0" anchor="ctr"/>
+          <a:lstStyle/>
+          <a:p>
+            <a:pPr indent="0" marL="0">
+              <a:buNone/>
+            </a:pPr>
+            <a:r>
+              <a:rPr lang="en-US" sz="1250" dirty="0">
+                <a:solidFill>
+                  <a:srgbClr val="6E7A8A"/>
+                </a:solidFill>
+                <a:latin typeface="Calibri" pitchFamily="34" charset="0"/>
+                <a:ea typeface="Calibri" pitchFamily="34" charset="-122"/>
+                <a:cs typeface="Calibri" pitchFamily="34" charset="-120"/>
+              </a:rPr>
+              <a:t>문장 평균 길이</a:t>
+            </a:r>
+            <a:endParaRPr lang="en-US" sz="1250" dirty="0"/>
+          </a:p>
+        </p:txBody>
+      </p:sp>
+      <p:sp>
+        <p:nvSpPr>
           <p:cNvPr id="8" name="Text 6"/>
           <p:cNvSpPr txBox="1"/>
           <p:nvPr/>
         </p:nvSpPr>
         <p:spPr>
           <a:xfrm>
-            <a:off x="2514600" y="2560320"/>
-            <a:ext cx="4023360" cy="548640"/>
-          </a:xfrm>
-          <a:prstGeom prst="rect">
-            <a:avLst/>
-          </a:prstGeom>
-          <a:noFill/>
-          <a:ln/>
-        </p:spPr>
-        <p:txBody>
-          <a:bodyPr wrap="square" lIns="0" tIns="0" rIns="0" bIns="0" rtlCol="0" anchor="ctr"/>
-          <a:lstStyle/>
-          <a:p>
-            <a:pPr indent="0" marL="0">
-              <a:buNone/>
-            </a:pPr>
-            <a:r>
-              <a:rPr lang="en-US" sz="1250" dirty="0">
-                <a:solidFill>
-                  <a:srgbClr val="6E7A8A"/>
-                </a:solidFill>
-                <a:latin typeface="Calibri" pitchFamily="34" charset="0"/>
-                <a:ea typeface="Calibri" pitchFamily="34" charset="-122"/>
-                <a:cs typeface="Calibri" pitchFamily="34" charset="-120"/>
-              </a:rPr>
-              <a:t>회사의 실적과 사례를 모르니 일반론으로 채웁니다</a:t>
-            </a:r>
-            <a:endParaRPr lang="en-US" sz="1250" dirty="0"/>
+            <a:off x="4069080" y="2487168"/>
+            <a:ext cx="1645920" cy="274320"/>
+          </a:xfrm>
+          <a:prstGeom prst="rect">
+            <a:avLst/>
+          </a:prstGeom>
+          <a:noFill/>
+          <a:ln/>
+        </p:spPr>
+        <p:txBody>
+          <a:bodyPr wrap="square" lIns="0" tIns="0" rIns="0" bIns="0" rtlCol="0" anchor="ctr"/>
+          <a:lstStyle/>
+          <a:p>
+            <a:pPr algn="r" indent="0" marL="0">
+              <a:buNone/>
+            </a:pPr>
+            <a:r>
+              <a:rPr lang="en-US" sz="1350" b="1" dirty="0">
+                <a:solidFill>
+                  <a:srgbClr val="0B1220"/>
+                </a:solidFill>
+                <a:latin typeface="Calibri" pitchFamily="34" charset="0"/>
+                <a:ea typeface="Calibri" pitchFamily="34" charset="-122"/>
+                <a:cs typeface="Calibri" pitchFamily="34" charset="-120"/>
+              </a:rPr>
+              <a:t>46.9자</a:t>
+            </a:r>
+            <a:endParaRPr lang="en-US" sz="1350" dirty="0"/>
           </a:p>
         </p:txBody>
       </p:sp>
@@ -6045,12 +6278,327 @@
         </p:nvSpPr>
         <p:spPr>
           <a:xfrm>
-            <a:off x="6949440" y="2377440"/>
-            <a:ext cx="4480560" cy="859536"/>
+            <a:off x="777240" y="3017520"/>
+            <a:ext cx="5120640" cy="548640"/>
           </a:xfrm>
           <a:prstGeom prst="roundRect">
             <a:avLst>
-              <a:gd name="adj" fmla="val 8511"/>
+              <a:gd name="adj" fmla="val 13333"/>
+            </a:avLst>
+          </a:prstGeom>
+          <a:solidFill>
+            <a:srgbClr val="FFFFFF"/>
+          </a:solidFill>
+          <a:ln w="12700">
+            <a:solidFill>
+              <a:srgbClr val="E6E9EF"/>
+            </a:solidFill>
+            <a:prstDash val="solid"/>
+          </a:ln>
+        </p:spPr>
+      </p:sp>
+      <p:sp>
+        <p:nvSpPr>
+          <p:cNvPr id="10" name="Text 8"/>
+          <p:cNvSpPr txBox="1"/>
+          <p:nvPr/>
+        </p:nvSpPr>
+        <p:spPr>
+          <a:xfrm>
+            <a:off x="1033272" y="3163824"/>
+            <a:ext cx="3108960" cy="256032"/>
+          </a:xfrm>
+          <a:prstGeom prst="rect">
+            <a:avLst/>
+          </a:prstGeom>
+          <a:noFill/>
+          <a:ln/>
+        </p:spPr>
+        <p:txBody>
+          <a:bodyPr wrap="square" lIns="0" tIns="0" rIns="0" bIns="0" rtlCol="0" anchor="ctr"/>
+          <a:lstStyle/>
+          <a:p>
+            <a:pPr indent="0" marL="0">
+              <a:buNone/>
+            </a:pPr>
+            <a:r>
+              <a:rPr lang="en-US" sz="1250" dirty="0">
+                <a:solidFill>
+                  <a:srgbClr val="6E7A8A"/>
+                </a:solidFill>
+                <a:latin typeface="Calibri" pitchFamily="34" charset="0"/>
+                <a:ea typeface="Calibri" pitchFamily="34" charset="-122"/>
+                <a:cs typeface="Calibri" pitchFamily="34" charset="-120"/>
+              </a:rPr>
+              <a:t>어미 전환률 중앙값</a:t>
+            </a:r>
+            <a:endParaRPr lang="en-US" sz="1250" dirty="0"/>
+          </a:p>
+        </p:txBody>
+      </p:sp>
+      <p:sp>
+        <p:nvSpPr>
+          <p:cNvPr id="11" name="Text 9"/>
+          <p:cNvSpPr txBox="1"/>
+          <p:nvPr/>
+        </p:nvSpPr>
+        <p:spPr>
+          <a:xfrm>
+            <a:off x="4069080" y="3145536"/>
+            <a:ext cx="1645920" cy="274320"/>
+          </a:xfrm>
+          <a:prstGeom prst="rect">
+            <a:avLst/>
+          </a:prstGeom>
+          <a:noFill/>
+          <a:ln/>
+        </p:spPr>
+        <p:txBody>
+          <a:bodyPr wrap="square" lIns="0" tIns="0" rIns="0" bIns="0" rtlCol="0" anchor="ctr"/>
+          <a:lstStyle/>
+          <a:p>
+            <a:pPr algn="r" indent="0" marL="0">
+              <a:buNone/>
+            </a:pPr>
+            <a:r>
+              <a:rPr lang="en-US" sz="1350" b="1" dirty="0">
+                <a:solidFill>
+                  <a:srgbClr val="0B1220"/>
+                </a:solidFill>
+                <a:latin typeface="Calibri" pitchFamily="34" charset="0"/>
+                <a:ea typeface="Calibri" pitchFamily="34" charset="-122"/>
+                <a:cs typeface="Calibri" pitchFamily="34" charset="-120"/>
+              </a:rPr>
+              <a:t>10.4%</a:t>
+            </a:r>
+            <a:endParaRPr lang="en-US" sz="1350" dirty="0"/>
+          </a:p>
+        </p:txBody>
+      </p:sp>
+      <p:sp>
+        <p:nvSpPr>
+          <p:cNvPr id="12" name="Shape 10"/>
+          <p:cNvSpPr/>
+          <p:nvPr/>
+        </p:nvSpPr>
+        <p:spPr>
+          <a:xfrm>
+            <a:off x="777240" y="3675888"/>
+            <a:ext cx="5120640" cy="548640"/>
+          </a:xfrm>
+          <a:prstGeom prst="roundRect">
+            <a:avLst>
+              <a:gd name="adj" fmla="val 13333"/>
+            </a:avLst>
+          </a:prstGeom>
+          <a:solidFill>
+            <a:srgbClr val="FFFFFF"/>
+          </a:solidFill>
+          <a:ln w="12700">
+            <a:solidFill>
+              <a:srgbClr val="E6E9EF"/>
+            </a:solidFill>
+            <a:prstDash val="solid"/>
+          </a:ln>
+        </p:spPr>
+      </p:sp>
+      <p:sp>
+        <p:nvSpPr>
+          <p:cNvPr id="13" name="Text 11"/>
+          <p:cNvSpPr txBox="1"/>
+          <p:nvPr/>
+        </p:nvSpPr>
+        <p:spPr>
+          <a:xfrm>
+            <a:off x="1033272" y="3822192"/>
+            <a:ext cx="3108960" cy="256032"/>
+          </a:xfrm>
+          <a:prstGeom prst="rect">
+            <a:avLst/>
+          </a:prstGeom>
+          <a:noFill/>
+          <a:ln/>
+        </p:spPr>
+        <p:txBody>
+          <a:bodyPr wrap="square" lIns="0" tIns="0" rIns="0" bIns="0" rtlCol="0" anchor="ctr"/>
+          <a:lstStyle/>
+          <a:p>
+            <a:pPr indent="0" marL="0">
+              <a:buNone/>
+            </a:pPr>
+            <a:r>
+              <a:rPr lang="en-US" sz="1250" dirty="0">
+                <a:solidFill>
+                  <a:srgbClr val="6E7A8A"/>
+                </a:solidFill>
+                <a:latin typeface="Calibri" pitchFamily="34" charset="0"/>
+                <a:ea typeface="Calibri" pitchFamily="34" charset="-122"/>
+                <a:cs typeface="Calibri" pitchFamily="34" charset="-120"/>
+              </a:rPr>
+              <a:t>브랜드 언급</a:t>
+            </a:r>
+            <a:endParaRPr lang="en-US" sz="1250" dirty="0"/>
+          </a:p>
+        </p:txBody>
+      </p:sp>
+      <p:sp>
+        <p:nvSpPr>
+          <p:cNvPr id="14" name="Text 12"/>
+          <p:cNvSpPr txBox="1"/>
+          <p:nvPr/>
+        </p:nvSpPr>
+        <p:spPr>
+          <a:xfrm>
+            <a:off x="4069080" y="3803904"/>
+            <a:ext cx="1645920" cy="274320"/>
+          </a:xfrm>
+          <a:prstGeom prst="rect">
+            <a:avLst/>
+          </a:prstGeom>
+          <a:noFill/>
+          <a:ln/>
+        </p:spPr>
+        <p:txBody>
+          <a:bodyPr wrap="square" lIns="0" tIns="0" rIns="0" bIns="0" rtlCol="0" anchor="ctr"/>
+          <a:lstStyle/>
+          <a:p>
+            <a:pPr algn="r" indent="0" marL="0">
+              <a:buNone/>
+            </a:pPr>
+            <a:r>
+              <a:rPr lang="en-US" sz="1350" b="1" dirty="0">
+                <a:solidFill>
+                  <a:srgbClr val="0B1220"/>
+                </a:solidFill>
+                <a:latin typeface="Calibri" pitchFamily="34" charset="0"/>
+                <a:ea typeface="Calibri" pitchFamily="34" charset="-122"/>
+                <a:cs typeface="Calibri" pitchFamily="34" charset="-120"/>
+              </a:rPr>
+              <a:t>1.09회 / 1,000자</a:t>
+            </a:r>
+            <a:endParaRPr lang="en-US" sz="1350" dirty="0"/>
+          </a:p>
+        </p:txBody>
+      </p:sp>
+      <p:sp>
+        <p:nvSpPr>
+          <p:cNvPr id="15" name="Shape 13"/>
+          <p:cNvSpPr/>
+          <p:nvPr/>
+        </p:nvSpPr>
+        <p:spPr>
+          <a:xfrm>
+            <a:off x="777240" y="4334256"/>
+            <a:ext cx="5120640" cy="548640"/>
+          </a:xfrm>
+          <a:prstGeom prst="roundRect">
+            <a:avLst>
+              <a:gd name="adj" fmla="val 13333"/>
+            </a:avLst>
+          </a:prstGeom>
+          <a:solidFill>
+            <a:srgbClr val="FFFFFF"/>
+          </a:solidFill>
+          <a:ln w="12700">
+            <a:solidFill>
+              <a:srgbClr val="E6E9EF"/>
+            </a:solidFill>
+            <a:prstDash val="solid"/>
+          </a:ln>
+        </p:spPr>
+      </p:sp>
+      <p:sp>
+        <p:nvSpPr>
+          <p:cNvPr id="16" name="Text 14"/>
+          <p:cNvSpPr txBox="1"/>
+          <p:nvPr/>
+        </p:nvSpPr>
+        <p:spPr>
+          <a:xfrm>
+            <a:off x="1033272" y="4480560"/>
+            <a:ext cx="3108960" cy="256032"/>
+          </a:xfrm>
+          <a:prstGeom prst="rect">
+            <a:avLst/>
+          </a:prstGeom>
+          <a:noFill/>
+          <a:ln/>
+        </p:spPr>
+        <p:txBody>
+          <a:bodyPr wrap="square" lIns="0" tIns="0" rIns="0" bIns="0" rtlCol="0" anchor="ctr"/>
+          <a:lstStyle/>
+          <a:p>
+            <a:pPr indent="0" marL="0">
+              <a:buNone/>
+            </a:pPr>
+            <a:r>
+              <a:rPr lang="en-US" sz="1250" dirty="0">
+                <a:solidFill>
+                  <a:srgbClr val="6E7A8A"/>
+                </a:solidFill>
+                <a:latin typeface="Calibri" pitchFamily="34" charset="0"/>
+                <a:ea typeface="Calibri" pitchFamily="34" charset="-122"/>
+                <a:cs typeface="Calibri" pitchFamily="34" charset="-120"/>
+              </a:rPr>
+              <a:t>수치 인용</a:t>
+            </a:r>
+            <a:endParaRPr lang="en-US" sz="1250" dirty="0"/>
+          </a:p>
+        </p:txBody>
+      </p:sp>
+      <p:sp>
+        <p:nvSpPr>
+          <p:cNvPr id="17" name="Text 15"/>
+          <p:cNvSpPr txBox="1"/>
+          <p:nvPr/>
+        </p:nvSpPr>
+        <p:spPr>
+          <a:xfrm>
+            <a:off x="4069080" y="4462272"/>
+            <a:ext cx="1645920" cy="274320"/>
+          </a:xfrm>
+          <a:prstGeom prst="rect">
+            <a:avLst/>
+          </a:prstGeom>
+          <a:noFill/>
+          <a:ln/>
+        </p:spPr>
+        <p:txBody>
+          <a:bodyPr wrap="square" lIns="0" tIns="0" rIns="0" bIns="0" rtlCol="0" anchor="ctr"/>
+          <a:lstStyle/>
+          <a:p>
+            <a:pPr algn="r" indent="0" marL="0">
+              <a:buNone/>
+            </a:pPr>
+            <a:r>
+              <a:rPr lang="en-US" sz="1350" b="1" dirty="0">
+                <a:solidFill>
+                  <a:srgbClr val="0B1220"/>
+                </a:solidFill>
+                <a:latin typeface="Calibri" pitchFamily="34" charset="0"/>
+                <a:ea typeface="Calibri" pitchFamily="34" charset="-122"/>
+                <a:cs typeface="Calibri" pitchFamily="34" charset="-120"/>
+              </a:rPr>
+              <a:t>1.26회 / 1,000자</a:t>
+            </a:r>
+            <a:endParaRPr lang="en-US" sz="1350" dirty="0"/>
+          </a:p>
+        </p:txBody>
+      </p:sp>
+      <p:sp>
+        <p:nvSpPr>
+          <p:cNvPr id="18" name="Shape 16"/>
+          <p:cNvSpPr/>
+          <p:nvPr/>
+        </p:nvSpPr>
+        <p:spPr>
+          <a:xfrm>
+            <a:off x="6217920" y="2359152"/>
+            <a:ext cx="5120640" cy="1847088"/>
+          </a:xfrm>
+          <a:prstGeom prst="roundRect">
+            <a:avLst>
+              <a:gd name="adj" fmla="val 3960"/>
             </a:avLst>
           </a:prstGeom>
           <a:solidFill>
@@ -6066,96 +6614,128 @@
       </p:sp>
       <p:sp>
         <p:nvSpPr>
-          <p:cNvPr id="10" name="Text 8"/>
-          <p:cNvSpPr txBox="1"/>
-          <p:nvPr/>
-        </p:nvSpPr>
-        <p:spPr>
-          <a:xfrm>
-            <a:off x="7223760" y="2560320"/>
-            <a:ext cx="4023360" cy="548640"/>
-          </a:xfrm>
-          <a:prstGeom prst="rect">
-            <a:avLst/>
-          </a:prstGeom>
-          <a:noFill/>
-          <a:ln/>
-        </p:spPr>
-        <p:txBody>
-          <a:bodyPr wrap="square" lIns="0" tIns="0" rIns="0" bIns="0" rtlCol="0" anchor="ctr"/>
-          <a:lstStyle/>
-          <a:p>
-            <a:pPr indent="0" marL="0">
-              <a:buNone/>
-            </a:pPr>
-            <a:r>
-              <a:rPr lang="en-US" sz="1250" dirty="0">
-                <a:solidFill>
-                  <a:srgbClr val="0B1220"/>
-                </a:solidFill>
-                <a:latin typeface="Calibri" pitchFamily="34" charset="0"/>
-                <a:ea typeface="Calibri" pitchFamily="34" charset="-122"/>
-                <a:cs typeface="Calibri" pitchFamily="34" charset="-120"/>
-              </a:rPr>
-              <a:t>자사 성과 데이터에서 인용합니다</a:t>
-            </a:r>
-            <a:endParaRPr lang="en-US" sz="1250" dirty="0"/>
-          </a:p>
-        </p:txBody>
-      </p:sp>
-      <p:sp>
-        <p:nvSpPr>
-          <p:cNvPr id="11" name="Text 9"/>
-          <p:cNvSpPr txBox="1"/>
-          <p:nvPr/>
-        </p:nvSpPr>
-        <p:spPr>
-          <a:xfrm>
-            <a:off x="777240" y="3657600"/>
-            <a:ext cx="1371600" cy="274320"/>
-          </a:xfrm>
-          <a:prstGeom prst="rect">
-            <a:avLst/>
-          </a:prstGeom>
-          <a:noFill/>
-          <a:ln/>
-        </p:spPr>
-        <p:txBody>
-          <a:bodyPr wrap="square" lIns="0" tIns="0" rIns="0" bIns="0" rtlCol="0" anchor="ctr"/>
-          <a:lstStyle/>
-          <a:p>
-            <a:pPr indent="0" marL="0">
-              <a:buNone/>
-            </a:pPr>
-            <a:r>
-              <a:rPr lang="en-US" sz="1500" b="1" dirty="0">
-                <a:solidFill>
-                  <a:srgbClr val="0B1220"/>
-                </a:solidFill>
-                <a:latin typeface="Calibri" pitchFamily="34" charset="0"/>
-                <a:ea typeface="Calibri" pitchFamily="34" charset="-122"/>
-                <a:cs typeface="Calibri" pitchFamily="34" charset="-120"/>
-              </a:rPr>
-              <a:t>기억</a:t>
-            </a:r>
-            <a:endParaRPr lang="en-US" sz="1500" dirty="0"/>
-          </a:p>
-        </p:txBody>
-      </p:sp>
-      <p:sp>
-        <p:nvSpPr>
-          <p:cNvPr id="12" name="Shape 10"/>
+          <p:cNvPr id="19" name="Text 17"/>
+          <p:cNvSpPr txBox="1"/>
+          <p:nvPr/>
+        </p:nvSpPr>
+        <p:spPr>
+          <a:xfrm>
+            <a:off x="6492240" y="2560320"/>
+            <a:ext cx="4572000" cy="274320"/>
+          </a:xfrm>
+          <a:prstGeom prst="rect">
+            <a:avLst/>
+          </a:prstGeom>
+          <a:noFill/>
+          <a:ln/>
+        </p:spPr>
+        <p:txBody>
+          <a:bodyPr wrap="square" lIns="0" tIns="0" rIns="0" bIns="0" rtlCol="0" anchor="ctr"/>
+          <a:lstStyle/>
+          <a:p>
+            <a:pPr indent="0" marL="0">
+              <a:buNone/>
+            </a:pPr>
+            <a:r>
+              <a:rPr lang="en-US" sz="1400" b="1" dirty="0">
+                <a:solidFill>
+                  <a:srgbClr val="1A61EA"/>
+                </a:solidFill>
+                <a:latin typeface="Calibri" pitchFamily="34" charset="0"/>
+                <a:ea typeface="Calibri" pitchFamily="34" charset="-122"/>
+                <a:cs typeface="Calibri" pitchFamily="34" charset="-120"/>
+              </a:rPr>
+              <a:t>기준을 고칠 때마다 통과해야 하는 관문</a:t>
+            </a:r>
+            <a:endParaRPr lang="en-US" sz="1400" dirty="0"/>
+          </a:p>
+        </p:txBody>
+      </p:sp>
+      <p:sp>
+        <p:nvSpPr>
+          <p:cNvPr id="20" name="Text 18"/>
+          <p:cNvSpPr txBox="1"/>
+          <p:nvPr/>
+        </p:nvSpPr>
+        <p:spPr>
+          <a:xfrm>
+            <a:off x="6492240" y="2926080"/>
+            <a:ext cx="4572000" cy="1188720"/>
+          </a:xfrm>
+          <a:prstGeom prst="rect">
+            <a:avLst/>
+          </a:prstGeom>
+          <a:noFill/>
+          <a:ln/>
+        </p:spPr>
+        <p:txBody>
+          <a:bodyPr wrap="square" lIns="0" tIns="0" rIns="0" bIns="0" rtlCol="0" anchor="ctr"/>
+          <a:lstStyle/>
+          <a:p>
+            <a:pPr indent="0" marL="0">
+              <a:lnSpc>
+                <a:spcPts val="1700"/>
+              </a:lnSpc>
+              <a:buNone/>
+            </a:pPr>
+            <a:r>
+              <a:rPr lang="en-US" sz="1200" dirty="0">
+                <a:solidFill>
+                  <a:srgbClr val="38445A"/>
+                </a:solidFill>
+                <a:latin typeface="Calibri" pitchFamily="34" charset="0"/>
+                <a:ea typeface="Calibri" pitchFamily="34" charset="-122"/>
+                <a:cs typeface="Calibri" pitchFamily="34" charset="-120"/>
+              </a:rPr>
+              <a:t>수정한 채점 기준으로 그 46편을 다시 채점해 중앙값 92점이 유지되어야 채택하고, 그러지 못하면 폐기합니다.</a:t>
+            </a:r>
+            <a:endParaRPr lang="en-US" sz="1200" dirty="0"/>
+          </a:p>
+          <a:p>
+            <a:pPr indent="0" marL="0">
+              <a:lnSpc>
+                <a:spcPts val="1700"/>
+              </a:lnSpc>
+              <a:buNone/>
+            </a:pPr>
+            <a:endParaRPr lang="en-US" sz="1200" dirty="0"/>
+          </a:p>
+          <a:p>
+            <a:pPr indent="0" marL="0">
+              <a:lnSpc>
+                <a:spcPts val="1700"/>
+              </a:lnSpc>
+              <a:buNone/>
+            </a:pPr>
+            <a:r>
+              <a:rPr lang="en-US" sz="1200" dirty="0">
+                <a:solidFill>
+                  <a:srgbClr val="38445A"/>
+                </a:solidFill>
+                <a:latin typeface="Calibri" pitchFamily="34" charset="0"/>
+                <a:ea typeface="Calibri" pitchFamily="34" charset="-122"/>
+                <a:cs typeface="Calibri" pitchFamily="34" charset="-120"/>
+              </a:rPr>
+              <a:t>실제로 네 차례 폐기하거나 고쳤습니다. 저희 결과에 유리하도록 맞춘 지표가 아니라, 고객사의 글로 검증한 지표라는 뜻입니다.</a:t>
+            </a:r>
+            <a:endParaRPr lang="en-US" sz="1200" dirty="0"/>
+          </a:p>
+        </p:txBody>
+      </p:sp>
+      <p:sp>
+        <p:nvSpPr>
+          <p:cNvPr id="21" name="Shape 19"/>
           <p:cNvSpPr/>
           <p:nvPr/>
         </p:nvSpPr>
         <p:spPr>
           <a:xfrm>
-            <a:off x="2240280" y="3401568"/>
-            <a:ext cx="4480560" cy="859536"/>
+            <a:off x="6217920" y="4370832"/>
+            <a:ext cx="5120640" cy="1463040"/>
           </a:xfrm>
           <a:prstGeom prst="roundRect">
             <a:avLst>
-              <a:gd name="adj" fmla="val 8511"/>
+              <a:gd name="adj" fmla="val 5000"/>
             </a:avLst>
           </a:prstGeom>
           <a:solidFill>
@@ -6171,30 +6751,72 @@
       </p:sp>
       <p:sp>
         <p:nvSpPr>
-          <p:cNvPr id="13" name="Text 11"/>
-          <p:cNvSpPr txBox="1"/>
-          <p:nvPr/>
-        </p:nvSpPr>
-        <p:spPr>
-          <a:xfrm>
-            <a:off x="2514600" y="3584448"/>
-            <a:ext cx="4023360" cy="548640"/>
-          </a:xfrm>
-          <a:prstGeom prst="rect">
-            <a:avLst/>
-          </a:prstGeom>
-          <a:noFill/>
-          <a:ln/>
-        </p:spPr>
-        <p:txBody>
-          <a:bodyPr wrap="square" lIns="0" tIns="0" rIns="0" bIns="0" rtlCol="0" anchor="ctr"/>
-          <a:lstStyle/>
-          <a:p>
-            <a:pPr indent="0" marL="0">
-              <a:buNone/>
-            </a:pPr>
-            <a:r>
-              <a:rPr lang="en-US" sz="1250" dirty="0">
+          <p:cNvPr id="22" name="Text 20"/>
+          <p:cNvSpPr txBox="1"/>
+          <p:nvPr/>
+        </p:nvSpPr>
+        <p:spPr>
+          <a:xfrm>
+            <a:off x="6492240" y="4535424"/>
+            <a:ext cx="4572000" cy="256032"/>
+          </a:xfrm>
+          <a:prstGeom prst="rect">
+            <a:avLst/>
+          </a:prstGeom>
+          <a:noFill/>
+          <a:ln/>
+        </p:spPr>
+        <p:txBody>
+          <a:bodyPr wrap="square" lIns="0" tIns="0" rIns="0" bIns="0" rtlCol="0" anchor="ctr"/>
+          <a:lstStyle/>
+          <a:p>
+            <a:pPr indent="0" marL="0">
+              <a:buNone/>
+            </a:pPr>
+            <a:r>
+              <a:rPr lang="en-US" sz="1300" b="1" dirty="0">
+                <a:solidFill>
+                  <a:srgbClr val="0B1220"/>
+                </a:solidFill>
+                <a:latin typeface="Calibri" pitchFamily="34" charset="0"/>
+                <a:ea typeface="Calibri" pitchFamily="34" charset="-122"/>
+                <a:cs typeface="Calibri" pitchFamily="34" charset="-120"/>
+              </a:rPr>
+              <a:t>폐기한 지표의 예</a:t>
+            </a:r>
+            <a:endParaRPr lang="en-US" sz="1300" dirty="0"/>
+          </a:p>
+        </p:txBody>
+      </p:sp>
+      <p:sp>
+        <p:nvSpPr>
+          <p:cNvPr id="23" name="Text 21"/>
+          <p:cNvSpPr txBox="1"/>
+          <p:nvPr/>
+        </p:nvSpPr>
+        <p:spPr>
+          <a:xfrm>
+            <a:off x="6492240" y="4846320"/>
+            <a:ext cx="4572000" cy="914400"/>
+          </a:xfrm>
+          <a:prstGeom prst="rect">
+            <a:avLst/>
+          </a:prstGeom>
+          <a:noFill/>
+          <a:ln/>
+        </p:spPr>
+        <p:txBody>
+          <a:bodyPr wrap="square" lIns="0" tIns="0" rIns="0" bIns="0" rtlCol="0" anchor="ctr"/>
+          <a:lstStyle/>
+          <a:p>
+            <a:pPr indent="0" marL="0">
+              <a:lnSpc>
+                <a:spcPts val="1600"/>
+              </a:lnSpc>
+              <a:buNone/>
+            </a:pPr>
+            <a:r>
+              <a:rPr lang="en-US" sz="1150" dirty="0">
                 <a:solidFill>
                   <a:srgbClr val="6E7A8A"/>
                 </a:solidFill>
@@ -6202,285 +6824,9 @@
                 <a:ea typeface="Calibri" pitchFamily="34" charset="-122"/>
                 <a:cs typeface="Calibri" pitchFamily="34" charset="-120"/>
               </a:rPr>
-              <a:t>어제 지적받은 내용을 기억하지 못합니다</a:t>
-            </a:r>
-            <a:endParaRPr lang="en-US" sz="1250" dirty="0"/>
-          </a:p>
-        </p:txBody>
-      </p:sp>
-      <p:sp>
-        <p:nvSpPr>
-          <p:cNvPr id="14" name="Shape 12"/>
-          <p:cNvSpPr/>
-          <p:nvPr/>
-        </p:nvSpPr>
-        <p:spPr>
-          <a:xfrm>
-            <a:off x="6949440" y="3401568"/>
-            <a:ext cx="4480560" cy="859536"/>
-          </a:xfrm>
-          <a:prstGeom prst="roundRect">
-            <a:avLst>
-              <a:gd name="adj" fmla="val 8511"/>
-            </a:avLst>
-          </a:prstGeom>
-          <a:solidFill>
-            <a:srgbClr val="FFFFFF"/>
-          </a:solidFill>
-          <a:ln w="12700">
-            <a:solidFill>
-              <a:srgbClr val="1A61EA"/>
-            </a:solidFill>
-            <a:prstDash val="solid"/>
-          </a:ln>
-        </p:spPr>
-      </p:sp>
-      <p:sp>
-        <p:nvSpPr>
-          <p:cNvPr id="15" name="Text 13"/>
-          <p:cNvSpPr txBox="1"/>
-          <p:nvPr/>
-        </p:nvSpPr>
-        <p:spPr>
-          <a:xfrm>
-            <a:off x="7223760" y="3584448"/>
-            <a:ext cx="4023360" cy="548640"/>
-          </a:xfrm>
-          <a:prstGeom prst="rect">
-            <a:avLst/>
-          </a:prstGeom>
-          <a:noFill/>
-          <a:ln/>
-        </p:spPr>
-        <p:txBody>
-          <a:bodyPr wrap="square" lIns="0" tIns="0" rIns="0" bIns="0" rtlCol="0" anchor="ctr"/>
-          <a:lstStyle/>
-          <a:p>
-            <a:pPr indent="0" marL="0">
-              <a:buNone/>
-            </a:pPr>
-            <a:r>
-              <a:rPr lang="en-US" sz="1250" dirty="0">
-                <a:solidFill>
-                  <a:srgbClr val="0B1220"/>
-                </a:solidFill>
-                <a:latin typeface="Calibri" pitchFamily="34" charset="0"/>
-                <a:ea typeface="Calibri" pitchFamily="34" charset="-122"/>
-                <a:cs typeface="Calibri" pitchFamily="34" charset="-120"/>
-              </a:rPr>
-              <a:t>반려 사유가 규칙으로 남아 다음 생성에 적용됩니다</a:t>
-            </a:r>
-            <a:endParaRPr lang="en-US" sz="1250" dirty="0"/>
-          </a:p>
-        </p:txBody>
-      </p:sp>
-      <p:sp>
-        <p:nvSpPr>
-          <p:cNvPr id="16" name="Text 14"/>
-          <p:cNvSpPr txBox="1"/>
-          <p:nvPr/>
-        </p:nvSpPr>
-        <p:spPr>
-          <a:xfrm>
-            <a:off x="777240" y="4681728"/>
-            <a:ext cx="1371600" cy="274320"/>
-          </a:xfrm>
-          <a:prstGeom prst="rect">
-            <a:avLst/>
-          </a:prstGeom>
-          <a:noFill/>
-          <a:ln/>
-        </p:spPr>
-        <p:txBody>
-          <a:bodyPr wrap="square" lIns="0" tIns="0" rIns="0" bIns="0" rtlCol="0" anchor="ctr"/>
-          <a:lstStyle/>
-          <a:p>
-            <a:pPr indent="0" marL="0">
-              <a:buNone/>
-            </a:pPr>
-            <a:r>
-              <a:rPr lang="en-US" sz="1500" b="1" dirty="0">
-                <a:solidFill>
-                  <a:srgbClr val="0B1220"/>
-                </a:solidFill>
-                <a:latin typeface="Calibri" pitchFamily="34" charset="0"/>
-                <a:ea typeface="Calibri" pitchFamily="34" charset="-122"/>
-                <a:cs typeface="Calibri" pitchFamily="34" charset="-120"/>
-              </a:rPr>
-              <a:t>시작</a:t>
-            </a:r>
-            <a:endParaRPr lang="en-US" sz="1500" dirty="0"/>
-          </a:p>
-        </p:txBody>
-      </p:sp>
-      <p:sp>
-        <p:nvSpPr>
-          <p:cNvPr id="17" name="Shape 15"/>
-          <p:cNvSpPr/>
-          <p:nvPr/>
-        </p:nvSpPr>
-        <p:spPr>
-          <a:xfrm>
-            <a:off x="2240280" y="4425696"/>
-            <a:ext cx="4480560" cy="859536"/>
-          </a:xfrm>
-          <a:prstGeom prst="roundRect">
-            <a:avLst>
-              <a:gd name="adj" fmla="val 8511"/>
-            </a:avLst>
-          </a:prstGeom>
-          <a:solidFill>
-            <a:srgbClr val="FFFFFF"/>
-          </a:solidFill>
-          <a:ln w="12700">
-            <a:solidFill>
-              <a:srgbClr val="E6E9EF"/>
-            </a:solidFill>
-            <a:prstDash val="solid"/>
-          </a:ln>
-        </p:spPr>
-      </p:sp>
-      <p:sp>
-        <p:nvSpPr>
-          <p:cNvPr id="18" name="Text 16"/>
-          <p:cNvSpPr txBox="1"/>
-          <p:nvPr/>
-        </p:nvSpPr>
-        <p:spPr>
-          <a:xfrm>
-            <a:off x="2514600" y="4608576"/>
-            <a:ext cx="4023360" cy="548640"/>
-          </a:xfrm>
-          <a:prstGeom prst="rect">
-            <a:avLst/>
-          </a:prstGeom>
-          <a:noFill/>
-          <a:ln/>
-        </p:spPr>
-        <p:txBody>
-          <a:bodyPr wrap="square" lIns="0" tIns="0" rIns="0" bIns="0" rtlCol="0" anchor="ctr"/>
-          <a:lstStyle/>
-          <a:p>
-            <a:pPr indent="0" marL="0">
-              <a:buNone/>
-            </a:pPr>
-            <a:r>
-              <a:rPr lang="en-US" sz="1250" dirty="0">
-                <a:solidFill>
-                  <a:srgbClr val="6E7A8A"/>
-                </a:solidFill>
-                <a:latin typeface="Calibri" pitchFamily="34" charset="0"/>
-                <a:ea typeface="Calibri" pitchFamily="34" charset="-122"/>
-                <a:cs typeface="Calibri" pitchFamily="34" charset="-120"/>
-              </a:rPr>
-              <a:t>사람이 열어야 시작됩니다</a:t>
-            </a:r>
-            <a:endParaRPr lang="en-US" sz="1250" dirty="0"/>
-          </a:p>
-        </p:txBody>
-      </p:sp>
-      <p:sp>
-        <p:nvSpPr>
-          <p:cNvPr id="19" name="Shape 17"/>
-          <p:cNvSpPr/>
-          <p:nvPr/>
-        </p:nvSpPr>
-        <p:spPr>
-          <a:xfrm>
-            <a:off x="6949440" y="4425696"/>
-            <a:ext cx="4480560" cy="859536"/>
-          </a:xfrm>
-          <a:prstGeom prst="roundRect">
-            <a:avLst>
-              <a:gd name="adj" fmla="val 8511"/>
-            </a:avLst>
-          </a:prstGeom>
-          <a:solidFill>
-            <a:srgbClr val="FFFFFF"/>
-          </a:solidFill>
-          <a:ln w="12700">
-            <a:solidFill>
-              <a:srgbClr val="1A61EA"/>
-            </a:solidFill>
-            <a:prstDash val="solid"/>
-          </a:ln>
-        </p:spPr>
-      </p:sp>
-      <p:sp>
-        <p:nvSpPr>
-          <p:cNvPr id="20" name="Text 18"/>
-          <p:cNvSpPr txBox="1"/>
-          <p:nvPr/>
-        </p:nvSpPr>
-        <p:spPr>
-          <a:xfrm>
-            <a:off x="7223760" y="4608576"/>
-            <a:ext cx="4023360" cy="548640"/>
-          </a:xfrm>
-          <a:prstGeom prst="rect">
-            <a:avLst/>
-          </a:prstGeom>
-          <a:noFill/>
-          <a:ln/>
-        </p:spPr>
-        <p:txBody>
-          <a:bodyPr wrap="square" lIns="0" tIns="0" rIns="0" bIns="0" rtlCol="0" anchor="ctr"/>
-          <a:lstStyle/>
-          <a:p>
-            <a:pPr indent="0" marL="0">
-              <a:buNone/>
-            </a:pPr>
-            <a:r>
-              <a:rPr lang="en-US" sz="1250" dirty="0">
-                <a:solidFill>
-                  <a:srgbClr val="0B1220"/>
-                </a:solidFill>
-                <a:latin typeface="Calibri" pitchFamily="34" charset="0"/>
-                <a:ea typeface="Calibri" pitchFamily="34" charset="-122"/>
-                <a:cs typeface="Calibri" pitchFamily="34" charset="-120"/>
-              </a:rPr>
-              <a:t>데이터를 보고 먼저 제안하고 사람을 부릅니다</a:t>
-            </a:r>
-            <a:endParaRPr lang="en-US" sz="1250" dirty="0"/>
-          </a:p>
-        </p:txBody>
-      </p:sp>
-      <p:sp>
-        <p:nvSpPr>
-          <p:cNvPr id="21" name="Text 19"/>
-          <p:cNvSpPr txBox="1"/>
-          <p:nvPr/>
-        </p:nvSpPr>
-        <p:spPr>
-          <a:xfrm>
-            <a:off x="777240" y="5623560"/>
-            <a:ext cx="10058400" cy="365760"/>
-          </a:xfrm>
-          <a:prstGeom prst="rect">
-            <a:avLst/>
-          </a:prstGeom>
-          <a:noFill/>
-          <a:ln/>
-        </p:spPr>
-        <p:txBody>
-          <a:bodyPr wrap="square" lIns="0" tIns="0" rIns="0" bIns="0" rtlCol="0" anchor="ctr"/>
-          <a:lstStyle/>
-          <a:p>
-            <a:pPr indent="0" marL="0">
-              <a:buNone/>
-            </a:pPr>
-            <a:r>
-              <a:rPr lang="en-US" sz="1700" b="1" dirty="0">
-                <a:solidFill>
-                  <a:srgbClr val="1A61EA"/>
-                </a:solidFill>
-                <a:latin typeface="Calibri" pitchFamily="34" charset="0"/>
-                <a:ea typeface="Calibri" pitchFamily="34" charset="-122"/>
-                <a:cs typeface="Calibri" pitchFamily="34" charset="-120"/>
-              </a:rPr>
-              <a:t>이 시스템은 사람 대신 기억하는 구조입니다.</a:t>
-            </a:r>
-            <a:endParaRPr lang="en-US" sz="1700" dirty="0"/>
+              <a:t>“자사 글은 굵은 글씨를 쓰지 않는다”는 신호로 30점 차이를 만들었지만, 원본을 다시 확인하니 실제로는 1,000자당 9.73회 사용하고 있었습니다. 저희 수집 과정이 만든 착시였고, 그 신호는 폐기했습니다.</a:t>
+            </a:r>
+            <a:endParaRPr lang="en-US" sz="1150" dirty="0"/>
           </a:p>
         </p:txBody>
       </p:sp>
@@ -7416,7 +7762,7 @@
                 <a:ea typeface="Calibri" pitchFamily="34" charset="-122"/>
                 <a:cs typeface="Calibri" pitchFamily="34" charset="-120"/>
               </a:rPr>
-              <a:t>범위</a:t>
+              <a:t>SCOPE</a:t>
             </a:r>
             <a:endParaRPr lang="en-US" sz="1100" dirty="0"/>
           </a:p>
@@ -7455,7 +7801,7 @@
                 <a:ea typeface="Calibri" pitchFamily="34" charset="-122"/>
                 <a:cs typeface="Calibri" pitchFamily="34" charset="-120"/>
               </a:rPr>
-              <a:t>한 일과 하지 않은 일</a:t>
+              <a:t>Functionalities &amp; Limitations</a:t>
             </a:r>
             <a:endParaRPr lang="en-US" sz="3000" dirty="0"/>
           </a:p>

</xml_diff>

<commit_message>
docs: trim deck and script to fit 5 minutes
</commit_message>
<xml_diff>
--- a/aidlc-docs/deliverables/발표덱.pptx
+++ b/aidlc-docs/deliverables/발표덱.pptx
@@ -1127,7 +1127,7 @@
           <a:p>
             <a:r>
               <a:rPr lang="en-US" dirty="0"/>
-              <a:t>35초. 왼쪽은 훑고, 오른쪽 상단 관문만 또박또박 말합니다. 폐기 사례는 시간이 없으면 생략하고 질문 때 씁니다.</a:t>
+              <a:t>20초. 상단 기준값은 읽지 않고 관문 한 문장만 말합니다. 폐기 사례는 Q&amp;A용입니다.</a:t>
             </a:r>
             <a:endParaRPr lang="en-US" dirty="0"/>
           </a:p>
@@ -1303,7 +1303,7 @@
           <a:p>
             <a:r>
               <a:rPr lang="en-US" dirty="0"/>
-              <a:t>20초. 하지 않은 것을 먼저 말하고 도입 조건으로 닫습니다.</a:t>
+              <a:t>15초. 하지 않은 것을 먼저 말하고 링크드인 사유 한 줄로 닫습니다.</a:t>
             </a:r>
             <a:endParaRPr lang="en-US" dirty="0"/>
           </a:p>
@@ -2037,6 +2037,45 @@
         <p:spPr>
           <a:xfrm>
             <a:off x="777240" y="4407408"/>
+            <a:ext cx="10058400" cy="274320"/>
+          </a:xfrm>
+          <a:prstGeom prst="rect">
+            <a:avLst/>
+          </a:prstGeom>
+          <a:noFill/>
+          <a:ln/>
+        </p:spPr>
+        <p:txBody>
+          <a:bodyPr wrap="square" lIns="0" tIns="0" rIns="0" bIns="0" rtlCol="0" anchor="ctr"/>
+          <a:lstStyle/>
+          <a:p>
+            <a:pPr indent="0" marL="0">
+              <a:buNone/>
+            </a:pPr>
+            <a:r>
+              <a:rPr lang="en-US" sz="1350" dirty="0">
+                <a:solidFill>
+                  <a:srgbClr val="8FA3C4"/>
+                </a:solidFill>
+                <a:latin typeface="Calibri" pitchFamily="34" charset="0"/>
+                <a:ea typeface="Calibri" pitchFamily="34" charset="-122"/>
+                <a:cs typeface="Calibri" pitchFamily="34" charset="-120"/>
+              </a:rPr>
+              <a:t>도입에 필요한 것 — 문의 폼에 유입 경로 파라미터 한 줄, 승인자 계정 등록, 링크드인 토큰 연결</a:t>
+            </a:r>
+            <a:endParaRPr lang="en-US" sz="1350" dirty="0"/>
+          </a:p>
+        </p:txBody>
+      </p:sp>
+      <p:sp>
+        <p:nvSpPr>
+          <p:cNvPr id="7" name="Text 5"/>
+          <p:cNvSpPr txBox="1"/>
+          <p:nvPr/>
+        </p:nvSpPr>
+        <p:spPr>
+          <a:xfrm>
+            <a:off x="777240" y="4754880"/>
             <a:ext cx="7315200" cy="274320"/>
           </a:xfrm>
           <a:prstGeom prst="rect">
@@ -2053,9 +2092,9 @@
               <a:buNone/>
             </a:pPr>
             <a:r>
-              <a:rPr lang="en-US" sz="1300" dirty="0">
-                <a:solidFill>
-                  <a:srgbClr val="8FA3C4"/>
+              <a:rPr lang="en-US" sz="1250" dirty="0">
+                <a:solidFill>
+                  <a:srgbClr val="6B7F9E"/>
                 </a:solidFill>
                 <a:latin typeface="Calibri" pitchFamily="34" charset="0"/>
                 <a:ea typeface="Calibri" pitchFamily="34" charset="-122"/>
@@ -2063,7 +2102,7 @@
               </a:rPr>
               <a:t>marketingbot.vercel.app</a:t>
             </a:r>
-            <a:endParaRPr lang="en-US" sz="1300" dirty="0"/>
+            <a:endParaRPr lang="en-US" sz="1250" dirty="0"/>
           </a:p>
         </p:txBody>
       </p:sp>
@@ -6128,57 +6167,18 @@
       </p:sp>
       <p:sp>
         <p:nvSpPr>
-          <p:cNvPr id="5" name="Text 3"/>
-          <p:cNvSpPr txBox="1"/>
+          <p:cNvPr id="5" name="Shape 3"/>
+          <p:cNvSpPr/>
           <p:nvPr/>
         </p:nvSpPr>
         <p:spPr>
           <a:xfrm>
             <a:off x="777240" y="1965960"/>
-            <a:ext cx="5486400" cy="274320"/>
-          </a:xfrm>
-          <a:prstGeom prst="rect">
-            <a:avLst/>
-          </a:prstGeom>
-          <a:noFill/>
-          <a:ln/>
-        </p:spPr>
-        <p:txBody>
-          <a:bodyPr wrap="square" lIns="0" tIns="0" rIns="0" bIns="0" rtlCol="0" anchor="ctr"/>
-          <a:lstStyle/>
-          <a:p>
-            <a:pPr indent="0" marL="0">
-              <a:buNone/>
-            </a:pPr>
-            <a:r>
-              <a:rPr lang="en-US" sz="1400" b="1" dirty="0">
-                <a:solidFill>
-                  <a:srgbClr val="0B1220"/>
-                </a:solidFill>
-                <a:latin typeface="Calibri" pitchFamily="34" charset="0"/>
-                <a:ea typeface="Calibri" pitchFamily="34" charset="-122"/>
-                <a:cs typeface="Calibri" pitchFamily="34" charset="-120"/>
-              </a:rPr>
-              <a:t>기준값은 전부 그 46편의 실측값입니다</a:t>
-            </a:r>
-            <a:endParaRPr lang="en-US" sz="1400" dirty="0"/>
-          </a:p>
-        </p:txBody>
-      </p:sp>
-      <p:sp>
-        <p:nvSpPr>
-          <p:cNvPr id="6" name="Shape 4"/>
-          <p:cNvSpPr/>
-          <p:nvPr/>
-        </p:nvSpPr>
-        <p:spPr>
-          <a:xfrm>
-            <a:off x="777240" y="2359152"/>
-            <a:ext cx="5120640" cy="548640"/>
+            <a:ext cx="10607040" cy="868680"/>
           </a:xfrm>
           <a:prstGeom prst="roundRect">
             <a:avLst>
-              <a:gd name="adj" fmla="val 13333"/>
+              <a:gd name="adj" fmla="val 8421"/>
             </a:avLst>
           </a:prstGeom>
           <a:solidFill>
@@ -6194,30 +6194,108 @@
       </p:sp>
       <p:sp>
         <p:nvSpPr>
+          <p:cNvPr id="6" name="Text 4"/>
+          <p:cNvSpPr txBox="1"/>
+          <p:nvPr/>
+        </p:nvSpPr>
+        <p:spPr>
+          <a:xfrm>
+            <a:off x="1097280" y="2157984"/>
+            <a:ext cx="2377440" cy="219456"/>
+          </a:xfrm>
+          <a:prstGeom prst="rect">
+            <a:avLst/>
+          </a:prstGeom>
+          <a:noFill/>
+          <a:ln/>
+        </p:spPr>
+        <p:txBody>
+          <a:bodyPr wrap="square" lIns="0" tIns="0" rIns="0" bIns="0" rtlCol="0" anchor="ctr"/>
+          <a:lstStyle/>
+          <a:p>
+            <a:pPr indent="0" marL="0">
+              <a:buNone/>
+            </a:pPr>
+            <a:r>
+              <a:rPr lang="en-US" sz="1100" dirty="0">
+                <a:solidFill>
+                  <a:srgbClr val="6E7A8A"/>
+                </a:solidFill>
+                <a:latin typeface="Calibri" pitchFamily="34" charset="0"/>
+                <a:ea typeface="Calibri" pitchFamily="34" charset="-122"/>
+                <a:cs typeface="Calibri" pitchFamily="34" charset="-120"/>
+              </a:rPr>
+              <a:t>문장 평균 길이</a:t>
+            </a:r>
+            <a:endParaRPr lang="en-US" sz="1100" dirty="0"/>
+          </a:p>
+        </p:txBody>
+      </p:sp>
+      <p:sp>
+        <p:nvSpPr>
           <p:cNvPr id="7" name="Text 5"/>
           <p:cNvSpPr txBox="1"/>
           <p:nvPr/>
         </p:nvSpPr>
         <p:spPr>
           <a:xfrm>
-            <a:off x="1033272" y="2505456"/>
-            <a:ext cx="3108960" cy="256032"/>
-          </a:xfrm>
-          <a:prstGeom prst="rect">
-            <a:avLst/>
-          </a:prstGeom>
-          <a:noFill/>
-          <a:ln/>
-        </p:spPr>
-        <p:txBody>
-          <a:bodyPr wrap="square" lIns="0" tIns="0" rIns="0" bIns="0" rtlCol="0" anchor="ctr"/>
-          <a:lstStyle/>
-          <a:p>
-            <a:pPr indent="0" marL="0">
-              <a:buNone/>
-            </a:pPr>
-            <a:r>
-              <a:rPr lang="en-US" sz="1250" dirty="0">
+            <a:off x="1097280" y="2395728"/>
+            <a:ext cx="2377440" cy="274320"/>
+          </a:xfrm>
+          <a:prstGeom prst="rect">
+            <a:avLst/>
+          </a:prstGeom>
+          <a:noFill/>
+          <a:ln/>
+        </p:spPr>
+        <p:txBody>
+          <a:bodyPr wrap="square" lIns="0" tIns="0" rIns="0" bIns="0" rtlCol="0" anchor="ctr"/>
+          <a:lstStyle/>
+          <a:p>
+            <a:pPr indent="0" marL="0">
+              <a:buNone/>
+            </a:pPr>
+            <a:r>
+              <a:rPr lang="en-US" sz="1500" b="1" dirty="0">
+                <a:solidFill>
+                  <a:srgbClr val="0B1220"/>
+                </a:solidFill>
+                <a:latin typeface="Calibri" pitchFamily="34" charset="0"/>
+                <a:ea typeface="Calibri" pitchFamily="34" charset="-122"/>
+                <a:cs typeface="Calibri" pitchFamily="34" charset="-120"/>
+              </a:rPr>
+              <a:t>46.9자</a:t>
+            </a:r>
+            <a:endParaRPr lang="en-US" sz="1500" dirty="0"/>
+          </a:p>
+        </p:txBody>
+      </p:sp>
+      <p:sp>
+        <p:nvSpPr>
+          <p:cNvPr id="8" name="Text 6"/>
+          <p:cNvSpPr txBox="1"/>
+          <p:nvPr/>
+        </p:nvSpPr>
+        <p:spPr>
+          <a:xfrm>
+            <a:off x="3703320" y="2157984"/>
+            <a:ext cx="2377440" cy="219456"/>
+          </a:xfrm>
+          <a:prstGeom prst="rect">
+            <a:avLst/>
+          </a:prstGeom>
+          <a:noFill/>
+          <a:ln/>
+        </p:spPr>
+        <p:txBody>
+          <a:bodyPr wrap="square" lIns="0" tIns="0" rIns="0" bIns="0" rtlCol="0" anchor="ctr"/>
+          <a:lstStyle/>
+          <a:p>
+            <a:pPr indent="0" marL="0">
+              <a:buNone/>
+            </a:pPr>
+            <a:r>
+              <a:rPr lang="en-US" sz="1100" dirty="0">
                 <a:solidFill>
                   <a:srgbClr val="6E7A8A"/>
                 </a:solidFill>
@@ -6225,38 +6303,38 @@
                 <a:ea typeface="Calibri" pitchFamily="34" charset="-122"/>
                 <a:cs typeface="Calibri" pitchFamily="34" charset="-120"/>
               </a:rPr>
-              <a:t>문장 평균 길이</a:t>
-            </a:r>
-            <a:endParaRPr lang="en-US" sz="1250" dirty="0"/>
-          </a:p>
-        </p:txBody>
-      </p:sp>
-      <p:sp>
-        <p:nvSpPr>
-          <p:cNvPr id="8" name="Text 6"/>
-          <p:cNvSpPr txBox="1"/>
-          <p:nvPr/>
-        </p:nvSpPr>
-        <p:spPr>
-          <a:xfrm>
-            <a:off x="4069080" y="2487168"/>
-            <a:ext cx="1645920" cy="274320"/>
-          </a:xfrm>
-          <a:prstGeom prst="rect">
-            <a:avLst/>
-          </a:prstGeom>
-          <a:noFill/>
-          <a:ln/>
-        </p:spPr>
-        <p:txBody>
-          <a:bodyPr wrap="square" lIns="0" tIns="0" rIns="0" bIns="0" rtlCol="0" anchor="ctr"/>
-          <a:lstStyle/>
-          <a:p>
-            <a:pPr algn="r" indent="0" marL="0">
-              <a:buNone/>
-            </a:pPr>
-            <a:r>
-              <a:rPr lang="en-US" sz="1350" b="1" dirty="0">
+              <a:t>어미 전환률 중앙값</a:t>
+            </a:r>
+            <a:endParaRPr lang="en-US" sz="1100" dirty="0"/>
+          </a:p>
+        </p:txBody>
+      </p:sp>
+      <p:sp>
+        <p:nvSpPr>
+          <p:cNvPr id="9" name="Text 7"/>
+          <p:cNvSpPr txBox="1"/>
+          <p:nvPr/>
+        </p:nvSpPr>
+        <p:spPr>
+          <a:xfrm>
+            <a:off x="3703320" y="2395728"/>
+            <a:ext cx="2377440" cy="274320"/>
+          </a:xfrm>
+          <a:prstGeom prst="rect">
+            <a:avLst/>
+          </a:prstGeom>
+          <a:noFill/>
+          <a:ln/>
+        </p:spPr>
+        <p:txBody>
+          <a:bodyPr wrap="square" lIns="0" tIns="0" rIns="0" bIns="0" rtlCol="0" anchor="ctr"/>
+          <a:lstStyle/>
+          <a:p>
+            <a:pPr indent="0" marL="0">
+              <a:buNone/>
+            </a:pPr>
+            <a:r>
+              <a:rPr lang="en-US" sz="1500" b="1" dirty="0">
                 <a:solidFill>
                   <a:srgbClr val="0B1220"/>
                 </a:solidFill>
@@ -6264,26 +6342,310 @@
                 <a:ea typeface="Calibri" pitchFamily="34" charset="-122"/>
                 <a:cs typeface="Calibri" pitchFamily="34" charset="-120"/>
               </a:rPr>
-              <a:t>46.9자</a:t>
-            </a:r>
-            <a:endParaRPr lang="en-US" sz="1350" dirty="0"/>
-          </a:p>
-        </p:txBody>
-      </p:sp>
-      <p:sp>
-        <p:nvSpPr>
-          <p:cNvPr id="9" name="Shape 7"/>
+              <a:t>10.4%</a:t>
+            </a:r>
+            <a:endParaRPr lang="en-US" sz="1500" dirty="0"/>
+          </a:p>
+        </p:txBody>
+      </p:sp>
+      <p:sp>
+        <p:nvSpPr>
+          <p:cNvPr id="10" name="Text 8"/>
+          <p:cNvSpPr txBox="1"/>
+          <p:nvPr/>
+        </p:nvSpPr>
+        <p:spPr>
+          <a:xfrm>
+            <a:off x="6309360" y="2157984"/>
+            <a:ext cx="2377440" cy="219456"/>
+          </a:xfrm>
+          <a:prstGeom prst="rect">
+            <a:avLst/>
+          </a:prstGeom>
+          <a:noFill/>
+          <a:ln/>
+        </p:spPr>
+        <p:txBody>
+          <a:bodyPr wrap="square" lIns="0" tIns="0" rIns="0" bIns="0" rtlCol="0" anchor="ctr"/>
+          <a:lstStyle/>
+          <a:p>
+            <a:pPr indent="0" marL="0">
+              <a:buNone/>
+            </a:pPr>
+            <a:r>
+              <a:rPr lang="en-US" sz="1100" dirty="0">
+                <a:solidFill>
+                  <a:srgbClr val="6E7A8A"/>
+                </a:solidFill>
+                <a:latin typeface="Calibri" pitchFamily="34" charset="0"/>
+                <a:ea typeface="Calibri" pitchFamily="34" charset="-122"/>
+                <a:cs typeface="Calibri" pitchFamily="34" charset="-120"/>
+              </a:rPr>
+              <a:t>브랜드 언급</a:t>
+            </a:r>
+            <a:endParaRPr lang="en-US" sz="1100" dirty="0"/>
+          </a:p>
+        </p:txBody>
+      </p:sp>
+      <p:sp>
+        <p:nvSpPr>
+          <p:cNvPr id="11" name="Text 9"/>
+          <p:cNvSpPr txBox="1"/>
+          <p:nvPr/>
+        </p:nvSpPr>
+        <p:spPr>
+          <a:xfrm>
+            <a:off x="6309360" y="2395728"/>
+            <a:ext cx="2377440" cy="274320"/>
+          </a:xfrm>
+          <a:prstGeom prst="rect">
+            <a:avLst/>
+          </a:prstGeom>
+          <a:noFill/>
+          <a:ln/>
+        </p:spPr>
+        <p:txBody>
+          <a:bodyPr wrap="square" lIns="0" tIns="0" rIns="0" bIns="0" rtlCol="0" anchor="ctr"/>
+          <a:lstStyle/>
+          <a:p>
+            <a:pPr indent="0" marL="0">
+              <a:buNone/>
+            </a:pPr>
+            <a:r>
+              <a:rPr lang="en-US" sz="1500" b="1" dirty="0">
+                <a:solidFill>
+                  <a:srgbClr val="0B1220"/>
+                </a:solidFill>
+                <a:latin typeface="Calibri" pitchFamily="34" charset="0"/>
+                <a:ea typeface="Calibri" pitchFamily="34" charset="-122"/>
+                <a:cs typeface="Calibri" pitchFamily="34" charset="-120"/>
+              </a:rPr>
+              <a:t>1.09회 / 1,000자</a:t>
+            </a:r>
+            <a:endParaRPr lang="en-US" sz="1500" dirty="0"/>
+          </a:p>
+        </p:txBody>
+      </p:sp>
+      <p:sp>
+        <p:nvSpPr>
+          <p:cNvPr id="12" name="Text 10"/>
+          <p:cNvSpPr txBox="1"/>
+          <p:nvPr/>
+        </p:nvSpPr>
+        <p:spPr>
+          <a:xfrm>
+            <a:off x="8915400" y="2157984"/>
+            <a:ext cx="2377440" cy="219456"/>
+          </a:xfrm>
+          <a:prstGeom prst="rect">
+            <a:avLst/>
+          </a:prstGeom>
+          <a:noFill/>
+          <a:ln/>
+        </p:spPr>
+        <p:txBody>
+          <a:bodyPr wrap="square" lIns="0" tIns="0" rIns="0" bIns="0" rtlCol="0" anchor="ctr"/>
+          <a:lstStyle/>
+          <a:p>
+            <a:pPr indent="0" marL="0">
+              <a:buNone/>
+            </a:pPr>
+            <a:r>
+              <a:rPr lang="en-US" sz="1100" dirty="0">
+                <a:solidFill>
+                  <a:srgbClr val="6E7A8A"/>
+                </a:solidFill>
+                <a:latin typeface="Calibri" pitchFamily="34" charset="0"/>
+                <a:ea typeface="Calibri" pitchFamily="34" charset="-122"/>
+                <a:cs typeface="Calibri" pitchFamily="34" charset="-120"/>
+              </a:rPr>
+              <a:t>수치 인용</a:t>
+            </a:r>
+            <a:endParaRPr lang="en-US" sz="1100" dirty="0"/>
+          </a:p>
+        </p:txBody>
+      </p:sp>
+      <p:sp>
+        <p:nvSpPr>
+          <p:cNvPr id="13" name="Text 11"/>
+          <p:cNvSpPr txBox="1"/>
+          <p:nvPr/>
+        </p:nvSpPr>
+        <p:spPr>
+          <a:xfrm>
+            <a:off x="8915400" y="2395728"/>
+            <a:ext cx="2377440" cy="274320"/>
+          </a:xfrm>
+          <a:prstGeom prst="rect">
+            <a:avLst/>
+          </a:prstGeom>
+          <a:noFill/>
+          <a:ln/>
+        </p:spPr>
+        <p:txBody>
+          <a:bodyPr wrap="square" lIns="0" tIns="0" rIns="0" bIns="0" rtlCol="0" anchor="ctr"/>
+          <a:lstStyle/>
+          <a:p>
+            <a:pPr indent="0" marL="0">
+              <a:buNone/>
+            </a:pPr>
+            <a:r>
+              <a:rPr lang="en-US" sz="1500" b="1" dirty="0">
+                <a:solidFill>
+                  <a:srgbClr val="0B1220"/>
+                </a:solidFill>
+                <a:latin typeface="Calibri" pitchFamily="34" charset="0"/>
+                <a:ea typeface="Calibri" pitchFamily="34" charset="-122"/>
+                <a:cs typeface="Calibri" pitchFamily="34" charset="-120"/>
+              </a:rPr>
+              <a:t>1.26회 / 1,000자</a:t>
+            </a:r>
+            <a:endParaRPr lang="en-US" sz="1500" dirty="0"/>
+          </a:p>
+        </p:txBody>
+      </p:sp>
+      <p:sp>
+        <p:nvSpPr>
+          <p:cNvPr id="14" name="Shape 12"/>
           <p:cNvSpPr/>
           <p:nvPr/>
         </p:nvSpPr>
         <p:spPr>
           <a:xfrm>
-            <a:off x="777240" y="3017520"/>
-            <a:ext cx="5120640" cy="548640"/>
+            <a:off x="777240" y="3063240"/>
+            <a:ext cx="10607040" cy="1554480"/>
           </a:xfrm>
           <a:prstGeom prst="roundRect">
             <a:avLst>
-              <a:gd name="adj" fmla="val 13333"/>
+              <a:gd name="adj" fmla="val 4706"/>
+            </a:avLst>
+          </a:prstGeom>
+          <a:solidFill>
+            <a:srgbClr val="FFFFFF"/>
+          </a:solidFill>
+          <a:ln w="12700">
+            <a:solidFill>
+              <a:srgbClr val="1A61EA"/>
+            </a:solidFill>
+            <a:prstDash val="solid"/>
+          </a:ln>
+        </p:spPr>
+      </p:sp>
+      <p:sp>
+        <p:nvSpPr>
+          <p:cNvPr id="15" name="Text 13"/>
+          <p:cNvSpPr txBox="1"/>
+          <p:nvPr/>
+        </p:nvSpPr>
+        <p:spPr>
+          <a:xfrm>
+            <a:off x="1188720" y="3291840"/>
+            <a:ext cx="7315200" cy="310896"/>
+          </a:xfrm>
+          <a:prstGeom prst="rect">
+            <a:avLst/>
+          </a:prstGeom>
+          <a:noFill/>
+          <a:ln/>
+        </p:spPr>
+        <p:txBody>
+          <a:bodyPr wrap="square" lIns="0" tIns="0" rIns="0" bIns="0" rtlCol="0" anchor="ctr"/>
+          <a:lstStyle/>
+          <a:p>
+            <a:pPr indent="0" marL="0">
+              <a:buNone/>
+            </a:pPr>
+            <a:r>
+              <a:rPr lang="en-US" sz="1900" b="1" dirty="0">
+                <a:solidFill>
+                  <a:srgbClr val="1A61EA"/>
+                </a:solidFill>
+                <a:latin typeface="Calibri" pitchFamily="34" charset="0"/>
+                <a:ea typeface="Calibri" pitchFamily="34" charset="-122"/>
+                <a:cs typeface="Calibri" pitchFamily="34" charset="-120"/>
+              </a:rPr>
+              <a:t>기준을 고칠 때마다 통과해야 하는 관문</a:t>
+            </a:r>
+            <a:endParaRPr lang="en-US" sz="1900" dirty="0"/>
+          </a:p>
+        </p:txBody>
+      </p:sp>
+      <p:sp>
+        <p:nvSpPr>
+          <p:cNvPr id="16" name="Text 14"/>
+          <p:cNvSpPr txBox="1"/>
+          <p:nvPr/>
+        </p:nvSpPr>
+        <p:spPr>
+          <a:xfrm>
+            <a:off x="1188720" y="3703320"/>
+            <a:ext cx="9875520" cy="777240"/>
+          </a:xfrm>
+          <a:prstGeom prst="rect">
+            <a:avLst/>
+          </a:prstGeom>
+          <a:noFill/>
+          <a:ln/>
+        </p:spPr>
+        <p:txBody>
+          <a:bodyPr wrap="square" lIns="0" tIns="0" rIns="0" bIns="0" rtlCol="0" anchor="ctr"/>
+          <a:lstStyle/>
+          <a:p>
+            <a:pPr indent="0" marL="0">
+              <a:lnSpc>
+                <a:spcPts val="2200"/>
+              </a:lnSpc>
+              <a:buNone/>
+            </a:pPr>
+            <a:r>
+              <a:rPr lang="en-US" sz="1400" dirty="0">
+                <a:solidFill>
+                  <a:srgbClr val="38445A"/>
+                </a:solidFill>
+                <a:latin typeface="Calibri" pitchFamily="34" charset="0"/>
+                <a:ea typeface="Calibri" pitchFamily="34" charset="-122"/>
+                <a:cs typeface="Calibri" pitchFamily="34" charset="-120"/>
+              </a:rPr>
+              <a:t>수정한 채점 기준으로 그 46편을 다시 채점해 중앙값 92점이 유지되어야 채택하고, 그러지 못하면 폐기합니다.</a:t>
+            </a:r>
+            <a:endParaRPr lang="en-US" sz="1400" dirty="0"/>
+          </a:p>
+          <a:p>
+            <a:pPr indent="0" marL="0">
+              <a:lnSpc>
+                <a:spcPts val="2200"/>
+              </a:lnSpc>
+              <a:buNone/>
+            </a:pPr>
+            <a:r>
+              <a:rPr lang="en-US" sz="1400" dirty="0">
+                <a:solidFill>
+                  <a:srgbClr val="38445A"/>
+                </a:solidFill>
+                <a:latin typeface="Calibri" pitchFamily="34" charset="0"/>
+                <a:ea typeface="Calibri" pitchFamily="34" charset="-122"/>
+                <a:cs typeface="Calibri" pitchFamily="34" charset="-120"/>
+              </a:rPr>
+              <a:t>실제로 네 차례 폐기하거나 고쳤습니다. 저희 결과에 유리하도록 맞춘 지표가 아니라, 고객사의 글로 검증한 지표입니다.</a:t>
+            </a:r>
+            <a:endParaRPr lang="en-US" sz="1400" dirty="0"/>
+          </a:p>
+        </p:txBody>
+      </p:sp>
+      <p:sp>
+        <p:nvSpPr>
+          <p:cNvPr id="17" name="Shape 15"/>
+          <p:cNvSpPr/>
+          <p:nvPr/>
+        </p:nvSpPr>
+        <p:spPr>
+          <a:xfrm>
+            <a:off x="777240" y="4846320"/>
+            <a:ext cx="10607040" cy="1143000"/>
+          </a:xfrm>
+          <a:prstGeom prst="roundRect">
+            <a:avLst>
+              <a:gd name="adj" fmla="val 6400"/>
             </a:avLst>
           </a:prstGeom>
           <a:solidFill>
@@ -6299,26 +6661,68 @@
       </p:sp>
       <p:sp>
         <p:nvSpPr>
-          <p:cNvPr id="10" name="Text 8"/>
-          <p:cNvSpPr txBox="1"/>
-          <p:nvPr/>
-        </p:nvSpPr>
-        <p:spPr>
-          <a:xfrm>
-            <a:off x="1033272" y="3163824"/>
-            <a:ext cx="3108960" cy="256032"/>
-          </a:xfrm>
-          <a:prstGeom prst="rect">
-            <a:avLst/>
-          </a:prstGeom>
-          <a:noFill/>
-          <a:ln/>
-        </p:spPr>
-        <p:txBody>
-          <a:bodyPr wrap="square" lIns="0" tIns="0" rIns="0" bIns="0" rtlCol="0" anchor="ctr"/>
-          <a:lstStyle/>
-          <a:p>
-            <a:pPr indent="0" marL="0">
+          <p:cNvPr id="18" name="Text 16"/>
+          <p:cNvSpPr txBox="1"/>
+          <p:nvPr/>
+        </p:nvSpPr>
+        <p:spPr>
+          <a:xfrm>
+            <a:off x="1188720" y="5029200"/>
+            <a:ext cx="4572000" cy="256032"/>
+          </a:xfrm>
+          <a:prstGeom prst="rect">
+            <a:avLst/>
+          </a:prstGeom>
+          <a:noFill/>
+          <a:ln/>
+        </p:spPr>
+        <p:txBody>
+          <a:bodyPr wrap="square" lIns="0" tIns="0" rIns="0" bIns="0" rtlCol="0" anchor="ctr"/>
+          <a:lstStyle/>
+          <a:p>
+            <a:pPr indent="0" marL="0">
+              <a:buNone/>
+            </a:pPr>
+            <a:r>
+              <a:rPr lang="en-US" sz="1350" b="1" dirty="0">
+                <a:solidFill>
+                  <a:srgbClr val="0B1220"/>
+                </a:solidFill>
+                <a:latin typeface="Calibri" pitchFamily="34" charset="0"/>
+                <a:ea typeface="Calibri" pitchFamily="34" charset="-122"/>
+                <a:cs typeface="Calibri" pitchFamily="34" charset="-120"/>
+              </a:rPr>
+              <a:t>폐기한 지표의 예</a:t>
+            </a:r>
+            <a:endParaRPr lang="en-US" sz="1350" dirty="0"/>
+          </a:p>
+        </p:txBody>
+      </p:sp>
+      <p:sp>
+        <p:nvSpPr>
+          <p:cNvPr id="19" name="Text 17"/>
+          <p:cNvSpPr txBox="1"/>
+          <p:nvPr/>
+        </p:nvSpPr>
+        <p:spPr>
+          <a:xfrm>
+            <a:off x="1188720" y="5340096"/>
+            <a:ext cx="9875520" cy="548640"/>
+          </a:xfrm>
+          <a:prstGeom prst="rect">
+            <a:avLst/>
+          </a:prstGeom>
+          <a:noFill/>
+          <a:ln/>
+        </p:spPr>
+        <p:txBody>
+          <a:bodyPr wrap="square" lIns="0" tIns="0" rIns="0" bIns="0" rtlCol="0" anchor="ctr"/>
+          <a:lstStyle/>
+          <a:p>
+            <a:pPr indent="0" marL="0">
+              <a:lnSpc>
+                <a:spcPts val="1800"/>
+              </a:lnSpc>
               <a:buNone/>
             </a:pPr>
             <a:r>
@@ -6330,503 +6734,9 @@
                 <a:ea typeface="Calibri" pitchFamily="34" charset="-122"/>
                 <a:cs typeface="Calibri" pitchFamily="34" charset="-120"/>
               </a:rPr>
-              <a:t>어미 전환률 중앙값</a:t>
+              <a:t>“자사 글은 굵은 글씨를 쓰지 않는다”는 신호로 30점 차이를 만들었지만, 원본을 다시 확인하니 실제로는 1,000자당 9.73회 사용하고 있었습니다. 저희 수집 과정이 만든 착시였고, 그 신호는 폐기했습니다.</a:t>
             </a:r>
             <a:endParaRPr lang="en-US" sz="1250" dirty="0"/>
-          </a:p>
-        </p:txBody>
-      </p:sp>
-      <p:sp>
-        <p:nvSpPr>
-          <p:cNvPr id="11" name="Text 9"/>
-          <p:cNvSpPr txBox="1"/>
-          <p:nvPr/>
-        </p:nvSpPr>
-        <p:spPr>
-          <a:xfrm>
-            <a:off x="4069080" y="3145536"/>
-            <a:ext cx="1645920" cy="274320"/>
-          </a:xfrm>
-          <a:prstGeom prst="rect">
-            <a:avLst/>
-          </a:prstGeom>
-          <a:noFill/>
-          <a:ln/>
-        </p:spPr>
-        <p:txBody>
-          <a:bodyPr wrap="square" lIns="0" tIns="0" rIns="0" bIns="0" rtlCol="0" anchor="ctr"/>
-          <a:lstStyle/>
-          <a:p>
-            <a:pPr algn="r" indent="0" marL="0">
-              <a:buNone/>
-            </a:pPr>
-            <a:r>
-              <a:rPr lang="en-US" sz="1350" b="1" dirty="0">
-                <a:solidFill>
-                  <a:srgbClr val="0B1220"/>
-                </a:solidFill>
-                <a:latin typeface="Calibri" pitchFamily="34" charset="0"/>
-                <a:ea typeface="Calibri" pitchFamily="34" charset="-122"/>
-                <a:cs typeface="Calibri" pitchFamily="34" charset="-120"/>
-              </a:rPr>
-              <a:t>10.4%</a:t>
-            </a:r>
-            <a:endParaRPr lang="en-US" sz="1350" dirty="0"/>
-          </a:p>
-        </p:txBody>
-      </p:sp>
-      <p:sp>
-        <p:nvSpPr>
-          <p:cNvPr id="12" name="Shape 10"/>
-          <p:cNvSpPr/>
-          <p:nvPr/>
-        </p:nvSpPr>
-        <p:spPr>
-          <a:xfrm>
-            <a:off x="777240" y="3675888"/>
-            <a:ext cx="5120640" cy="548640"/>
-          </a:xfrm>
-          <a:prstGeom prst="roundRect">
-            <a:avLst>
-              <a:gd name="adj" fmla="val 13333"/>
-            </a:avLst>
-          </a:prstGeom>
-          <a:solidFill>
-            <a:srgbClr val="FFFFFF"/>
-          </a:solidFill>
-          <a:ln w="12700">
-            <a:solidFill>
-              <a:srgbClr val="E6E9EF"/>
-            </a:solidFill>
-            <a:prstDash val="solid"/>
-          </a:ln>
-        </p:spPr>
-      </p:sp>
-      <p:sp>
-        <p:nvSpPr>
-          <p:cNvPr id="13" name="Text 11"/>
-          <p:cNvSpPr txBox="1"/>
-          <p:nvPr/>
-        </p:nvSpPr>
-        <p:spPr>
-          <a:xfrm>
-            <a:off x="1033272" y="3822192"/>
-            <a:ext cx="3108960" cy="256032"/>
-          </a:xfrm>
-          <a:prstGeom prst="rect">
-            <a:avLst/>
-          </a:prstGeom>
-          <a:noFill/>
-          <a:ln/>
-        </p:spPr>
-        <p:txBody>
-          <a:bodyPr wrap="square" lIns="0" tIns="0" rIns="0" bIns="0" rtlCol="0" anchor="ctr"/>
-          <a:lstStyle/>
-          <a:p>
-            <a:pPr indent="0" marL="0">
-              <a:buNone/>
-            </a:pPr>
-            <a:r>
-              <a:rPr lang="en-US" sz="1250" dirty="0">
-                <a:solidFill>
-                  <a:srgbClr val="6E7A8A"/>
-                </a:solidFill>
-                <a:latin typeface="Calibri" pitchFamily="34" charset="0"/>
-                <a:ea typeface="Calibri" pitchFamily="34" charset="-122"/>
-                <a:cs typeface="Calibri" pitchFamily="34" charset="-120"/>
-              </a:rPr>
-              <a:t>브랜드 언급</a:t>
-            </a:r>
-            <a:endParaRPr lang="en-US" sz="1250" dirty="0"/>
-          </a:p>
-        </p:txBody>
-      </p:sp>
-      <p:sp>
-        <p:nvSpPr>
-          <p:cNvPr id="14" name="Text 12"/>
-          <p:cNvSpPr txBox="1"/>
-          <p:nvPr/>
-        </p:nvSpPr>
-        <p:spPr>
-          <a:xfrm>
-            <a:off x="4069080" y="3803904"/>
-            <a:ext cx="1645920" cy="274320"/>
-          </a:xfrm>
-          <a:prstGeom prst="rect">
-            <a:avLst/>
-          </a:prstGeom>
-          <a:noFill/>
-          <a:ln/>
-        </p:spPr>
-        <p:txBody>
-          <a:bodyPr wrap="square" lIns="0" tIns="0" rIns="0" bIns="0" rtlCol="0" anchor="ctr"/>
-          <a:lstStyle/>
-          <a:p>
-            <a:pPr algn="r" indent="0" marL="0">
-              <a:buNone/>
-            </a:pPr>
-            <a:r>
-              <a:rPr lang="en-US" sz="1350" b="1" dirty="0">
-                <a:solidFill>
-                  <a:srgbClr val="0B1220"/>
-                </a:solidFill>
-                <a:latin typeface="Calibri" pitchFamily="34" charset="0"/>
-                <a:ea typeface="Calibri" pitchFamily="34" charset="-122"/>
-                <a:cs typeface="Calibri" pitchFamily="34" charset="-120"/>
-              </a:rPr>
-              <a:t>1.09회 / 1,000자</a:t>
-            </a:r>
-            <a:endParaRPr lang="en-US" sz="1350" dirty="0"/>
-          </a:p>
-        </p:txBody>
-      </p:sp>
-      <p:sp>
-        <p:nvSpPr>
-          <p:cNvPr id="15" name="Shape 13"/>
-          <p:cNvSpPr/>
-          <p:nvPr/>
-        </p:nvSpPr>
-        <p:spPr>
-          <a:xfrm>
-            <a:off x="777240" y="4334256"/>
-            <a:ext cx="5120640" cy="548640"/>
-          </a:xfrm>
-          <a:prstGeom prst="roundRect">
-            <a:avLst>
-              <a:gd name="adj" fmla="val 13333"/>
-            </a:avLst>
-          </a:prstGeom>
-          <a:solidFill>
-            <a:srgbClr val="FFFFFF"/>
-          </a:solidFill>
-          <a:ln w="12700">
-            <a:solidFill>
-              <a:srgbClr val="E6E9EF"/>
-            </a:solidFill>
-            <a:prstDash val="solid"/>
-          </a:ln>
-        </p:spPr>
-      </p:sp>
-      <p:sp>
-        <p:nvSpPr>
-          <p:cNvPr id="16" name="Text 14"/>
-          <p:cNvSpPr txBox="1"/>
-          <p:nvPr/>
-        </p:nvSpPr>
-        <p:spPr>
-          <a:xfrm>
-            <a:off x="1033272" y="4480560"/>
-            <a:ext cx="3108960" cy="256032"/>
-          </a:xfrm>
-          <a:prstGeom prst="rect">
-            <a:avLst/>
-          </a:prstGeom>
-          <a:noFill/>
-          <a:ln/>
-        </p:spPr>
-        <p:txBody>
-          <a:bodyPr wrap="square" lIns="0" tIns="0" rIns="0" bIns="0" rtlCol="0" anchor="ctr"/>
-          <a:lstStyle/>
-          <a:p>
-            <a:pPr indent="0" marL="0">
-              <a:buNone/>
-            </a:pPr>
-            <a:r>
-              <a:rPr lang="en-US" sz="1250" dirty="0">
-                <a:solidFill>
-                  <a:srgbClr val="6E7A8A"/>
-                </a:solidFill>
-                <a:latin typeface="Calibri" pitchFamily="34" charset="0"/>
-                <a:ea typeface="Calibri" pitchFamily="34" charset="-122"/>
-                <a:cs typeface="Calibri" pitchFamily="34" charset="-120"/>
-              </a:rPr>
-              <a:t>수치 인용</a:t>
-            </a:r>
-            <a:endParaRPr lang="en-US" sz="1250" dirty="0"/>
-          </a:p>
-        </p:txBody>
-      </p:sp>
-      <p:sp>
-        <p:nvSpPr>
-          <p:cNvPr id="17" name="Text 15"/>
-          <p:cNvSpPr txBox="1"/>
-          <p:nvPr/>
-        </p:nvSpPr>
-        <p:spPr>
-          <a:xfrm>
-            <a:off x="4069080" y="4462272"/>
-            <a:ext cx="1645920" cy="274320"/>
-          </a:xfrm>
-          <a:prstGeom prst="rect">
-            <a:avLst/>
-          </a:prstGeom>
-          <a:noFill/>
-          <a:ln/>
-        </p:spPr>
-        <p:txBody>
-          <a:bodyPr wrap="square" lIns="0" tIns="0" rIns="0" bIns="0" rtlCol="0" anchor="ctr"/>
-          <a:lstStyle/>
-          <a:p>
-            <a:pPr algn="r" indent="0" marL="0">
-              <a:buNone/>
-            </a:pPr>
-            <a:r>
-              <a:rPr lang="en-US" sz="1350" b="1" dirty="0">
-                <a:solidFill>
-                  <a:srgbClr val="0B1220"/>
-                </a:solidFill>
-                <a:latin typeface="Calibri" pitchFamily="34" charset="0"/>
-                <a:ea typeface="Calibri" pitchFamily="34" charset="-122"/>
-                <a:cs typeface="Calibri" pitchFamily="34" charset="-120"/>
-              </a:rPr>
-              <a:t>1.26회 / 1,000자</a:t>
-            </a:r>
-            <a:endParaRPr lang="en-US" sz="1350" dirty="0"/>
-          </a:p>
-        </p:txBody>
-      </p:sp>
-      <p:sp>
-        <p:nvSpPr>
-          <p:cNvPr id="18" name="Shape 16"/>
-          <p:cNvSpPr/>
-          <p:nvPr/>
-        </p:nvSpPr>
-        <p:spPr>
-          <a:xfrm>
-            <a:off x="6217920" y="2359152"/>
-            <a:ext cx="5120640" cy="1847088"/>
-          </a:xfrm>
-          <a:prstGeom prst="roundRect">
-            <a:avLst>
-              <a:gd name="adj" fmla="val 3960"/>
-            </a:avLst>
-          </a:prstGeom>
-          <a:solidFill>
-            <a:srgbClr val="FFFFFF"/>
-          </a:solidFill>
-          <a:ln w="12700">
-            <a:solidFill>
-              <a:srgbClr val="1A61EA"/>
-            </a:solidFill>
-            <a:prstDash val="solid"/>
-          </a:ln>
-        </p:spPr>
-      </p:sp>
-      <p:sp>
-        <p:nvSpPr>
-          <p:cNvPr id="19" name="Text 17"/>
-          <p:cNvSpPr txBox="1"/>
-          <p:nvPr/>
-        </p:nvSpPr>
-        <p:spPr>
-          <a:xfrm>
-            <a:off x="6492240" y="2560320"/>
-            <a:ext cx="4572000" cy="274320"/>
-          </a:xfrm>
-          <a:prstGeom prst="rect">
-            <a:avLst/>
-          </a:prstGeom>
-          <a:noFill/>
-          <a:ln/>
-        </p:spPr>
-        <p:txBody>
-          <a:bodyPr wrap="square" lIns="0" tIns="0" rIns="0" bIns="0" rtlCol="0" anchor="ctr"/>
-          <a:lstStyle/>
-          <a:p>
-            <a:pPr indent="0" marL="0">
-              <a:buNone/>
-            </a:pPr>
-            <a:r>
-              <a:rPr lang="en-US" sz="1400" b="1" dirty="0">
-                <a:solidFill>
-                  <a:srgbClr val="1A61EA"/>
-                </a:solidFill>
-                <a:latin typeface="Calibri" pitchFamily="34" charset="0"/>
-                <a:ea typeface="Calibri" pitchFamily="34" charset="-122"/>
-                <a:cs typeface="Calibri" pitchFamily="34" charset="-120"/>
-              </a:rPr>
-              <a:t>기준을 고칠 때마다 통과해야 하는 관문</a:t>
-            </a:r>
-            <a:endParaRPr lang="en-US" sz="1400" dirty="0"/>
-          </a:p>
-        </p:txBody>
-      </p:sp>
-      <p:sp>
-        <p:nvSpPr>
-          <p:cNvPr id="20" name="Text 18"/>
-          <p:cNvSpPr txBox="1"/>
-          <p:nvPr/>
-        </p:nvSpPr>
-        <p:spPr>
-          <a:xfrm>
-            <a:off x="6492240" y="2926080"/>
-            <a:ext cx="4572000" cy="1188720"/>
-          </a:xfrm>
-          <a:prstGeom prst="rect">
-            <a:avLst/>
-          </a:prstGeom>
-          <a:noFill/>
-          <a:ln/>
-        </p:spPr>
-        <p:txBody>
-          <a:bodyPr wrap="square" lIns="0" tIns="0" rIns="0" bIns="0" rtlCol="0" anchor="ctr"/>
-          <a:lstStyle/>
-          <a:p>
-            <a:pPr indent="0" marL="0">
-              <a:lnSpc>
-                <a:spcPts val="1700"/>
-              </a:lnSpc>
-              <a:buNone/>
-            </a:pPr>
-            <a:r>
-              <a:rPr lang="en-US" sz="1200" dirty="0">
-                <a:solidFill>
-                  <a:srgbClr val="38445A"/>
-                </a:solidFill>
-                <a:latin typeface="Calibri" pitchFamily="34" charset="0"/>
-                <a:ea typeface="Calibri" pitchFamily="34" charset="-122"/>
-                <a:cs typeface="Calibri" pitchFamily="34" charset="-120"/>
-              </a:rPr>
-              <a:t>수정한 채점 기준으로 그 46편을 다시 채점해 중앙값 92점이 유지되어야 채택하고, 그러지 못하면 폐기합니다.</a:t>
-            </a:r>
-            <a:endParaRPr lang="en-US" sz="1200" dirty="0"/>
-          </a:p>
-          <a:p>
-            <a:pPr indent="0" marL="0">
-              <a:lnSpc>
-                <a:spcPts val="1700"/>
-              </a:lnSpc>
-              <a:buNone/>
-            </a:pPr>
-            <a:endParaRPr lang="en-US" sz="1200" dirty="0"/>
-          </a:p>
-          <a:p>
-            <a:pPr indent="0" marL="0">
-              <a:lnSpc>
-                <a:spcPts val="1700"/>
-              </a:lnSpc>
-              <a:buNone/>
-            </a:pPr>
-            <a:r>
-              <a:rPr lang="en-US" sz="1200" dirty="0">
-                <a:solidFill>
-                  <a:srgbClr val="38445A"/>
-                </a:solidFill>
-                <a:latin typeface="Calibri" pitchFamily="34" charset="0"/>
-                <a:ea typeface="Calibri" pitchFamily="34" charset="-122"/>
-                <a:cs typeface="Calibri" pitchFamily="34" charset="-120"/>
-              </a:rPr>
-              <a:t>실제로 네 차례 폐기하거나 고쳤습니다. 저희 결과에 유리하도록 맞춘 지표가 아니라, 고객사의 글로 검증한 지표라는 뜻입니다.</a:t>
-            </a:r>
-            <a:endParaRPr lang="en-US" sz="1200" dirty="0"/>
-          </a:p>
-        </p:txBody>
-      </p:sp>
-      <p:sp>
-        <p:nvSpPr>
-          <p:cNvPr id="21" name="Shape 19"/>
-          <p:cNvSpPr/>
-          <p:nvPr/>
-        </p:nvSpPr>
-        <p:spPr>
-          <a:xfrm>
-            <a:off x="6217920" y="4370832"/>
-            <a:ext cx="5120640" cy="1463040"/>
-          </a:xfrm>
-          <a:prstGeom prst="roundRect">
-            <a:avLst>
-              <a:gd name="adj" fmla="val 5000"/>
-            </a:avLst>
-          </a:prstGeom>
-          <a:solidFill>
-            <a:srgbClr val="FFFFFF"/>
-          </a:solidFill>
-          <a:ln w="12700">
-            <a:solidFill>
-              <a:srgbClr val="E6E9EF"/>
-            </a:solidFill>
-            <a:prstDash val="solid"/>
-          </a:ln>
-        </p:spPr>
-      </p:sp>
-      <p:sp>
-        <p:nvSpPr>
-          <p:cNvPr id="22" name="Text 20"/>
-          <p:cNvSpPr txBox="1"/>
-          <p:nvPr/>
-        </p:nvSpPr>
-        <p:spPr>
-          <a:xfrm>
-            <a:off x="6492240" y="4535424"/>
-            <a:ext cx="4572000" cy="256032"/>
-          </a:xfrm>
-          <a:prstGeom prst="rect">
-            <a:avLst/>
-          </a:prstGeom>
-          <a:noFill/>
-          <a:ln/>
-        </p:spPr>
-        <p:txBody>
-          <a:bodyPr wrap="square" lIns="0" tIns="0" rIns="0" bIns="0" rtlCol="0" anchor="ctr"/>
-          <a:lstStyle/>
-          <a:p>
-            <a:pPr indent="0" marL="0">
-              <a:buNone/>
-            </a:pPr>
-            <a:r>
-              <a:rPr lang="en-US" sz="1300" b="1" dirty="0">
-                <a:solidFill>
-                  <a:srgbClr val="0B1220"/>
-                </a:solidFill>
-                <a:latin typeface="Calibri" pitchFamily="34" charset="0"/>
-                <a:ea typeface="Calibri" pitchFamily="34" charset="-122"/>
-                <a:cs typeface="Calibri" pitchFamily="34" charset="-120"/>
-              </a:rPr>
-              <a:t>폐기한 지표의 예</a:t>
-            </a:r>
-            <a:endParaRPr lang="en-US" sz="1300" dirty="0"/>
-          </a:p>
-        </p:txBody>
-      </p:sp>
-      <p:sp>
-        <p:nvSpPr>
-          <p:cNvPr id="23" name="Text 21"/>
-          <p:cNvSpPr txBox="1"/>
-          <p:nvPr/>
-        </p:nvSpPr>
-        <p:spPr>
-          <a:xfrm>
-            <a:off x="6492240" y="4846320"/>
-            <a:ext cx="4572000" cy="914400"/>
-          </a:xfrm>
-          <a:prstGeom prst="rect">
-            <a:avLst/>
-          </a:prstGeom>
-          <a:noFill/>
-          <a:ln/>
-        </p:spPr>
-        <p:txBody>
-          <a:bodyPr wrap="square" lIns="0" tIns="0" rIns="0" bIns="0" rtlCol="0" anchor="ctr"/>
-          <a:lstStyle/>
-          <a:p>
-            <a:pPr indent="0" marL="0">
-              <a:lnSpc>
-                <a:spcPts val="1600"/>
-              </a:lnSpc>
-              <a:buNone/>
-            </a:pPr>
-            <a:r>
-              <a:rPr lang="en-US" sz="1150" dirty="0">
-                <a:solidFill>
-                  <a:srgbClr val="6E7A8A"/>
-                </a:solidFill>
-                <a:latin typeface="Calibri" pitchFamily="34" charset="0"/>
-                <a:ea typeface="Calibri" pitchFamily="34" charset="-122"/>
-                <a:cs typeface="Calibri" pitchFamily="34" charset="-120"/>
-              </a:rPr>
-              <a:t>“자사 글은 굵은 글씨를 쓰지 않는다”는 신호로 30점 차이를 만들었지만, 원본을 다시 확인하니 실제로는 1,000자당 9.73회 사용하고 있었습니다. 저희 수집 과정이 만든 착시였고, 그 신호는 폐기했습니다.</a:t>
-            </a:r>
-            <a:endParaRPr lang="en-US" sz="1150" dirty="0"/>
           </a:p>
         </p:txBody>
       </p:sp>
@@ -8205,96 +8115,33 @@
       </p:sp>
       <p:sp>
         <p:nvSpPr>
-          <p:cNvPr id="16" name="Shape 14"/>
-          <p:cNvSpPr/>
-          <p:nvPr/>
-        </p:nvSpPr>
-        <p:spPr>
-          <a:xfrm>
-            <a:off x="777240" y="5029200"/>
-            <a:ext cx="10607040" cy="1005840"/>
-          </a:xfrm>
-          <a:prstGeom prst="roundRect">
-            <a:avLst>
-              <a:gd name="adj" fmla="val 7273"/>
-            </a:avLst>
-          </a:prstGeom>
-          <a:solidFill>
-            <a:srgbClr val="FFFFFF"/>
-          </a:solidFill>
-          <a:ln w="12700">
-            <a:solidFill>
-              <a:srgbClr val="1A61EA"/>
-            </a:solidFill>
-            <a:prstDash val="solid"/>
-          </a:ln>
-        </p:spPr>
-      </p:sp>
-      <p:sp>
-        <p:nvSpPr>
-          <p:cNvPr id="17" name="Text 15"/>
-          <p:cNvSpPr txBox="1"/>
-          <p:nvPr/>
-        </p:nvSpPr>
-        <p:spPr>
-          <a:xfrm>
-            <a:off x="1143000" y="5193792"/>
-            <a:ext cx="4572000" cy="274320"/>
-          </a:xfrm>
-          <a:prstGeom prst="rect">
-            <a:avLst/>
-          </a:prstGeom>
-          <a:noFill/>
-          <a:ln/>
-        </p:spPr>
-        <p:txBody>
-          <a:bodyPr wrap="square" lIns="0" tIns="0" rIns="0" bIns="0" rtlCol="0" anchor="ctr"/>
-          <a:lstStyle/>
-          <a:p>
-            <a:pPr indent="0" marL="0">
-              <a:buNone/>
-            </a:pPr>
-            <a:r>
-              <a:rPr lang="en-US" sz="1400" b="1" dirty="0">
-                <a:solidFill>
-                  <a:srgbClr val="1A61EA"/>
-                </a:solidFill>
-                <a:latin typeface="Calibri" pitchFamily="34" charset="0"/>
-                <a:ea typeface="Calibri" pitchFamily="34" charset="-122"/>
-                <a:cs typeface="Calibri" pitchFamily="34" charset="-120"/>
-              </a:rPr>
-              <a:t>내일부터 쓰려면 필요한 것</a:t>
-            </a:r>
-            <a:endParaRPr lang="en-US" sz="1400" dirty="0"/>
-          </a:p>
-        </p:txBody>
-      </p:sp>
-      <p:sp>
-        <p:nvSpPr>
-          <p:cNvPr id="18" name="Text 16"/>
-          <p:cNvSpPr txBox="1"/>
-          <p:nvPr/>
-        </p:nvSpPr>
-        <p:spPr>
-          <a:xfrm>
-            <a:off x="1143000" y="5504688"/>
-            <a:ext cx="9875520" cy="365760"/>
-          </a:xfrm>
-          <a:prstGeom prst="rect">
-            <a:avLst/>
-          </a:prstGeom>
-          <a:noFill/>
-          <a:ln/>
-        </p:spPr>
-        <p:txBody>
-          <a:bodyPr wrap="square" lIns="0" tIns="0" rIns="0" bIns="0" rtlCol="0" anchor="ctr"/>
-          <a:lstStyle/>
-          <a:p>
-            <a:pPr indent="0" marL="0">
-              <a:buNone/>
-            </a:pPr>
-            <a:r>
-              <a:rPr lang="en-US" sz="1250" dirty="0">
+          <p:cNvPr id="16" name="Text 14"/>
+          <p:cNvSpPr txBox="1"/>
+          <p:nvPr/>
+        </p:nvSpPr>
+        <p:spPr>
+          <a:xfrm>
+            <a:off x="777240" y="5120640"/>
+            <a:ext cx="10424160" cy="548640"/>
+          </a:xfrm>
+          <a:prstGeom prst="rect">
+            <a:avLst/>
+          </a:prstGeom>
+          <a:noFill/>
+          <a:ln/>
+        </p:spPr>
+        <p:txBody>
+          <a:bodyPr wrap="square" lIns="0" tIns="0" rIns="0" bIns="0" rtlCol="0" anchor="ctr"/>
+          <a:lstStyle/>
+          <a:p>
+            <a:pPr indent="0" marL="0">
+              <a:lnSpc>
+                <a:spcPts val="2000"/>
+              </a:lnSpc>
+              <a:buNone/>
+            </a:pPr>
+            <a:r>
+              <a:rPr lang="en-US" sz="1300" dirty="0">
                 <a:solidFill>
                   <a:srgbClr val="38445A"/>
                 </a:solidFill>
@@ -8302,9 +8149,9 @@
                 <a:ea typeface="Calibri" pitchFamily="34" charset="-122"/>
                 <a:cs typeface="Calibri" pitchFamily="34" charset="-120"/>
               </a:rPr>
-              <a:t>문의 폼에 유입 경로 파라미터 한 줄 · 승인자 계정 등록 · 링크드인 토큰 연결 — 스키마와 되먹임 구조는 그대로 갑니다.</a:t>
-            </a:r>
-            <a:endParaRPr lang="en-US" sz="1250" dirty="0"/>
+              <a:t>링크드인 실제 발행만 못 했습니다. 조직 페이지 발행에는 별도 승인이 필요한데, 저희가 받은 실데이터의 출처가 바로 그 API입니다 — 코드프레소는 이미 권한을 갖고 있습니다.</a:t>
+            </a:r>
+            <a:endParaRPr lang="en-US" sz="1300" dirty="0"/>
           </a:p>
         </p:txBody>
       </p:sp>

</xml_diff>

<commit_message>
docs(deck): reorder for final 8-slide flow with two Q&A backup slides; surface judgment log on the gate slide
</commit_message>
<xml_diff>
--- a/aidlc-docs/deliverables/발표덱.pptx
+++ b/aidlc-docs/deliverables/발표덱.pptx
@@ -599,7 +599,7 @@
           <a:p>
             <a:r>
               <a:rPr lang="en-US" dirty="0"/>
-              <a:t>Q&amp;A로 넘어갑니다.</a:t>
+              <a:t>30초. 마지막 문단을 스스로 말하는 것이 중요합니다. 질문으로 나오기 전에 먼저 꺼냅니다.</a:t>
             </a:r>
             <a:endParaRPr lang="en-US" dirty="0"/>
           </a:p>
@@ -1039,7 +1039,7 @@
           <a:p>
             <a:r>
               <a:rPr lang="en-US" dirty="0"/>
-              <a:t>45초. 두 글을 소리 내어 비교하지 말고, 왼쪽 첫 문장과 오른쪽 첫 문장만 읽습니다. 아래 네 칸이 근거입니다.</a:t>
+              <a:t>35초. 왼쪽은 '어느 회사 블로그에 놔도 어색하지 않은 글' — 담당자가 지적한 문제 상태입니다. 오른쪽은 코드프레소만 쓸 수 있는 글이라고 말합니다. 절대 반대로 말하지 않도록 주의합니다.</a:t>
             </a:r>
             <a:endParaRPr lang="en-US" dirty="0"/>
           </a:p>
@@ -1127,7 +1127,7 @@
           <a:p>
             <a:r>
               <a:rPr lang="en-US" dirty="0"/>
-              <a:t>20초. 상단 기준값은 읽지 않고 관문 한 문장만 말합니다. 폐기 사례는 Q&amp;A용입니다.</a:t>
+              <a:t>15초. 하지 않은 것을 먼저 말하고 링크드인 사유 한 줄로 닫습니다.</a:t>
             </a:r>
             <a:endParaRPr lang="en-US" dirty="0"/>
           </a:p>
@@ -1215,7 +1215,7 @@
           <a:p>
             <a:r>
               <a:rPr lang="en-US" dirty="0"/>
-              <a:t>30초. 마지막 문단을 스스로 말하는 것이 중요합니다. 질문으로 나오기 전에 먼저 꺼냅니다.</a:t>
+              <a:t>Q&amp;A로 넘어갑니다.</a:t>
             </a:r>
             <a:endParaRPr lang="en-US" dirty="0"/>
           </a:p>
@@ -1303,7 +1303,7 @@
           <a:p>
             <a:r>
               <a:rPr lang="en-US" dirty="0"/>
-              <a:t>15초. 하지 않은 것을 먼저 말하고 링크드인 사유 한 줄로 닫습니다.</a:t>
+              <a:t>20초. 상단 기준값은 읽지 않고 관문 한 문장만 말합니다. 폐기 사례는 Q&amp;A용입니다.</a:t>
             </a:r>
             <a:endParaRPr lang="en-US" dirty="0"/>
           </a:p>
@@ -1886,6 +1886,13 @@
 <file path=ppt/slides/slide10.xml><?xml version="1.0" encoding="utf-8"?>
 <p:sld xmlns:a="http://schemas.openxmlformats.org/drawingml/2006/main" xmlns:r="http://schemas.openxmlformats.org/officeDocument/2006/relationships" xmlns:p="http://schemas.openxmlformats.org/presentationml/2006/main">
   <p:cSld name="Slide 10">
+    <p:bg>
+      <p:bgPr>
+        <a:solidFill>
+          <a:srgbClr val="F5F6F8"/>
+        </a:solidFill>
+      </p:bgPr>
+    </p:bg>
     <p:spTree>
       <p:nvGrpSpPr>
         <p:cNvPr id="1" name=""/>
@@ -1902,20 +1909,125 @@
       </p:grpSpPr>
       <p:sp>
         <p:nvSpPr>
-          <p:cNvPr id="2" name="Shape 0"/>
+          <p:cNvPr id="2" name="Text 0"/>
+          <p:cNvSpPr txBox="1"/>
+          <p:nvPr/>
+        </p:nvSpPr>
+        <p:spPr>
+          <a:xfrm>
+            <a:off x="777240" y="384048"/>
+            <a:ext cx="7315200" cy="237744"/>
+          </a:xfrm>
+          <a:prstGeom prst="rect">
+            <a:avLst/>
+          </a:prstGeom>
+          <a:noFill/>
+          <a:ln/>
+        </p:spPr>
+        <p:txBody>
+          <a:bodyPr wrap="square" lIns="0" tIns="0" rIns="0" bIns="0" rtlCol="0" anchor="ctr"/>
+          <a:lstStyle/>
+          <a:p>
+            <a:pPr indent="0" marL="0">
+              <a:buNone/>
+            </a:pPr>
+            <a:r>
+              <a:rPr lang="en-US" sz="1100" b="1" spc="200" kern="0" dirty="0">
+                <a:solidFill>
+                  <a:srgbClr val="1A61EA"/>
+                </a:solidFill>
+                <a:latin typeface="Calibri" pitchFamily="34" charset="0"/>
+                <a:ea typeface="Calibri" pitchFamily="34" charset="-122"/>
+                <a:cs typeface="Calibri" pitchFamily="34" charset="-120"/>
+              </a:rPr>
+              <a:t>참고 자료 · Q&amp;A용</a:t>
+            </a:r>
+            <a:endParaRPr lang="en-US" sz="1100" dirty="0"/>
+          </a:p>
+        </p:txBody>
+      </p:sp>
+      <p:sp>
+        <p:nvSpPr>
+          <p:cNvPr id="3" name="Text 1"/>
+          <p:cNvSpPr txBox="1"/>
+          <p:nvPr/>
+        </p:nvSpPr>
+        <p:spPr>
+          <a:xfrm>
+            <a:off x="777240" y="658368"/>
+            <a:ext cx="10607040" cy="566928"/>
+          </a:xfrm>
+          <a:prstGeom prst="rect">
+            <a:avLst/>
+          </a:prstGeom>
+          <a:noFill/>
+          <a:ln/>
+        </p:spPr>
+        <p:txBody>
+          <a:bodyPr wrap="square" lIns="0" tIns="0" rIns="0" bIns="0" rtlCol="0" anchor="ctr"/>
+          <a:lstStyle/>
+          <a:p>
+            <a:pPr indent="0" marL="0">
+              <a:buNone/>
+            </a:pPr>
+            <a:r>
+              <a:rPr lang="en-US" sz="3000" b="1" dirty="0">
+                <a:solidFill>
+                  <a:srgbClr val="0B1220"/>
+                </a:solidFill>
+                <a:latin typeface="Calibri" pitchFamily="34" charset="0"/>
+                <a:ea typeface="Calibri" pitchFamily="34" charset="-122"/>
+                <a:cs typeface="Calibri" pitchFamily="34" charset="-120"/>
+              </a:rPr>
+              <a:t>결과를 믿을 수 있는 근거</a:t>
+            </a:r>
+            <a:endParaRPr lang="en-US" sz="3000" dirty="0"/>
+          </a:p>
+        </p:txBody>
+      </p:sp>
+      <p:sp>
+        <p:nvSpPr>
+          <p:cNvPr id="4" name="Shape 2"/>
           <p:cNvSpPr/>
           <p:nvPr/>
         </p:nvSpPr>
         <p:spPr>
           <a:xfrm>
-            <a:off x="0" y="0"/>
-            <a:ext cx="12161520" cy="6858000"/>
-          </a:xfrm>
-          <a:prstGeom prst="rect">
-            <a:avLst/>
+            <a:off x="777240" y="1783080"/>
+            <a:ext cx="5120640" cy="1234440"/>
+          </a:xfrm>
+          <a:prstGeom prst="roundRect">
+            <a:avLst>
+              <a:gd name="adj" fmla="val 5926"/>
+            </a:avLst>
           </a:prstGeom>
           <a:solidFill>
-            <a:srgbClr val="0B1220"/>
+            <a:srgbClr val="FFFFFF"/>
+          </a:solidFill>
+          <a:ln w="12700">
+            <a:solidFill>
+              <a:srgbClr val="E6E9EF"/>
+            </a:solidFill>
+            <a:prstDash val="solid"/>
+          </a:ln>
+        </p:spPr>
+      </p:sp>
+      <p:sp>
+        <p:nvSpPr>
+          <p:cNvPr id="5" name="Shape 3"/>
+          <p:cNvSpPr/>
+          <p:nvPr/>
+        </p:nvSpPr>
+        <p:spPr>
+          <a:xfrm>
+            <a:off x="1051560" y="2057400"/>
+            <a:ext cx="310896" cy="310896"/>
+          </a:xfrm>
+          <a:prstGeom prst="ellipse">
+            <a:avLst/>
+          </a:prstGeom>
+          <a:solidFill>
+            <a:srgbClr val="E7EEFD"/>
           </a:solidFill>
           <a:ln w="12700">
             <a:solidFill>
@@ -1927,98 +2039,167 @@
       </p:sp>
       <p:sp>
         <p:nvSpPr>
-          <p:cNvPr id="3" name="Text 1"/>
-          <p:cNvSpPr txBox="1"/>
-          <p:nvPr/>
-        </p:nvSpPr>
-        <p:spPr>
-          <a:xfrm>
-            <a:off x="777240" y="2651760"/>
-            <a:ext cx="10058400" cy="731520"/>
-          </a:xfrm>
-          <a:prstGeom prst="rect">
-            <a:avLst/>
-          </a:prstGeom>
-          <a:noFill/>
-          <a:ln/>
-        </p:spPr>
-        <p:txBody>
-          <a:bodyPr wrap="square" lIns="0" tIns="0" rIns="0" bIns="0" rtlCol="0" anchor="ctr"/>
-          <a:lstStyle/>
-          <a:p>
-            <a:pPr indent="0" marL="0">
-              <a:buNone/>
-            </a:pPr>
-            <a:r>
-              <a:rPr lang="en-US" sz="4000" b="1" dirty="0">
-                <a:solidFill>
-                  <a:srgbClr val="FFFFFF"/>
-                </a:solidFill>
-                <a:latin typeface="Calibri" pitchFamily="34" charset="0"/>
-                <a:ea typeface="Calibri" pitchFamily="34" charset="-122"/>
-                <a:cs typeface="Calibri" pitchFamily="34" charset="-120"/>
-              </a:rPr>
-              <a:t>감사합니다</a:t>
-            </a:r>
-            <a:endParaRPr lang="en-US" sz="4000" dirty="0"/>
-          </a:p>
-        </p:txBody>
-      </p:sp>
-      <p:sp>
-        <p:nvSpPr>
-          <p:cNvPr id="4" name="Text 2"/>
-          <p:cNvSpPr txBox="1"/>
-          <p:nvPr/>
-        </p:nvSpPr>
-        <p:spPr>
-          <a:xfrm>
-            <a:off x="777240" y="3520440"/>
-            <a:ext cx="10058400" cy="411480"/>
-          </a:xfrm>
-          <a:prstGeom prst="rect">
-            <a:avLst/>
-          </a:prstGeom>
-          <a:noFill/>
-          <a:ln/>
-        </p:spPr>
-        <p:txBody>
-          <a:bodyPr wrap="square" lIns="0" tIns="0" rIns="0" bIns="0" rtlCol="0" anchor="ctr"/>
-          <a:lstStyle/>
-          <a:p>
-            <a:pPr indent="0" marL="0">
-              <a:buNone/>
-            </a:pPr>
-            <a:r>
-              <a:rPr lang="en-US" sz="1700" dirty="0">
-                <a:solidFill>
-                  <a:srgbClr val="C7D4EA"/>
-                </a:solidFill>
-                <a:latin typeface="Calibri" pitchFamily="34" charset="0"/>
-                <a:ea typeface="Calibri" pitchFamily="34" charset="-122"/>
-                <a:cs typeface="Calibri" pitchFamily="34" charset="-120"/>
-              </a:rPr>
-              <a:t>여덟 단계를 자동화한 것이 아니라, 판단이 쌓이는 회로를 만들었습니다.</a:t>
-            </a:r>
-            <a:endParaRPr lang="en-US" sz="1700" dirty="0"/>
-          </a:p>
-        </p:txBody>
-      </p:sp>
-      <p:sp>
-        <p:nvSpPr>
-          <p:cNvPr id="5" name="Shape 3"/>
+          <p:cNvPr id="6" name="Text 4"/>
+          <p:cNvSpPr txBox="1"/>
+          <p:nvPr/>
+        </p:nvSpPr>
+        <p:spPr>
+          <a:xfrm>
+            <a:off x="1051560" y="2093976"/>
+            <a:ext cx="310896" cy="237744"/>
+          </a:xfrm>
+          <a:prstGeom prst="rect">
+            <a:avLst/>
+          </a:prstGeom>
+          <a:noFill/>
+          <a:ln/>
+        </p:spPr>
+        <p:txBody>
+          <a:bodyPr wrap="square" lIns="0" tIns="0" rIns="0" bIns="0" rtlCol="0" anchor="ctr"/>
+          <a:lstStyle/>
+          <a:p>
+            <a:pPr algn="ctr" indent="0" marL="0">
+              <a:buNone/>
+            </a:pPr>
+            <a:r>
+              <a:rPr lang="en-US" sz="1200" b="1" dirty="0">
+                <a:solidFill>
+                  <a:srgbClr val="1A61EA"/>
+                </a:solidFill>
+                <a:latin typeface="Calibri" pitchFamily="34" charset="0"/>
+                <a:ea typeface="Calibri" pitchFamily="34" charset="-122"/>
+                <a:cs typeface="Calibri" pitchFamily="34" charset="-120"/>
+              </a:rPr>
+              <a:t>1</a:t>
+            </a:r>
+            <a:endParaRPr lang="en-US" sz="1200" dirty="0"/>
+          </a:p>
+        </p:txBody>
+      </p:sp>
+      <p:sp>
+        <p:nvSpPr>
+          <p:cNvPr id="7" name="Text 5"/>
+          <p:cNvSpPr txBox="1"/>
+          <p:nvPr/>
+        </p:nvSpPr>
+        <p:spPr>
+          <a:xfrm>
+            <a:off x="1490472" y="2039112"/>
+            <a:ext cx="4114800" cy="274320"/>
+          </a:xfrm>
+          <a:prstGeom prst="rect">
+            <a:avLst/>
+          </a:prstGeom>
+          <a:noFill/>
+          <a:ln/>
+        </p:spPr>
+        <p:txBody>
+          <a:bodyPr wrap="square" lIns="0" tIns="0" rIns="0" bIns="0" rtlCol="0" anchor="ctr"/>
+          <a:lstStyle/>
+          <a:p>
+            <a:pPr indent="0" marL="0">
+              <a:buNone/>
+            </a:pPr>
+            <a:r>
+              <a:rPr lang="en-US" sz="1450" b="1" dirty="0">
+                <a:solidFill>
+                  <a:srgbClr val="0B1220"/>
+                </a:solidFill>
+                <a:latin typeface="Calibri" pitchFamily="34" charset="0"/>
+                <a:ea typeface="Calibri" pitchFamily="34" charset="-122"/>
+                <a:cs typeface="Calibri" pitchFamily="34" charset="-120"/>
+              </a:rPr>
+              <a:t>승인 게이트</a:t>
+            </a:r>
+            <a:endParaRPr lang="en-US" sz="1450" dirty="0"/>
+          </a:p>
+        </p:txBody>
+      </p:sp>
+      <p:sp>
+        <p:nvSpPr>
+          <p:cNvPr id="8" name="Text 6"/>
+          <p:cNvSpPr txBox="1"/>
+          <p:nvPr/>
+        </p:nvSpPr>
+        <p:spPr>
+          <a:xfrm>
+            <a:off x="1490472" y="2350008"/>
+            <a:ext cx="4114800" cy="548640"/>
+          </a:xfrm>
+          <a:prstGeom prst="rect">
+            <a:avLst/>
+          </a:prstGeom>
+          <a:noFill/>
+          <a:ln/>
+        </p:spPr>
+        <p:txBody>
+          <a:bodyPr wrap="square" lIns="0" tIns="0" rIns="0" bIns="0" rtlCol="0" anchor="ctr"/>
+          <a:lstStyle/>
+          <a:p>
+            <a:pPr indent="0" marL="0">
+              <a:lnSpc>
+                <a:spcPts val="1700"/>
+              </a:lnSpc>
+              <a:buNone/>
+            </a:pPr>
+            <a:r>
+              <a:rPr lang="en-US" sz="1200" dirty="0">
+                <a:solidFill>
+                  <a:srgbClr val="6E7A8A"/>
+                </a:solidFill>
+                <a:latin typeface="Calibri" pitchFamily="34" charset="0"/>
+                <a:ea typeface="Calibri" pitchFamily="34" charset="-122"/>
+                <a:cs typeface="Calibri" pitchFamily="34" charset="-120"/>
+              </a:rPr>
+              <a:t>사람의 결정 없이는 발행되지 않습니다. 반려에는 사유 입력이 필수입니다.</a:t>
+            </a:r>
+            <a:endParaRPr lang="en-US" sz="1200" dirty="0"/>
+          </a:p>
+        </p:txBody>
+      </p:sp>
+      <p:sp>
+        <p:nvSpPr>
+          <p:cNvPr id="9" name="Shape 7"/>
           <p:cNvSpPr/>
           <p:nvPr/>
         </p:nvSpPr>
         <p:spPr>
           <a:xfrm>
-            <a:off x="777240" y="4206240"/>
-            <a:ext cx="1005840" cy="32004"/>
-          </a:xfrm>
-          <a:prstGeom prst="rect">
-            <a:avLst/>
+            <a:off x="6172200" y="1783080"/>
+            <a:ext cx="5120640" cy="1234440"/>
+          </a:xfrm>
+          <a:prstGeom prst="roundRect">
+            <a:avLst>
+              <a:gd name="adj" fmla="val 5926"/>
+            </a:avLst>
           </a:prstGeom>
           <a:solidFill>
-            <a:srgbClr val="1A61EA"/>
+            <a:srgbClr val="FFFFFF"/>
+          </a:solidFill>
+          <a:ln w="12700">
+            <a:solidFill>
+              <a:srgbClr val="E6E9EF"/>
+            </a:solidFill>
+            <a:prstDash val="solid"/>
+          </a:ln>
+        </p:spPr>
+      </p:sp>
+      <p:sp>
+        <p:nvSpPr>
+          <p:cNvPr id="10" name="Shape 8"/>
+          <p:cNvSpPr/>
+          <p:nvPr/>
+        </p:nvSpPr>
+        <p:spPr>
+          <a:xfrm>
+            <a:off x="6446520" y="2057400"/>
+            <a:ext cx="310896" cy="310896"/>
+          </a:xfrm>
+          <a:prstGeom prst="ellipse">
+            <a:avLst/>
+          </a:prstGeom>
+          <a:solidFill>
+            <a:srgbClr val="E7EEFD"/>
           </a:solidFill>
           <a:ln w="12700">
             <a:solidFill>
@@ -2030,77 +2211,532 @@
       </p:sp>
       <p:sp>
         <p:nvSpPr>
-          <p:cNvPr id="6" name="Text 4"/>
-          <p:cNvSpPr txBox="1"/>
-          <p:nvPr/>
-        </p:nvSpPr>
-        <p:spPr>
-          <a:xfrm>
-            <a:off x="777240" y="4407408"/>
-            <a:ext cx="10058400" cy="274320"/>
-          </a:xfrm>
-          <a:prstGeom prst="rect">
-            <a:avLst/>
-          </a:prstGeom>
-          <a:noFill/>
-          <a:ln/>
-        </p:spPr>
-        <p:txBody>
-          <a:bodyPr wrap="square" lIns="0" tIns="0" rIns="0" bIns="0" rtlCol="0" anchor="ctr"/>
-          <a:lstStyle/>
-          <a:p>
-            <a:pPr indent="0" marL="0">
-              <a:buNone/>
-            </a:pPr>
-            <a:r>
-              <a:rPr lang="en-US" sz="1350" dirty="0">
-                <a:solidFill>
-                  <a:srgbClr val="8FA3C4"/>
-                </a:solidFill>
-                <a:latin typeface="Calibri" pitchFamily="34" charset="0"/>
-                <a:ea typeface="Calibri" pitchFamily="34" charset="-122"/>
-                <a:cs typeface="Calibri" pitchFamily="34" charset="-120"/>
-              </a:rPr>
-              <a:t>도입에 필요한 것 — 문의 폼에 유입 경로 파라미터 한 줄, 승인자 계정 등록, 링크드인 토큰 연결</a:t>
-            </a:r>
-            <a:endParaRPr lang="en-US" sz="1350" dirty="0"/>
-          </a:p>
-        </p:txBody>
-      </p:sp>
-      <p:sp>
-        <p:nvSpPr>
-          <p:cNvPr id="7" name="Text 5"/>
-          <p:cNvSpPr txBox="1"/>
-          <p:nvPr/>
-        </p:nvSpPr>
-        <p:spPr>
-          <a:xfrm>
-            <a:off x="777240" y="4754880"/>
-            <a:ext cx="7315200" cy="274320"/>
-          </a:xfrm>
-          <a:prstGeom prst="rect">
-            <a:avLst/>
-          </a:prstGeom>
-          <a:noFill/>
-          <a:ln/>
-        </p:spPr>
-        <p:txBody>
-          <a:bodyPr wrap="square" lIns="0" tIns="0" rIns="0" bIns="0" rtlCol="0" anchor="ctr"/>
-          <a:lstStyle/>
-          <a:p>
-            <a:pPr indent="0" marL="0">
+          <p:cNvPr id="11" name="Text 9"/>
+          <p:cNvSpPr txBox="1"/>
+          <p:nvPr/>
+        </p:nvSpPr>
+        <p:spPr>
+          <a:xfrm>
+            <a:off x="6446520" y="2093976"/>
+            <a:ext cx="310896" cy="237744"/>
+          </a:xfrm>
+          <a:prstGeom prst="rect">
+            <a:avLst/>
+          </a:prstGeom>
+          <a:noFill/>
+          <a:ln/>
+        </p:spPr>
+        <p:txBody>
+          <a:bodyPr wrap="square" lIns="0" tIns="0" rIns="0" bIns="0" rtlCol="0" anchor="ctr"/>
+          <a:lstStyle/>
+          <a:p>
+            <a:pPr algn="ctr" indent="0" marL="0">
+              <a:buNone/>
+            </a:pPr>
+            <a:r>
+              <a:rPr lang="en-US" sz="1200" b="1" dirty="0">
+                <a:solidFill>
+                  <a:srgbClr val="1A61EA"/>
+                </a:solidFill>
+                <a:latin typeface="Calibri" pitchFamily="34" charset="0"/>
+                <a:ea typeface="Calibri" pitchFamily="34" charset="-122"/>
+                <a:cs typeface="Calibri" pitchFamily="34" charset="-120"/>
+              </a:rPr>
+              <a:t>2</a:t>
+            </a:r>
+            <a:endParaRPr lang="en-US" sz="1200" dirty="0"/>
+          </a:p>
+        </p:txBody>
+      </p:sp>
+      <p:sp>
+        <p:nvSpPr>
+          <p:cNvPr id="12" name="Text 10"/>
+          <p:cNvSpPr txBox="1"/>
+          <p:nvPr/>
+        </p:nvSpPr>
+        <p:spPr>
+          <a:xfrm>
+            <a:off x="6885432" y="2039112"/>
+            <a:ext cx="4114800" cy="274320"/>
+          </a:xfrm>
+          <a:prstGeom prst="rect">
+            <a:avLst/>
+          </a:prstGeom>
+          <a:noFill/>
+          <a:ln/>
+        </p:spPr>
+        <p:txBody>
+          <a:bodyPr wrap="square" lIns="0" tIns="0" rIns="0" bIns="0" rtlCol="0" anchor="ctr"/>
+          <a:lstStyle/>
+          <a:p>
+            <a:pPr indent="0" marL="0">
+              <a:buNone/>
+            </a:pPr>
+            <a:r>
+              <a:rPr lang="en-US" sz="1450" b="1" dirty="0">
+                <a:solidFill>
+                  <a:srgbClr val="0B1220"/>
+                </a:solidFill>
+                <a:latin typeface="Calibri" pitchFamily="34" charset="0"/>
+                <a:ea typeface="Calibri" pitchFamily="34" charset="-122"/>
+                <a:cs typeface="Calibri" pitchFamily="34" charset="-120"/>
+              </a:rPr>
+              <a:t>판단 로그</a:t>
+            </a:r>
+            <a:endParaRPr lang="en-US" sz="1450" dirty="0"/>
+          </a:p>
+        </p:txBody>
+      </p:sp>
+      <p:sp>
+        <p:nvSpPr>
+          <p:cNvPr id="13" name="Text 11"/>
+          <p:cNvSpPr txBox="1"/>
+          <p:nvPr/>
+        </p:nvSpPr>
+        <p:spPr>
+          <a:xfrm>
+            <a:off x="6885432" y="2350008"/>
+            <a:ext cx="4114800" cy="548640"/>
+          </a:xfrm>
+          <a:prstGeom prst="rect">
+            <a:avLst/>
+          </a:prstGeom>
+          <a:noFill/>
+          <a:ln/>
+        </p:spPr>
+        <p:txBody>
+          <a:bodyPr wrap="square" lIns="0" tIns="0" rIns="0" bIns="0" rtlCol="0" anchor="ctr"/>
+          <a:lstStyle/>
+          <a:p>
+            <a:pPr indent="0" marL="0">
+              <a:lnSpc>
+                <a:spcPts val="1700"/>
+              </a:lnSpc>
+              <a:buNone/>
+            </a:pPr>
+            <a:r>
+              <a:rPr lang="en-US" sz="1200" dirty="0">
+                <a:solidFill>
+                  <a:srgbClr val="6E7A8A"/>
+                </a:solidFill>
+                <a:latin typeface="Calibri" pitchFamily="34" charset="0"/>
+                <a:ea typeface="Calibri" pitchFamily="34" charset="-122"/>
+                <a:cs typeface="Calibri" pitchFamily="34" charset="-120"/>
+              </a:rPr>
+              <a:t>모든 결정이 누가·언제·왜와 함께 남고, 사람의 결정과 시스템의 실행이 구분됩니다.</a:t>
+            </a:r>
+            <a:endParaRPr lang="en-US" sz="1200" dirty="0"/>
+          </a:p>
+        </p:txBody>
+      </p:sp>
+      <p:sp>
+        <p:nvSpPr>
+          <p:cNvPr id="14" name="Shape 12"/>
+          <p:cNvSpPr/>
+          <p:nvPr/>
+        </p:nvSpPr>
+        <p:spPr>
+          <a:xfrm>
+            <a:off x="777240" y="3246120"/>
+            <a:ext cx="5120640" cy="1234440"/>
+          </a:xfrm>
+          <a:prstGeom prst="roundRect">
+            <a:avLst>
+              <a:gd name="adj" fmla="val 5926"/>
+            </a:avLst>
+          </a:prstGeom>
+          <a:solidFill>
+            <a:srgbClr val="FFFFFF"/>
+          </a:solidFill>
+          <a:ln w="12700">
+            <a:solidFill>
+              <a:srgbClr val="E6E9EF"/>
+            </a:solidFill>
+            <a:prstDash val="solid"/>
+          </a:ln>
+        </p:spPr>
+      </p:sp>
+      <p:sp>
+        <p:nvSpPr>
+          <p:cNvPr id="15" name="Shape 13"/>
+          <p:cNvSpPr/>
+          <p:nvPr/>
+        </p:nvSpPr>
+        <p:spPr>
+          <a:xfrm>
+            <a:off x="1051560" y="3520440"/>
+            <a:ext cx="310896" cy="310896"/>
+          </a:xfrm>
+          <a:prstGeom prst="ellipse">
+            <a:avLst/>
+          </a:prstGeom>
+          <a:solidFill>
+            <a:srgbClr val="E7EEFD"/>
+          </a:solidFill>
+          <a:ln w="12700">
+            <a:solidFill>
+              <a:srgbClr val="333333"/>
+            </a:solidFill>
+            <a:prstDash val="solid"/>
+          </a:ln>
+        </p:spPr>
+      </p:sp>
+      <p:sp>
+        <p:nvSpPr>
+          <p:cNvPr id="16" name="Text 14"/>
+          <p:cNvSpPr txBox="1"/>
+          <p:nvPr/>
+        </p:nvSpPr>
+        <p:spPr>
+          <a:xfrm>
+            <a:off x="1051560" y="3557016"/>
+            <a:ext cx="310896" cy="237744"/>
+          </a:xfrm>
+          <a:prstGeom prst="rect">
+            <a:avLst/>
+          </a:prstGeom>
+          <a:noFill/>
+          <a:ln/>
+        </p:spPr>
+        <p:txBody>
+          <a:bodyPr wrap="square" lIns="0" tIns="0" rIns="0" bIns="0" rtlCol="0" anchor="ctr"/>
+          <a:lstStyle/>
+          <a:p>
+            <a:pPr algn="ctr" indent="0" marL="0">
+              <a:buNone/>
+            </a:pPr>
+            <a:r>
+              <a:rPr lang="en-US" sz="1200" b="1" dirty="0">
+                <a:solidFill>
+                  <a:srgbClr val="1A61EA"/>
+                </a:solidFill>
+                <a:latin typeface="Calibri" pitchFamily="34" charset="0"/>
+                <a:ea typeface="Calibri" pitchFamily="34" charset="-122"/>
+                <a:cs typeface="Calibri" pitchFamily="34" charset="-120"/>
+              </a:rPr>
+              <a:t>3</a:t>
+            </a:r>
+            <a:endParaRPr lang="en-US" sz="1200" dirty="0"/>
+          </a:p>
+        </p:txBody>
+      </p:sp>
+      <p:sp>
+        <p:nvSpPr>
+          <p:cNvPr id="17" name="Text 15"/>
+          <p:cNvSpPr txBox="1"/>
+          <p:nvPr/>
+        </p:nvSpPr>
+        <p:spPr>
+          <a:xfrm>
+            <a:off x="1490472" y="3502152"/>
+            <a:ext cx="4114800" cy="274320"/>
+          </a:xfrm>
+          <a:prstGeom prst="rect">
+            <a:avLst/>
+          </a:prstGeom>
+          <a:noFill/>
+          <a:ln/>
+        </p:spPr>
+        <p:txBody>
+          <a:bodyPr wrap="square" lIns="0" tIns="0" rIns="0" bIns="0" rtlCol="0" anchor="ctr"/>
+          <a:lstStyle/>
+          <a:p>
+            <a:pPr indent="0" marL="0">
+              <a:buNone/>
+            </a:pPr>
+            <a:r>
+              <a:rPr lang="en-US" sz="1450" b="1" dirty="0">
+                <a:solidFill>
+                  <a:srgbClr val="0B1220"/>
+                </a:solidFill>
+                <a:latin typeface="Calibri" pitchFamily="34" charset="0"/>
+                <a:ea typeface="Calibri" pitchFamily="34" charset="-122"/>
+                <a:cs typeface="Calibri" pitchFamily="34" charset="-120"/>
+              </a:rPr>
+              <a:t>추적성</a:t>
+            </a:r>
+            <a:endParaRPr lang="en-US" sz="1450" dirty="0"/>
+          </a:p>
+        </p:txBody>
+      </p:sp>
+      <p:sp>
+        <p:nvSpPr>
+          <p:cNvPr id="18" name="Text 16"/>
+          <p:cNvSpPr txBox="1"/>
+          <p:nvPr/>
+        </p:nvSpPr>
+        <p:spPr>
+          <a:xfrm>
+            <a:off x="1490472" y="3813048"/>
+            <a:ext cx="4114800" cy="548640"/>
+          </a:xfrm>
+          <a:prstGeom prst="rect">
+            <a:avLst/>
+          </a:prstGeom>
+          <a:noFill/>
+          <a:ln/>
+        </p:spPr>
+        <p:txBody>
+          <a:bodyPr wrap="square" lIns="0" tIns="0" rIns="0" bIns="0" rtlCol="0" anchor="ctr"/>
+          <a:lstStyle/>
+          <a:p>
+            <a:pPr indent="0" marL="0">
+              <a:lnSpc>
+                <a:spcPts val="1700"/>
+              </a:lnSpc>
+              <a:buNone/>
+            </a:pPr>
+            <a:r>
+              <a:rPr lang="en-US" sz="1200" dirty="0">
+                <a:solidFill>
+                  <a:srgbClr val="6E7A8A"/>
+                </a:solidFill>
+                <a:latin typeface="Calibri" pitchFamily="34" charset="0"/>
+                <a:ea typeface="Calibri" pitchFamily="34" charset="-122"/>
+                <a:cs typeface="Calibri" pitchFamily="34" charset="-120"/>
+              </a:rPr>
+              <a:t>추천 → 콘텐츠 → 발행 → 문의가 하나의 식별자로 이어집니다.</a:t>
+            </a:r>
+            <a:endParaRPr lang="en-US" sz="1200" dirty="0"/>
+          </a:p>
+        </p:txBody>
+      </p:sp>
+      <p:sp>
+        <p:nvSpPr>
+          <p:cNvPr id="19" name="Shape 17"/>
+          <p:cNvSpPr/>
+          <p:nvPr/>
+        </p:nvSpPr>
+        <p:spPr>
+          <a:xfrm>
+            <a:off x="6172200" y="3246120"/>
+            <a:ext cx="5120640" cy="1234440"/>
+          </a:xfrm>
+          <a:prstGeom prst="roundRect">
+            <a:avLst>
+              <a:gd name="adj" fmla="val 5926"/>
+            </a:avLst>
+          </a:prstGeom>
+          <a:solidFill>
+            <a:srgbClr val="FFFFFF"/>
+          </a:solidFill>
+          <a:ln w="12700">
+            <a:solidFill>
+              <a:srgbClr val="E6E9EF"/>
+            </a:solidFill>
+            <a:prstDash val="solid"/>
+          </a:ln>
+        </p:spPr>
+      </p:sp>
+      <p:sp>
+        <p:nvSpPr>
+          <p:cNvPr id="20" name="Shape 18"/>
+          <p:cNvSpPr/>
+          <p:nvPr/>
+        </p:nvSpPr>
+        <p:spPr>
+          <a:xfrm>
+            <a:off x="6446520" y="3520440"/>
+            <a:ext cx="310896" cy="310896"/>
+          </a:xfrm>
+          <a:prstGeom prst="ellipse">
+            <a:avLst/>
+          </a:prstGeom>
+          <a:solidFill>
+            <a:srgbClr val="E7EEFD"/>
+          </a:solidFill>
+          <a:ln w="12700">
+            <a:solidFill>
+              <a:srgbClr val="333333"/>
+            </a:solidFill>
+            <a:prstDash val="solid"/>
+          </a:ln>
+        </p:spPr>
+      </p:sp>
+      <p:sp>
+        <p:nvSpPr>
+          <p:cNvPr id="21" name="Text 19"/>
+          <p:cNvSpPr txBox="1"/>
+          <p:nvPr/>
+        </p:nvSpPr>
+        <p:spPr>
+          <a:xfrm>
+            <a:off x="6446520" y="3557016"/>
+            <a:ext cx="310896" cy="237744"/>
+          </a:xfrm>
+          <a:prstGeom prst="rect">
+            <a:avLst/>
+          </a:prstGeom>
+          <a:noFill/>
+          <a:ln/>
+        </p:spPr>
+        <p:txBody>
+          <a:bodyPr wrap="square" lIns="0" tIns="0" rIns="0" bIns="0" rtlCol="0" anchor="ctr"/>
+          <a:lstStyle/>
+          <a:p>
+            <a:pPr algn="ctr" indent="0" marL="0">
+              <a:buNone/>
+            </a:pPr>
+            <a:r>
+              <a:rPr lang="en-US" sz="1200" b="1" dirty="0">
+                <a:solidFill>
+                  <a:srgbClr val="1A61EA"/>
+                </a:solidFill>
+                <a:latin typeface="Calibri" pitchFamily="34" charset="0"/>
+                <a:ea typeface="Calibri" pitchFamily="34" charset="-122"/>
+                <a:cs typeface="Calibri" pitchFamily="34" charset="-120"/>
+              </a:rPr>
+              <a:t>4</a:t>
+            </a:r>
+            <a:endParaRPr lang="en-US" sz="1200" dirty="0"/>
+          </a:p>
+        </p:txBody>
+      </p:sp>
+      <p:sp>
+        <p:nvSpPr>
+          <p:cNvPr id="22" name="Text 20"/>
+          <p:cNvSpPr txBox="1"/>
+          <p:nvPr/>
+        </p:nvSpPr>
+        <p:spPr>
+          <a:xfrm>
+            <a:off x="6885432" y="3502152"/>
+            <a:ext cx="4114800" cy="274320"/>
+          </a:xfrm>
+          <a:prstGeom prst="rect">
+            <a:avLst/>
+          </a:prstGeom>
+          <a:noFill/>
+          <a:ln/>
+        </p:spPr>
+        <p:txBody>
+          <a:bodyPr wrap="square" lIns="0" tIns="0" rIns="0" bIns="0" rtlCol="0" anchor="ctr"/>
+          <a:lstStyle/>
+          <a:p>
+            <a:pPr indent="0" marL="0">
+              <a:buNone/>
+            </a:pPr>
+            <a:r>
+              <a:rPr lang="en-US" sz="1450" b="1" dirty="0">
+                <a:solidFill>
+                  <a:srgbClr val="0B1220"/>
+                </a:solidFill>
+                <a:latin typeface="Calibri" pitchFamily="34" charset="0"/>
+                <a:ea typeface="Calibri" pitchFamily="34" charset="-122"/>
+                <a:cs typeface="Calibri" pitchFamily="34" charset="-120"/>
+              </a:rPr>
+              <a:t>오류 대응</a:t>
+            </a:r>
+            <a:endParaRPr lang="en-US" sz="1450" dirty="0"/>
+          </a:p>
+        </p:txBody>
+      </p:sp>
+      <p:sp>
+        <p:nvSpPr>
+          <p:cNvPr id="23" name="Text 21"/>
+          <p:cNvSpPr txBox="1"/>
+          <p:nvPr/>
+        </p:nvSpPr>
+        <p:spPr>
+          <a:xfrm>
+            <a:off x="6885432" y="3813048"/>
+            <a:ext cx="4114800" cy="548640"/>
+          </a:xfrm>
+          <a:prstGeom prst="rect">
+            <a:avLst/>
+          </a:prstGeom>
+          <a:noFill/>
+          <a:ln/>
+        </p:spPr>
+        <p:txBody>
+          <a:bodyPr wrap="square" lIns="0" tIns="0" rIns="0" bIns="0" rtlCol="0" anchor="ctr"/>
+          <a:lstStyle/>
+          <a:p>
+            <a:pPr indent="0" marL="0">
+              <a:lnSpc>
+                <a:spcPts val="1700"/>
+              </a:lnSpc>
+              <a:buNone/>
+            </a:pPr>
+            <a:r>
+              <a:rPr lang="en-US" sz="1200" dirty="0">
+                <a:solidFill>
+                  <a:srgbClr val="6E7A8A"/>
+                </a:solidFill>
+                <a:latin typeface="Calibri" pitchFamily="34" charset="0"/>
+                <a:ea typeface="Calibri" pitchFamily="34" charset="-122"/>
+                <a:cs typeface="Calibri" pitchFamily="34" charset="-120"/>
+              </a:rPr>
+              <a:t>텔레그램 장애 시 대시보드로 처리하고, 생성 실패 시 주제를 되돌리며, 실패도 로그에 남깁니다.</a:t>
+            </a:r>
+            <a:endParaRPr lang="en-US" sz="1200" dirty="0"/>
+          </a:p>
+        </p:txBody>
+      </p:sp>
+      <p:sp>
+        <p:nvSpPr>
+          <p:cNvPr id="24" name="Shape 22"/>
+          <p:cNvSpPr/>
+          <p:nvPr/>
+        </p:nvSpPr>
+        <p:spPr>
+          <a:xfrm>
+            <a:off x="777240" y="4892040"/>
+            <a:ext cx="10607040" cy="960120"/>
+          </a:xfrm>
+          <a:prstGeom prst="roundRect">
+            <a:avLst>
+              <a:gd name="adj" fmla="val 7619"/>
+            </a:avLst>
+          </a:prstGeom>
+          <a:solidFill>
+            <a:srgbClr val="FFFFFF"/>
+          </a:solidFill>
+          <a:ln w="12700">
+            <a:solidFill>
+              <a:srgbClr val="E6E9EF"/>
+            </a:solidFill>
+            <a:prstDash val="solid"/>
+          </a:ln>
+        </p:spPr>
+      </p:sp>
+      <p:sp>
+        <p:nvSpPr>
+          <p:cNvPr id="25" name="Text 23"/>
+          <p:cNvSpPr txBox="1"/>
+          <p:nvPr/>
+        </p:nvSpPr>
+        <p:spPr>
+          <a:xfrm>
+            <a:off x="1143000" y="5102352"/>
+            <a:ext cx="9875520" cy="640080"/>
+          </a:xfrm>
+          <a:prstGeom prst="rect">
+            <a:avLst/>
+          </a:prstGeom>
+          <a:noFill/>
+          <a:ln/>
+        </p:spPr>
+        <p:txBody>
+          <a:bodyPr wrap="square" lIns="0" tIns="0" rIns="0" bIns="0" rtlCol="0" anchor="ctr"/>
+          <a:lstStyle/>
+          <a:p>
+            <a:pPr indent="0" marL="0">
+              <a:lnSpc>
+                <a:spcPts val="1800"/>
+              </a:lnSpc>
               <a:buNone/>
             </a:pPr>
             <a:r>
               <a:rPr lang="en-US" sz="1250" dirty="0">
                 <a:solidFill>
-                  <a:srgbClr val="6B7F9E"/>
-                </a:solidFill>
-                <a:latin typeface="Calibri" pitchFamily="34" charset="0"/>
-                <a:ea typeface="Calibri" pitchFamily="34" charset="-122"/>
-                <a:cs typeface="Calibri" pitchFamily="34" charset="-120"/>
-              </a:rPr>
-              <a:t>marketingbot.vercel.app</a:t>
+                  <a:srgbClr val="38445A"/>
+                </a:solidFill>
+                <a:latin typeface="Calibri" pitchFamily="34" charset="0"/>
+                <a:ea typeface="Calibri" pitchFamily="34" charset="-122"/>
+                <a:cs typeface="Calibri" pitchFamily="34" charset="-120"/>
+              </a:rPr>
+              <a:t>정직하게 덧붙이면 — 생성물은 아직 블라인드 테스트를 통과하지 못합니다. 지적된 결함(문장마다 흔들리는 어미)을 지표로 만들어 전환률을 78.9%에서 0%로 낮췄습니다. 그래서 승인 게이트가 설계의 중심에 있습니다.</a:t>
             </a:r>
             <a:endParaRPr lang="en-US" sz="1250" dirty="0"/>
           </a:p>
@@ -4613,12 +5249,12 @@
         </p:nvSpPr>
         <p:spPr>
           <a:xfrm>
-            <a:off x="777240" y="4526280"/>
-            <a:ext cx="10607040" cy="1051560"/>
+            <a:off x="777240" y="4480560"/>
+            <a:ext cx="10607040" cy="1371600"/>
           </a:xfrm>
           <a:prstGeom prst="roundRect">
             <a:avLst>
-              <a:gd name="adj" fmla="val 6957"/>
+              <a:gd name="adj" fmla="val 5333"/>
             </a:avLst>
           </a:prstGeom>
           <a:solidFill>
@@ -4640,7 +5276,7 @@
         </p:nvSpPr>
         <p:spPr>
           <a:xfrm>
-            <a:off x="1143000" y="4709160"/>
+            <a:off x="1143000" y="4663440"/>
             <a:ext cx="10058400" cy="274320"/>
           </a:xfrm>
           <a:prstGeom prst="rect">
@@ -4679,8 +5315,8 @@
         </p:nvSpPr>
         <p:spPr>
           <a:xfrm>
-            <a:off x="1143000" y="5029200"/>
-            <a:ext cx="9875520" cy="365760"/>
+            <a:off x="1143000" y="4983480"/>
+            <a:ext cx="9875520" cy="292608"/>
           </a:xfrm>
           <a:prstGeom prst="rect">
             <a:avLst/>
@@ -4705,6 +5341,70 @@
                 <a:cs typeface="Calibri" pitchFamily="34" charset="-120"/>
               </a:rPr>
               <a:t>사례 콘텐츠에는 고객사명이 정당하게 등장합니다. 써도 되는지는 사람이 판단할 문제입니다. — 실제 발행글 46편 검증에서 잘못된 차단 0건</a:t>
+            </a:r>
+            <a:endParaRPr lang="en-US" sz="1250" dirty="0"/>
+          </a:p>
+        </p:txBody>
+      </p:sp>
+      <p:sp>
+        <p:nvSpPr>
+          <p:cNvPr id="15" name="Shape 13"/>
+          <p:cNvSpPr/>
+          <p:nvPr/>
+        </p:nvSpPr>
+        <p:spPr>
+          <a:xfrm>
+            <a:off x="1143000" y="5349240"/>
+            <a:ext cx="9875520" cy="10973"/>
+          </a:xfrm>
+          <a:prstGeom prst="rect">
+            <a:avLst/>
+          </a:prstGeom>
+          <a:solidFill>
+            <a:srgbClr val="E6E9EF"/>
+          </a:solidFill>
+          <a:ln w="12700">
+            <a:solidFill>
+              <a:srgbClr val="333333"/>
+            </a:solidFill>
+            <a:prstDash val="solid"/>
+          </a:ln>
+        </p:spPr>
+      </p:sp>
+      <p:sp>
+        <p:nvSpPr>
+          <p:cNvPr id="16" name="Text 14"/>
+          <p:cNvSpPr txBox="1"/>
+          <p:nvPr/>
+        </p:nvSpPr>
+        <p:spPr>
+          <a:xfrm>
+            <a:off x="1143000" y="5440680"/>
+            <a:ext cx="9875520" cy="292608"/>
+          </a:xfrm>
+          <a:prstGeom prst="rect">
+            <a:avLst/>
+          </a:prstGeom>
+          <a:noFill/>
+          <a:ln/>
+        </p:spPr>
+        <p:txBody>
+          <a:bodyPr wrap="square" lIns="0" tIns="0" rIns="0" bIns="0" rtlCol="0" anchor="ctr"/>
+          <a:lstStyle/>
+          <a:p>
+            <a:pPr indent="0" marL="0">
+              <a:buNone/>
+            </a:pPr>
+            <a:r>
+              <a:rPr lang="en-US" sz="1250" dirty="0">
+                <a:solidFill>
+                  <a:srgbClr val="1A61EA"/>
+                </a:solidFill>
+                <a:latin typeface="Calibri" pitchFamily="34" charset="0"/>
+                <a:ea typeface="Calibri" pitchFamily="34" charset="-122"/>
+                <a:cs typeface="Calibri" pitchFamily="34" charset="-120"/>
+              </a:rPr>
+              <a:t>모든 결정은 누가 · 언제 · 왜와 함께 기록되며, 사람의 결정과 시스템의 실행이 구분되어 남습니다.</a:t>
             </a:r>
             <a:endParaRPr lang="en-US" sz="1250" dirty="0"/>
           </a:p>
@@ -6081,7 +6781,7 @@
                 <a:ea typeface="Calibri" pitchFamily="34" charset="-122"/>
                 <a:cs typeface="Calibri" pitchFamily="34" charset="-120"/>
               </a:rPr>
-              <a:t>검증</a:t>
+              <a:t>SCOPE</a:t>
             </a:r>
             <a:endParaRPr lang="en-US" sz="1100" dirty="0"/>
           </a:p>
@@ -6120,7 +6820,7 @@
                 <a:ea typeface="Calibri" pitchFamily="34" charset="-122"/>
                 <a:cs typeface="Calibri" pitchFamily="34" charset="-120"/>
               </a:rPr>
-              <a:t>점수 채택 기준</a:t>
+              <a:t>Functionalities &amp; Limitations</a:t>
             </a:r>
             <a:endParaRPr lang="en-US" sz="3000" dirty="0"/>
           </a:p>
@@ -6128,57 +6828,18 @@
       </p:sp>
       <p:sp>
         <p:nvSpPr>
-          <p:cNvPr id="4" name="Text 2"/>
-          <p:cNvSpPr txBox="1"/>
-          <p:nvPr/>
-        </p:nvSpPr>
-        <p:spPr>
-          <a:xfrm>
-            <a:off x="777240" y="1243584"/>
-            <a:ext cx="10241280" cy="365760"/>
-          </a:xfrm>
-          <a:prstGeom prst="rect">
-            <a:avLst/>
-          </a:prstGeom>
-          <a:noFill/>
-          <a:ln/>
-        </p:spPr>
-        <p:txBody>
-          <a:bodyPr wrap="square" lIns="0" tIns="0" rIns="0" bIns="0" rtlCol="0" anchor="ctr"/>
-          <a:lstStyle/>
-          <a:p>
-            <a:pPr indent="0" marL="0">
-              <a:buNone/>
-            </a:pPr>
-            <a:r>
-              <a:rPr lang="en-US" sz="1400" dirty="0">
-                <a:solidFill>
-                  <a:srgbClr val="6E7A8A"/>
-                </a:solidFill>
-                <a:latin typeface="Calibri" pitchFamily="34" charset="0"/>
-                <a:ea typeface="Calibri" pitchFamily="34" charset="-122"/>
-                <a:cs typeface="Calibri" pitchFamily="34" charset="-120"/>
-              </a:rPr>
-              <a:t>이 점수는 저희가 정한 이상적인 글이 아니라, 코드프레소가 실제 발행한 글 46편에서 역산한 기준입니다</a:t>
-            </a:r>
-            <a:endParaRPr lang="en-US" sz="1400" dirty="0"/>
-          </a:p>
-        </p:txBody>
-      </p:sp>
-      <p:sp>
-        <p:nvSpPr>
-          <p:cNvPr id="5" name="Shape 3"/>
+          <p:cNvPr id="4" name="Shape 2"/>
           <p:cNvSpPr/>
           <p:nvPr/>
         </p:nvSpPr>
         <p:spPr>
           <a:xfrm>
-            <a:off x="777240" y="1965960"/>
-            <a:ext cx="10607040" cy="868680"/>
+            <a:off x="777240" y="2011680"/>
+            <a:ext cx="10607040" cy="786384"/>
           </a:xfrm>
           <a:prstGeom prst="roundRect">
             <a:avLst>
-              <a:gd name="adj" fmla="val 8421"/>
+              <a:gd name="adj" fmla="val 9302"/>
             </a:avLst>
           </a:prstGeom>
           <a:solidFill>
@@ -6194,338 +6855,26 @@
       </p:sp>
       <p:sp>
         <p:nvSpPr>
-          <p:cNvPr id="6" name="Text 4"/>
-          <p:cNvSpPr txBox="1"/>
-          <p:nvPr/>
-        </p:nvSpPr>
-        <p:spPr>
-          <a:xfrm>
-            <a:off x="1097280" y="2157984"/>
-            <a:ext cx="2377440" cy="219456"/>
-          </a:xfrm>
-          <a:prstGeom prst="rect">
-            <a:avLst/>
-          </a:prstGeom>
-          <a:noFill/>
-          <a:ln/>
-        </p:spPr>
-        <p:txBody>
-          <a:bodyPr wrap="square" lIns="0" tIns="0" rIns="0" bIns="0" rtlCol="0" anchor="ctr"/>
-          <a:lstStyle/>
-          <a:p>
-            <a:pPr indent="0" marL="0">
-              <a:buNone/>
-            </a:pPr>
-            <a:r>
-              <a:rPr lang="en-US" sz="1100" dirty="0">
-                <a:solidFill>
-                  <a:srgbClr val="6E7A8A"/>
-                </a:solidFill>
-                <a:latin typeface="Calibri" pitchFamily="34" charset="0"/>
-                <a:ea typeface="Calibri" pitchFamily="34" charset="-122"/>
-                <a:cs typeface="Calibri" pitchFamily="34" charset="-120"/>
-              </a:rPr>
-              <a:t>문장 평균 길이</a:t>
-            </a:r>
-            <a:endParaRPr lang="en-US" sz="1100" dirty="0"/>
-          </a:p>
-        </p:txBody>
-      </p:sp>
-      <p:sp>
-        <p:nvSpPr>
-          <p:cNvPr id="7" name="Text 5"/>
-          <p:cNvSpPr txBox="1"/>
-          <p:nvPr/>
-        </p:nvSpPr>
-        <p:spPr>
-          <a:xfrm>
-            <a:off x="1097280" y="2395728"/>
-            <a:ext cx="2377440" cy="274320"/>
-          </a:xfrm>
-          <a:prstGeom prst="rect">
-            <a:avLst/>
-          </a:prstGeom>
-          <a:noFill/>
-          <a:ln/>
-        </p:spPr>
-        <p:txBody>
-          <a:bodyPr wrap="square" lIns="0" tIns="0" rIns="0" bIns="0" rtlCol="0" anchor="ctr"/>
-          <a:lstStyle/>
-          <a:p>
-            <a:pPr indent="0" marL="0">
-              <a:buNone/>
-            </a:pPr>
-            <a:r>
-              <a:rPr lang="en-US" sz="1500" b="1" dirty="0">
-                <a:solidFill>
-                  <a:srgbClr val="0B1220"/>
-                </a:solidFill>
-                <a:latin typeface="Calibri" pitchFamily="34" charset="0"/>
-                <a:ea typeface="Calibri" pitchFamily="34" charset="-122"/>
-                <a:cs typeface="Calibri" pitchFamily="34" charset="-120"/>
-              </a:rPr>
-              <a:t>46.9자</a:t>
-            </a:r>
-            <a:endParaRPr lang="en-US" sz="1500" dirty="0"/>
-          </a:p>
-        </p:txBody>
-      </p:sp>
-      <p:sp>
-        <p:nvSpPr>
-          <p:cNvPr id="8" name="Text 6"/>
-          <p:cNvSpPr txBox="1"/>
-          <p:nvPr/>
-        </p:nvSpPr>
-        <p:spPr>
-          <a:xfrm>
-            <a:off x="3703320" y="2157984"/>
-            <a:ext cx="2377440" cy="219456"/>
-          </a:xfrm>
-          <a:prstGeom prst="rect">
-            <a:avLst/>
-          </a:prstGeom>
-          <a:noFill/>
-          <a:ln/>
-        </p:spPr>
-        <p:txBody>
-          <a:bodyPr wrap="square" lIns="0" tIns="0" rIns="0" bIns="0" rtlCol="0" anchor="ctr"/>
-          <a:lstStyle/>
-          <a:p>
-            <a:pPr indent="0" marL="0">
-              <a:buNone/>
-            </a:pPr>
-            <a:r>
-              <a:rPr lang="en-US" sz="1100" dirty="0">
-                <a:solidFill>
-                  <a:srgbClr val="6E7A8A"/>
-                </a:solidFill>
-                <a:latin typeface="Calibri" pitchFamily="34" charset="0"/>
-                <a:ea typeface="Calibri" pitchFamily="34" charset="-122"/>
-                <a:cs typeface="Calibri" pitchFamily="34" charset="-120"/>
-              </a:rPr>
-              <a:t>어미 전환률 중앙값</a:t>
-            </a:r>
-            <a:endParaRPr lang="en-US" sz="1100" dirty="0"/>
-          </a:p>
-        </p:txBody>
-      </p:sp>
-      <p:sp>
-        <p:nvSpPr>
-          <p:cNvPr id="9" name="Text 7"/>
-          <p:cNvSpPr txBox="1"/>
-          <p:nvPr/>
-        </p:nvSpPr>
-        <p:spPr>
-          <a:xfrm>
-            <a:off x="3703320" y="2395728"/>
-            <a:ext cx="2377440" cy="274320"/>
-          </a:xfrm>
-          <a:prstGeom prst="rect">
-            <a:avLst/>
-          </a:prstGeom>
-          <a:noFill/>
-          <a:ln/>
-        </p:spPr>
-        <p:txBody>
-          <a:bodyPr wrap="square" lIns="0" tIns="0" rIns="0" bIns="0" rtlCol="0" anchor="ctr"/>
-          <a:lstStyle/>
-          <a:p>
-            <a:pPr indent="0" marL="0">
-              <a:buNone/>
-            </a:pPr>
-            <a:r>
-              <a:rPr lang="en-US" sz="1500" b="1" dirty="0">
-                <a:solidFill>
-                  <a:srgbClr val="0B1220"/>
-                </a:solidFill>
-                <a:latin typeface="Calibri" pitchFamily="34" charset="0"/>
-                <a:ea typeface="Calibri" pitchFamily="34" charset="-122"/>
-                <a:cs typeface="Calibri" pitchFamily="34" charset="-120"/>
-              </a:rPr>
-              <a:t>10.4%</a:t>
-            </a:r>
-            <a:endParaRPr lang="en-US" sz="1500" dirty="0"/>
-          </a:p>
-        </p:txBody>
-      </p:sp>
-      <p:sp>
-        <p:nvSpPr>
-          <p:cNvPr id="10" name="Text 8"/>
-          <p:cNvSpPr txBox="1"/>
-          <p:nvPr/>
-        </p:nvSpPr>
-        <p:spPr>
-          <a:xfrm>
-            <a:off x="6309360" y="2157984"/>
-            <a:ext cx="2377440" cy="219456"/>
-          </a:xfrm>
-          <a:prstGeom prst="rect">
-            <a:avLst/>
-          </a:prstGeom>
-          <a:noFill/>
-          <a:ln/>
-        </p:spPr>
-        <p:txBody>
-          <a:bodyPr wrap="square" lIns="0" tIns="0" rIns="0" bIns="0" rtlCol="0" anchor="ctr"/>
-          <a:lstStyle/>
-          <a:p>
-            <a:pPr indent="0" marL="0">
-              <a:buNone/>
-            </a:pPr>
-            <a:r>
-              <a:rPr lang="en-US" sz="1100" dirty="0">
-                <a:solidFill>
-                  <a:srgbClr val="6E7A8A"/>
-                </a:solidFill>
-                <a:latin typeface="Calibri" pitchFamily="34" charset="0"/>
-                <a:ea typeface="Calibri" pitchFamily="34" charset="-122"/>
-                <a:cs typeface="Calibri" pitchFamily="34" charset="-120"/>
-              </a:rPr>
-              <a:t>브랜드 언급</a:t>
-            </a:r>
-            <a:endParaRPr lang="en-US" sz="1100" dirty="0"/>
-          </a:p>
-        </p:txBody>
-      </p:sp>
-      <p:sp>
-        <p:nvSpPr>
-          <p:cNvPr id="11" name="Text 9"/>
-          <p:cNvSpPr txBox="1"/>
-          <p:nvPr/>
-        </p:nvSpPr>
-        <p:spPr>
-          <a:xfrm>
-            <a:off x="6309360" y="2395728"/>
-            <a:ext cx="2377440" cy="274320"/>
-          </a:xfrm>
-          <a:prstGeom prst="rect">
-            <a:avLst/>
-          </a:prstGeom>
-          <a:noFill/>
-          <a:ln/>
-        </p:spPr>
-        <p:txBody>
-          <a:bodyPr wrap="square" lIns="0" tIns="0" rIns="0" bIns="0" rtlCol="0" anchor="ctr"/>
-          <a:lstStyle/>
-          <a:p>
-            <a:pPr indent="0" marL="0">
-              <a:buNone/>
-            </a:pPr>
-            <a:r>
-              <a:rPr lang="en-US" sz="1500" b="1" dirty="0">
-                <a:solidFill>
-                  <a:srgbClr val="0B1220"/>
-                </a:solidFill>
-                <a:latin typeface="Calibri" pitchFamily="34" charset="0"/>
-                <a:ea typeface="Calibri" pitchFamily="34" charset="-122"/>
-                <a:cs typeface="Calibri" pitchFamily="34" charset="-120"/>
-              </a:rPr>
-              <a:t>1.09회 / 1,000자</a:t>
-            </a:r>
-            <a:endParaRPr lang="en-US" sz="1500" dirty="0"/>
-          </a:p>
-        </p:txBody>
-      </p:sp>
-      <p:sp>
-        <p:nvSpPr>
-          <p:cNvPr id="12" name="Text 10"/>
-          <p:cNvSpPr txBox="1"/>
-          <p:nvPr/>
-        </p:nvSpPr>
-        <p:spPr>
-          <a:xfrm>
-            <a:off x="8915400" y="2157984"/>
-            <a:ext cx="2377440" cy="219456"/>
-          </a:xfrm>
-          <a:prstGeom prst="rect">
-            <a:avLst/>
-          </a:prstGeom>
-          <a:noFill/>
-          <a:ln/>
-        </p:spPr>
-        <p:txBody>
-          <a:bodyPr wrap="square" lIns="0" tIns="0" rIns="0" bIns="0" rtlCol="0" anchor="ctr"/>
-          <a:lstStyle/>
-          <a:p>
-            <a:pPr indent="0" marL="0">
-              <a:buNone/>
-            </a:pPr>
-            <a:r>
-              <a:rPr lang="en-US" sz="1100" dirty="0">
-                <a:solidFill>
-                  <a:srgbClr val="6E7A8A"/>
-                </a:solidFill>
-                <a:latin typeface="Calibri" pitchFamily="34" charset="0"/>
-                <a:ea typeface="Calibri" pitchFamily="34" charset="-122"/>
-                <a:cs typeface="Calibri" pitchFamily="34" charset="-120"/>
-              </a:rPr>
-              <a:t>수치 인용</a:t>
-            </a:r>
-            <a:endParaRPr lang="en-US" sz="1100" dirty="0"/>
-          </a:p>
-        </p:txBody>
-      </p:sp>
-      <p:sp>
-        <p:nvSpPr>
-          <p:cNvPr id="13" name="Text 11"/>
-          <p:cNvSpPr txBox="1"/>
-          <p:nvPr/>
-        </p:nvSpPr>
-        <p:spPr>
-          <a:xfrm>
-            <a:off x="8915400" y="2395728"/>
-            <a:ext cx="2377440" cy="274320"/>
-          </a:xfrm>
-          <a:prstGeom prst="rect">
-            <a:avLst/>
-          </a:prstGeom>
-          <a:noFill/>
-          <a:ln/>
-        </p:spPr>
-        <p:txBody>
-          <a:bodyPr wrap="square" lIns="0" tIns="0" rIns="0" bIns="0" rtlCol="0" anchor="ctr"/>
-          <a:lstStyle/>
-          <a:p>
-            <a:pPr indent="0" marL="0">
-              <a:buNone/>
-            </a:pPr>
-            <a:r>
-              <a:rPr lang="en-US" sz="1500" b="1" dirty="0">
-                <a:solidFill>
-                  <a:srgbClr val="0B1220"/>
-                </a:solidFill>
-                <a:latin typeface="Calibri" pitchFamily="34" charset="0"/>
-                <a:ea typeface="Calibri" pitchFamily="34" charset="-122"/>
-                <a:cs typeface="Calibri" pitchFamily="34" charset="-120"/>
-              </a:rPr>
-              <a:t>1.26회 / 1,000자</a:t>
-            </a:r>
-            <a:endParaRPr lang="en-US" sz="1500" dirty="0"/>
-          </a:p>
-        </p:txBody>
-      </p:sp>
-      <p:sp>
-        <p:nvSpPr>
-          <p:cNvPr id="14" name="Shape 12"/>
+          <p:cNvPr id="5" name="Shape 3"/>
           <p:cNvSpPr/>
           <p:nvPr/>
         </p:nvSpPr>
         <p:spPr>
           <a:xfrm>
-            <a:off x="777240" y="3063240"/>
-            <a:ext cx="10607040" cy="1554480"/>
+            <a:off x="1069848" y="2231136"/>
+            <a:ext cx="1371600" cy="347472"/>
           </a:xfrm>
           <a:prstGeom prst="roundRect">
             <a:avLst>
-              <a:gd name="adj" fmla="val 4706"/>
+              <a:gd name="adj" fmla="val 15789"/>
             </a:avLst>
           </a:prstGeom>
           <a:solidFill>
-            <a:srgbClr val="FFFFFF"/>
+            <a:srgbClr val="E8F3EE"/>
           </a:solidFill>
           <a:ln w="12700">
             <a:solidFill>
-              <a:srgbClr val="1A61EA"/>
+              <a:srgbClr val="333333"/>
             </a:solidFill>
             <a:prstDash val="solid"/>
           </a:ln>
@@ -6533,119 +6882,96 @@
       </p:sp>
       <p:sp>
         <p:nvSpPr>
-          <p:cNvPr id="15" name="Text 13"/>
-          <p:cNvSpPr txBox="1"/>
-          <p:nvPr/>
-        </p:nvSpPr>
-        <p:spPr>
-          <a:xfrm>
-            <a:off x="1188720" y="3291840"/>
-            <a:ext cx="7315200" cy="310896"/>
-          </a:xfrm>
-          <a:prstGeom prst="rect">
-            <a:avLst/>
-          </a:prstGeom>
-          <a:noFill/>
-          <a:ln/>
-        </p:spPr>
-        <p:txBody>
-          <a:bodyPr wrap="square" lIns="0" tIns="0" rIns="0" bIns="0" rtlCol="0" anchor="ctr"/>
-          <a:lstStyle/>
-          <a:p>
-            <a:pPr indent="0" marL="0">
-              <a:buNone/>
-            </a:pPr>
-            <a:r>
-              <a:rPr lang="en-US" sz="1900" b="1" dirty="0">
-                <a:solidFill>
-                  <a:srgbClr val="1A61EA"/>
-                </a:solidFill>
-                <a:latin typeface="Calibri" pitchFamily="34" charset="0"/>
-                <a:ea typeface="Calibri" pitchFamily="34" charset="-122"/>
-                <a:cs typeface="Calibri" pitchFamily="34" charset="-120"/>
-              </a:rPr>
-              <a:t>기준을 고칠 때마다 통과해야 하는 관문</a:t>
-            </a:r>
-            <a:endParaRPr lang="en-US" sz="1900" dirty="0"/>
-          </a:p>
-        </p:txBody>
-      </p:sp>
-      <p:sp>
-        <p:nvSpPr>
-          <p:cNvPr id="16" name="Text 14"/>
-          <p:cNvSpPr txBox="1"/>
-          <p:nvPr/>
-        </p:nvSpPr>
-        <p:spPr>
-          <a:xfrm>
-            <a:off x="1188720" y="3703320"/>
-            <a:ext cx="9875520" cy="777240"/>
-          </a:xfrm>
-          <a:prstGeom prst="rect">
-            <a:avLst/>
-          </a:prstGeom>
-          <a:noFill/>
-          <a:ln/>
-        </p:spPr>
-        <p:txBody>
-          <a:bodyPr wrap="square" lIns="0" tIns="0" rIns="0" bIns="0" rtlCol="0" anchor="ctr"/>
-          <a:lstStyle/>
-          <a:p>
-            <a:pPr indent="0" marL="0">
-              <a:lnSpc>
-                <a:spcPts val="2200"/>
-              </a:lnSpc>
-              <a:buNone/>
-            </a:pPr>
-            <a:r>
-              <a:rPr lang="en-US" sz="1400" dirty="0">
-                <a:solidFill>
-                  <a:srgbClr val="38445A"/>
-                </a:solidFill>
-                <a:latin typeface="Calibri" pitchFamily="34" charset="0"/>
-                <a:ea typeface="Calibri" pitchFamily="34" charset="-122"/>
-                <a:cs typeface="Calibri" pitchFamily="34" charset="-120"/>
-              </a:rPr>
-              <a:t>수정한 채점 기준으로 그 46편을 다시 채점해 중앙값 92점이 유지되어야 채택하고, 그러지 못하면 폐기합니다.</a:t>
-            </a:r>
-            <a:endParaRPr lang="en-US" sz="1400" dirty="0"/>
-          </a:p>
-          <a:p>
-            <a:pPr indent="0" marL="0">
-              <a:lnSpc>
-                <a:spcPts val="2200"/>
-              </a:lnSpc>
-              <a:buNone/>
-            </a:pPr>
-            <a:r>
-              <a:rPr lang="en-US" sz="1400" dirty="0">
-                <a:solidFill>
-                  <a:srgbClr val="38445A"/>
-                </a:solidFill>
-                <a:latin typeface="Calibri" pitchFamily="34" charset="0"/>
-                <a:ea typeface="Calibri" pitchFamily="34" charset="-122"/>
-                <a:cs typeface="Calibri" pitchFamily="34" charset="-120"/>
-              </a:rPr>
-              <a:t>실제로 네 차례 폐기하거나 고쳤습니다. 저희 결과에 유리하도록 맞춘 지표가 아니라, 고객사의 글로 검증한 지표입니다.</a:t>
-            </a:r>
-            <a:endParaRPr lang="en-US" sz="1400" dirty="0"/>
-          </a:p>
-        </p:txBody>
-      </p:sp>
-      <p:sp>
-        <p:nvSpPr>
-          <p:cNvPr id="17" name="Shape 15"/>
+          <p:cNvPr id="6" name="Text 4"/>
+          <p:cNvSpPr txBox="1"/>
+          <p:nvPr/>
+        </p:nvSpPr>
+        <p:spPr>
+          <a:xfrm>
+            <a:off x="1069848" y="2286000"/>
+            <a:ext cx="1371600" cy="237744"/>
+          </a:xfrm>
+          <a:prstGeom prst="rect">
+            <a:avLst/>
+          </a:prstGeom>
+          <a:noFill/>
+          <a:ln/>
+        </p:spPr>
+        <p:txBody>
+          <a:bodyPr wrap="square" lIns="0" tIns="0" rIns="0" bIns="0" rtlCol="0" anchor="ctr"/>
+          <a:lstStyle/>
+          <a:p>
+            <a:pPr algn="ctr" indent="0" marL="0">
+              <a:buNone/>
+            </a:pPr>
+            <a:r>
+              <a:rPr lang="en-US" sz="1150" b="1" dirty="0">
+                <a:solidFill>
+                  <a:srgbClr val="1E8E63"/>
+                </a:solidFill>
+                <a:latin typeface="Calibri" pitchFamily="34" charset="0"/>
+                <a:ea typeface="Calibri" pitchFamily="34" charset="-122"/>
+                <a:cs typeface="Calibri" pitchFamily="34" charset="-120"/>
+              </a:rPr>
+              <a:t>실제 구현</a:t>
+            </a:r>
+            <a:endParaRPr lang="en-US" sz="1150" dirty="0"/>
+          </a:p>
+        </p:txBody>
+      </p:sp>
+      <p:sp>
+        <p:nvSpPr>
+          <p:cNvPr id="7" name="Text 5"/>
+          <p:cNvSpPr txBox="1"/>
+          <p:nvPr/>
+        </p:nvSpPr>
+        <p:spPr>
+          <a:xfrm>
+            <a:off x="2651760" y="2267712"/>
+            <a:ext cx="8412480" cy="292608"/>
+          </a:xfrm>
+          <a:prstGeom prst="rect">
+            <a:avLst/>
+          </a:prstGeom>
+          <a:noFill/>
+          <a:ln/>
+        </p:spPr>
+        <p:txBody>
+          <a:bodyPr wrap="square" lIns="0" tIns="0" rIns="0" bIns="0" rtlCol="0" anchor="ctr"/>
+          <a:lstStyle/>
+          <a:p>
+            <a:pPr indent="0" marL="0">
+              <a:buNone/>
+            </a:pPr>
+            <a:r>
+              <a:rPr lang="en-US" sz="1350" dirty="0">
+                <a:solidFill>
+                  <a:srgbClr val="0B1220"/>
+                </a:solidFill>
+                <a:latin typeface="Calibri" pitchFamily="34" charset="0"/>
+                <a:ea typeface="Calibri" pitchFamily="34" charset="-122"/>
+                <a:cs typeface="Calibri" pitchFamily="34" charset="-120"/>
+              </a:rPr>
+              <a:t>아이디어 · 기획 · 원고 · 성과 취합 · 데이터 축적</a:t>
+            </a:r>
+            <a:endParaRPr lang="en-US" sz="1350" dirty="0"/>
+          </a:p>
+        </p:txBody>
+      </p:sp>
+      <p:sp>
+        <p:nvSpPr>
+          <p:cNvPr id="8" name="Shape 6"/>
           <p:cNvSpPr/>
           <p:nvPr/>
         </p:nvSpPr>
         <p:spPr>
           <a:xfrm>
-            <a:off x="777240" y="4846320"/>
-            <a:ext cx="10607040" cy="1143000"/>
+            <a:off x="777240" y="2971800"/>
+            <a:ext cx="10607040" cy="786384"/>
           </a:xfrm>
           <a:prstGeom prst="roundRect">
             <a:avLst>
-              <a:gd name="adj" fmla="val 6400"/>
+              <a:gd name="adj" fmla="val 9302"/>
             </a:avLst>
           </a:prstGeom>
           <a:solidFill>
@@ -6661,30 +6987,96 @@
       </p:sp>
       <p:sp>
         <p:nvSpPr>
-          <p:cNvPr id="18" name="Text 16"/>
-          <p:cNvSpPr txBox="1"/>
-          <p:nvPr/>
-        </p:nvSpPr>
-        <p:spPr>
-          <a:xfrm>
-            <a:off x="1188720" y="5029200"/>
-            <a:ext cx="4572000" cy="256032"/>
-          </a:xfrm>
-          <a:prstGeom prst="rect">
-            <a:avLst/>
-          </a:prstGeom>
-          <a:noFill/>
-          <a:ln/>
-        </p:spPr>
-        <p:txBody>
-          <a:bodyPr wrap="square" lIns="0" tIns="0" rIns="0" bIns="0" rtlCol="0" anchor="ctr"/>
-          <a:lstStyle/>
-          <a:p>
-            <a:pPr indent="0" marL="0">
-              <a:buNone/>
-            </a:pPr>
-            <a:r>
-              <a:rPr lang="en-US" sz="1350" b="1" dirty="0">
+          <p:cNvPr id="9" name="Shape 7"/>
+          <p:cNvSpPr/>
+          <p:nvPr/>
+        </p:nvSpPr>
+        <p:spPr>
+          <a:xfrm>
+            <a:off x="1069848" y="3191256"/>
+            <a:ext cx="1371600" cy="347472"/>
+          </a:xfrm>
+          <a:prstGeom prst="roundRect">
+            <a:avLst>
+              <a:gd name="adj" fmla="val 15789"/>
+            </a:avLst>
+          </a:prstGeom>
+          <a:solidFill>
+            <a:srgbClr val="FDF3E3"/>
+          </a:solidFill>
+          <a:ln w="12700">
+            <a:solidFill>
+              <a:srgbClr val="333333"/>
+            </a:solidFill>
+            <a:prstDash val="solid"/>
+          </a:ln>
+        </p:spPr>
+      </p:sp>
+      <p:sp>
+        <p:nvSpPr>
+          <p:cNvPr id="10" name="Text 8"/>
+          <p:cNvSpPr txBox="1"/>
+          <p:nvPr/>
+        </p:nvSpPr>
+        <p:spPr>
+          <a:xfrm>
+            <a:off x="1069848" y="3246120"/>
+            <a:ext cx="1371600" cy="237744"/>
+          </a:xfrm>
+          <a:prstGeom prst="rect">
+            <a:avLst/>
+          </a:prstGeom>
+          <a:noFill/>
+          <a:ln/>
+        </p:spPr>
+        <p:txBody>
+          <a:bodyPr wrap="square" lIns="0" tIns="0" rIns="0" bIns="0" rtlCol="0" anchor="ctr"/>
+          <a:lstStyle/>
+          <a:p>
+            <a:pPr algn="ctr" indent="0" marL="0">
+              <a:buNone/>
+            </a:pPr>
+            <a:r>
+              <a:rPr lang="en-US" sz="1150" b="1" dirty="0">
+                <a:solidFill>
+                  <a:srgbClr val="92580F"/>
+                </a:solidFill>
+                <a:latin typeface="Calibri" pitchFamily="34" charset="0"/>
+                <a:ea typeface="Calibri" pitchFamily="34" charset="-122"/>
+                <a:cs typeface="Calibri" pitchFamily="34" charset="-120"/>
+              </a:rPr>
+              <a:t>부분 구현</a:t>
+            </a:r>
+            <a:endParaRPr lang="en-US" sz="1150" dirty="0"/>
+          </a:p>
+        </p:txBody>
+      </p:sp>
+      <p:sp>
+        <p:nvSpPr>
+          <p:cNvPr id="11" name="Text 9"/>
+          <p:cNvSpPr txBox="1"/>
+          <p:nvPr/>
+        </p:nvSpPr>
+        <p:spPr>
+          <a:xfrm>
+            <a:off x="2651760" y="3227832"/>
+            <a:ext cx="8412480" cy="292608"/>
+          </a:xfrm>
+          <a:prstGeom prst="rect">
+            <a:avLst/>
+          </a:prstGeom>
+          <a:noFill/>
+          <a:ln/>
+        </p:spPr>
+        <p:txBody>
+          <a:bodyPr wrap="square" lIns="0" tIns="0" rIns="0" bIns="0" rtlCol="0" anchor="ctr"/>
+          <a:lstStyle/>
+          <a:p>
+            <a:pPr indent="0" marL="0">
+              <a:buNone/>
+            </a:pPr>
+            <a:r>
+              <a:rPr lang="en-US" sz="1350" dirty="0">
                 <a:solidFill>
                   <a:srgbClr val="0B1220"/>
                 </a:solidFill>
@@ -6692,7 +7084,7 @@
                 <a:ea typeface="Calibri" pitchFamily="34" charset="-122"/>
                 <a:cs typeface="Calibri" pitchFamily="34" charset="-120"/>
               </a:rPr>
-              <a:t>폐기한 지표의 예</a:t>
+              <a:t>편집(이미지 제외) · 업로드(외부 채널은 큐까지)</a:t>
             </a:r>
             <a:endParaRPr lang="en-US" sz="1350" dirty="0"/>
           </a:p>
@@ -6700,14 +7092,146 @@
       </p:sp>
       <p:sp>
         <p:nvSpPr>
-          <p:cNvPr id="19" name="Text 17"/>
-          <p:cNvSpPr txBox="1"/>
-          <p:nvPr/>
-        </p:nvSpPr>
-        <p:spPr>
-          <a:xfrm>
-            <a:off x="1188720" y="5340096"/>
-            <a:ext cx="9875520" cy="548640"/>
+          <p:cNvPr id="12" name="Shape 10"/>
+          <p:cNvSpPr/>
+          <p:nvPr/>
+        </p:nvSpPr>
+        <p:spPr>
+          <a:xfrm>
+            <a:off x="777240" y="3931920"/>
+            <a:ext cx="10607040" cy="786384"/>
+          </a:xfrm>
+          <a:prstGeom prst="roundRect">
+            <a:avLst>
+              <a:gd name="adj" fmla="val 9302"/>
+            </a:avLst>
+          </a:prstGeom>
+          <a:solidFill>
+            <a:srgbClr val="FFFFFF"/>
+          </a:solidFill>
+          <a:ln w="12700">
+            <a:solidFill>
+              <a:srgbClr val="E6E9EF"/>
+            </a:solidFill>
+            <a:prstDash val="solid"/>
+          </a:ln>
+        </p:spPr>
+      </p:sp>
+      <p:sp>
+        <p:nvSpPr>
+          <p:cNvPr id="13" name="Shape 11"/>
+          <p:cNvSpPr/>
+          <p:nvPr/>
+        </p:nvSpPr>
+        <p:spPr>
+          <a:xfrm>
+            <a:off x="1069848" y="4151376"/>
+            <a:ext cx="1371600" cy="347472"/>
+          </a:xfrm>
+          <a:prstGeom prst="roundRect">
+            <a:avLst>
+              <a:gd name="adj" fmla="val 15789"/>
+            </a:avLst>
+          </a:prstGeom>
+          <a:solidFill>
+            <a:srgbClr val="F0F2F6"/>
+          </a:solidFill>
+          <a:ln w="12700">
+            <a:solidFill>
+              <a:srgbClr val="333333"/>
+            </a:solidFill>
+            <a:prstDash val="solid"/>
+          </a:ln>
+        </p:spPr>
+      </p:sp>
+      <p:sp>
+        <p:nvSpPr>
+          <p:cNvPr id="14" name="Text 12"/>
+          <p:cNvSpPr txBox="1"/>
+          <p:nvPr/>
+        </p:nvSpPr>
+        <p:spPr>
+          <a:xfrm>
+            <a:off x="1069848" y="4206240"/>
+            <a:ext cx="1371600" cy="237744"/>
+          </a:xfrm>
+          <a:prstGeom prst="rect">
+            <a:avLst/>
+          </a:prstGeom>
+          <a:noFill/>
+          <a:ln/>
+        </p:spPr>
+        <p:txBody>
+          <a:bodyPr wrap="square" lIns="0" tIns="0" rIns="0" bIns="0" rtlCol="0" anchor="ctr"/>
+          <a:lstStyle/>
+          <a:p>
+            <a:pPr algn="ctr" indent="0" marL="0">
+              <a:buNone/>
+            </a:pPr>
+            <a:r>
+              <a:rPr lang="en-US" sz="1150" b="1" dirty="0">
+                <a:solidFill>
+                  <a:srgbClr val="6E7A8A"/>
+                </a:solidFill>
+                <a:latin typeface="Calibri" pitchFamily="34" charset="0"/>
+                <a:ea typeface="Calibri" pitchFamily="34" charset="-122"/>
+                <a:cs typeface="Calibri" pitchFamily="34" charset="-120"/>
+              </a:rPr>
+              <a:t>설계만</a:t>
+            </a:r>
+            <a:endParaRPr lang="en-US" sz="1150" dirty="0"/>
+          </a:p>
+        </p:txBody>
+      </p:sp>
+      <p:sp>
+        <p:nvSpPr>
+          <p:cNvPr id="15" name="Text 13"/>
+          <p:cNvSpPr txBox="1"/>
+          <p:nvPr/>
+        </p:nvSpPr>
+        <p:spPr>
+          <a:xfrm>
+            <a:off x="2651760" y="4187952"/>
+            <a:ext cx="8412480" cy="292608"/>
+          </a:xfrm>
+          <a:prstGeom prst="rect">
+            <a:avLst/>
+          </a:prstGeom>
+          <a:noFill/>
+          <a:ln/>
+        </p:spPr>
+        <p:txBody>
+          <a:bodyPr wrap="square" lIns="0" tIns="0" rIns="0" bIns="0" rtlCol="0" anchor="ctr"/>
+          <a:lstStyle/>
+          <a:p>
+            <a:pPr indent="0" marL="0">
+              <a:buNone/>
+            </a:pPr>
+            <a:r>
+              <a:rPr lang="en-US" sz="1350" dirty="0">
+                <a:solidFill>
+                  <a:srgbClr val="0B1220"/>
+                </a:solidFill>
+                <a:latin typeface="Calibri" pitchFamily="34" charset="0"/>
+                <a:ea typeface="Calibri" pitchFamily="34" charset="-122"/>
+                <a:cs typeface="Calibri" pitchFamily="34" charset="-120"/>
+              </a:rPr>
+              <a:t>SNS 확산 — 채널별 포맷 변환</a:t>
+            </a:r>
+            <a:endParaRPr lang="en-US" sz="1350" dirty="0"/>
+          </a:p>
+        </p:txBody>
+      </p:sp>
+      <p:sp>
+        <p:nvSpPr>
+          <p:cNvPr id="16" name="Text 14"/>
+          <p:cNvSpPr txBox="1"/>
+          <p:nvPr/>
+        </p:nvSpPr>
+        <p:spPr>
+          <a:xfrm>
+            <a:off x="777240" y="5120640"/>
+            <a:ext cx="10424160" cy="548640"/>
           </a:xfrm>
           <a:prstGeom prst="rect">
             <a:avLst/>
@@ -6721,22 +7245,22 @@
           <a:p>
             <a:pPr indent="0" marL="0">
               <a:lnSpc>
-                <a:spcPts val="1800"/>
+                <a:spcPts val="2000"/>
               </a:lnSpc>
               <a:buNone/>
             </a:pPr>
             <a:r>
-              <a:rPr lang="en-US" sz="1250" dirty="0">
-                <a:solidFill>
-                  <a:srgbClr val="6E7A8A"/>
-                </a:solidFill>
-                <a:latin typeface="Calibri" pitchFamily="34" charset="0"/>
-                <a:ea typeface="Calibri" pitchFamily="34" charset="-122"/>
-                <a:cs typeface="Calibri" pitchFamily="34" charset="-120"/>
-              </a:rPr>
-              <a:t>“자사 글은 굵은 글씨를 쓰지 않는다”는 신호로 30점 차이를 만들었지만, 원본을 다시 확인하니 실제로는 1,000자당 9.73회 사용하고 있었습니다. 저희 수집 과정이 만든 착시였고, 그 신호는 폐기했습니다.</a:t>
-            </a:r>
-            <a:endParaRPr lang="en-US" sz="1250" dirty="0"/>
+              <a:rPr lang="en-US" sz="1300" dirty="0">
+                <a:solidFill>
+                  <a:srgbClr val="38445A"/>
+                </a:solidFill>
+                <a:latin typeface="Calibri" pitchFamily="34" charset="0"/>
+                <a:ea typeface="Calibri" pitchFamily="34" charset="-122"/>
+                <a:cs typeface="Calibri" pitchFamily="34" charset="-120"/>
+              </a:rPr>
+              <a:t>링크드인 실제 발행만 못 했습니다. 조직 페이지 발행에는 별도 승인이 필요한데, 저희가 받은 실데이터의 출처가 바로 그 API입니다 — 코드프레소는 이미 권한을 갖고 있습니다.</a:t>
+            </a:r>
+            <a:endParaRPr lang="en-US" sz="1300" dirty="0"/>
           </a:p>
         </p:txBody>
       </p:sp>
@@ -6751,13 +7275,6 @@
 <file path=ppt/slides/slide8.xml><?xml version="1.0" encoding="utf-8"?>
 <p:sld xmlns:a="http://schemas.openxmlformats.org/drawingml/2006/main" xmlns:r="http://schemas.openxmlformats.org/officeDocument/2006/relationships" xmlns:p="http://schemas.openxmlformats.org/presentationml/2006/main">
   <p:cSld name="Slide 8">
-    <p:bg>
-      <p:bgPr>
-        <a:solidFill>
-          <a:srgbClr val="F5F6F8"/>
-        </a:solidFill>
-      </p:bgPr>
-    </p:bg>
     <p:spTree>
       <p:nvGrpSpPr>
         <p:cNvPr id="1" name=""/>
@@ -6774,125 +7291,20 @@
       </p:grpSpPr>
       <p:sp>
         <p:nvSpPr>
-          <p:cNvPr id="2" name="Text 0"/>
-          <p:cNvSpPr txBox="1"/>
-          <p:nvPr/>
-        </p:nvSpPr>
-        <p:spPr>
-          <a:xfrm>
-            <a:off x="777240" y="384048"/>
-            <a:ext cx="7315200" cy="237744"/>
-          </a:xfrm>
-          <a:prstGeom prst="rect">
-            <a:avLst/>
-          </a:prstGeom>
-          <a:noFill/>
-          <a:ln/>
-        </p:spPr>
-        <p:txBody>
-          <a:bodyPr wrap="square" lIns="0" tIns="0" rIns="0" bIns="0" rtlCol="0" anchor="ctr"/>
-          <a:lstStyle/>
-          <a:p>
-            <a:pPr indent="0" marL="0">
-              <a:buNone/>
-            </a:pPr>
-            <a:r>
-              <a:rPr lang="en-US" sz="1100" b="1" spc="200" kern="0" dirty="0">
-                <a:solidFill>
-                  <a:srgbClr val="1A61EA"/>
-                </a:solidFill>
-                <a:latin typeface="Calibri" pitchFamily="34" charset="0"/>
-                <a:ea typeface="Calibri" pitchFamily="34" charset="-122"/>
-                <a:cs typeface="Calibri" pitchFamily="34" charset="-120"/>
-              </a:rPr>
-              <a:t>신뢰</a:t>
-            </a:r>
-            <a:endParaRPr lang="en-US" sz="1100" dirty="0"/>
-          </a:p>
-        </p:txBody>
-      </p:sp>
-      <p:sp>
-        <p:nvSpPr>
-          <p:cNvPr id="3" name="Text 1"/>
-          <p:cNvSpPr txBox="1"/>
-          <p:nvPr/>
-        </p:nvSpPr>
-        <p:spPr>
-          <a:xfrm>
-            <a:off x="777240" y="658368"/>
-            <a:ext cx="10607040" cy="566928"/>
-          </a:xfrm>
-          <a:prstGeom prst="rect">
-            <a:avLst/>
-          </a:prstGeom>
-          <a:noFill/>
-          <a:ln/>
-        </p:spPr>
-        <p:txBody>
-          <a:bodyPr wrap="square" lIns="0" tIns="0" rIns="0" bIns="0" rtlCol="0" anchor="ctr"/>
-          <a:lstStyle/>
-          <a:p>
-            <a:pPr indent="0" marL="0">
-              <a:buNone/>
-            </a:pPr>
-            <a:r>
-              <a:rPr lang="en-US" sz="3000" b="1" dirty="0">
-                <a:solidFill>
-                  <a:srgbClr val="0B1220"/>
-                </a:solidFill>
-                <a:latin typeface="Calibri" pitchFamily="34" charset="0"/>
-                <a:ea typeface="Calibri" pitchFamily="34" charset="-122"/>
-                <a:cs typeface="Calibri" pitchFamily="34" charset="-120"/>
-              </a:rPr>
-              <a:t>결과를 믿을 수 있는 근거</a:t>
-            </a:r>
-            <a:endParaRPr lang="en-US" sz="3000" dirty="0"/>
-          </a:p>
-        </p:txBody>
-      </p:sp>
-      <p:sp>
-        <p:nvSpPr>
-          <p:cNvPr id="4" name="Shape 2"/>
+          <p:cNvPr id="2" name="Shape 0"/>
           <p:cNvSpPr/>
           <p:nvPr/>
         </p:nvSpPr>
         <p:spPr>
           <a:xfrm>
-            <a:off x="777240" y="1783080"/>
-            <a:ext cx="5120640" cy="1234440"/>
-          </a:xfrm>
-          <a:prstGeom prst="roundRect">
-            <a:avLst>
-              <a:gd name="adj" fmla="val 5926"/>
-            </a:avLst>
+            <a:off x="0" y="0"/>
+            <a:ext cx="12161520" cy="6858000"/>
+          </a:xfrm>
+          <a:prstGeom prst="rect">
+            <a:avLst/>
           </a:prstGeom>
           <a:solidFill>
-            <a:srgbClr val="FFFFFF"/>
-          </a:solidFill>
-          <a:ln w="12700">
-            <a:solidFill>
-              <a:srgbClr val="E6E9EF"/>
-            </a:solidFill>
-            <a:prstDash val="solid"/>
-          </a:ln>
-        </p:spPr>
-      </p:sp>
-      <p:sp>
-        <p:nvSpPr>
-          <p:cNvPr id="5" name="Shape 3"/>
-          <p:cNvSpPr/>
-          <p:nvPr/>
-        </p:nvSpPr>
-        <p:spPr>
-          <a:xfrm>
-            <a:off x="1051560" y="2057400"/>
-            <a:ext cx="310896" cy="310896"/>
-          </a:xfrm>
-          <a:prstGeom prst="ellipse">
-            <a:avLst/>
-          </a:prstGeom>
-          <a:solidFill>
-            <a:srgbClr val="E7EEFD"/>
+            <a:srgbClr val="0B1220"/>
           </a:solidFill>
           <a:ln w="12700">
             <a:solidFill>
@@ -6904,167 +7316,98 @@
       </p:sp>
       <p:sp>
         <p:nvSpPr>
-          <p:cNvPr id="6" name="Text 4"/>
-          <p:cNvSpPr txBox="1"/>
-          <p:nvPr/>
-        </p:nvSpPr>
-        <p:spPr>
-          <a:xfrm>
-            <a:off x="1051560" y="2093976"/>
-            <a:ext cx="310896" cy="237744"/>
-          </a:xfrm>
-          <a:prstGeom prst="rect">
-            <a:avLst/>
-          </a:prstGeom>
-          <a:noFill/>
-          <a:ln/>
-        </p:spPr>
-        <p:txBody>
-          <a:bodyPr wrap="square" lIns="0" tIns="0" rIns="0" bIns="0" rtlCol="0" anchor="ctr"/>
-          <a:lstStyle/>
-          <a:p>
-            <a:pPr algn="ctr" indent="0" marL="0">
-              <a:buNone/>
-            </a:pPr>
-            <a:r>
-              <a:rPr lang="en-US" sz="1200" b="1" dirty="0">
-                <a:solidFill>
-                  <a:srgbClr val="1A61EA"/>
-                </a:solidFill>
-                <a:latin typeface="Calibri" pitchFamily="34" charset="0"/>
-                <a:ea typeface="Calibri" pitchFamily="34" charset="-122"/>
-                <a:cs typeface="Calibri" pitchFamily="34" charset="-120"/>
-              </a:rPr>
-              <a:t>1</a:t>
-            </a:r>
-            <a:endParaRPr lang="en-US" sz="1200" dirty="0"/>
-          </a:p>
-        </p:txBody>
-      </p:sp>
-      <p:sp>
-        <p:nvSpPr>
-          <p:cNvPr id="7" name="Text 5"/>
-          <p:cNvSpPr txBox="1"/>
-          <p:nvPr/>
-        </p:nvSpPr>
-        <p:spPr>
-          <a:xfrm>
-            <a:off x="1490472" y="2039112"/>
-            <a:ext cx="4114800" cy="274320"/>
-          </a:xfrm>
-          <a:prstGeom prst="rect">
-            <a:avLst/>
-          </a:prstGeom>
-          <a:noFill/>
-          <a:ln/>
-        </p:spPr>
-        <p:txBody>
-          <a:bodyPr wrap="square" lIns="0" tIns="0" rIns="0" bIns="0" rtlCol="0" anchor="ctr"/>
-          <a:lstStyle/>
-          <a:p>
-            <a:pPr indent="0" marL="0">
-              <a:buNone/>
-            </a:pPr>
-            <a:r>
-              <a:rPr lang="en-US" sz="1450" b="1" dirty="0">
-                <a:solidFill>
-                  <a:srgbClr val="0B1220"/>
-                </a:solidFill>
-                <a:latin typeface="Calibri" pitchFamily="34" charset="0"/>
-                <a:ea typeface="Calibri" pitchFamily="34" charset="-122"/>
-                <a:cs typeface="Calibri" pitchFamily="34" charset="-120"/>
-              </a:rPr>
-              <a:t>승인 게이트</a:t>
-            </a:r>
-            <a:endParaRPr lang="en-US" sz="1450" dirty="0"/>
-          </a:p>
-        </p:txBody>
-      </p:sp>
-      <p:sp>
-        <p:nvSpPr>
-          <p:cNvPr id="8" name="Text 6"/>
-          <p:cNvSpPr txBox="1"/>
-          <p:nvPr/>
-        </p:nvSpPr>
-        <p:spPr>
-          <a:xfrm>
-            <a:off x="1490472" y="2350008"/>
-            <a:ext cx="4114800" cy="548640"/>
-          </a:xfrm>
-          <a:prstGeom prst="rect">
-            <a:avLst/>
-          </a:prstGeom>
-          <a:noFill/>
-          <a:ln/>
-        </p:spPr>
-        <p:txBody>
-          <a:bodyPr wrap="square" lIns="0" tIns="0" rIns="0" bIns="0" rtlCol="0" anchor="ctr"/>
-          <a:lstStyle/>
-          <a:p>
-            <a:pPr indent="0" marL="0">
-              <a:lnSpc>
-                <a:spcPts val="1700"/>
-              </a:lnSpc>
-              <a:buNone/>
-            </a:pPr>
-            <a:r>
-              <a:rPr lang="en-US" sz="1200" dirty="0">
-                <a:solidFill>
-                  <a:srgbClr val="6E7A8A"/>
-                </a:solidFill>
-                <a:latin typeface="Calibri" pitchFamily="34" charset="0"/>
-                <a:ea typeface="Calibri" pitchFamily="34" charset="-122"/>
-                <a:cs typeface="Calibri" pitchFamily="34" charset="-120"/>
-              </a:rPr>
-              <a:t>사람의 결정 없이는 발행되지 않습니다. 반려에는 사유 입력이 필수입니다.</a:t>
-            </a:r>
-            <a:endParaRPr lang="en-US" sz="1200" dirty="0"/>
-          </a:p>
-        </p:txBody>
-      </p:sp>
-      <p:sp>
-        <p:nvSpPr>
-          <p:cNvPr id="9" name="Shape 7"/>
+          <p:cNvPr id="3" name="Text 1"/>
+          <p:cNvSpPr txBox="1"/>
+          <p:nvPr/>
+        </p:nvSpPr>
+        <p:spPr>
+          <a:xfrm>
+            <a:off x="777240" y="2651760"/>
+            <a:ext cx="10058400" cy="731520"/>
+          </a:xfrm>
+          <a:prstGeom prst="rect">
+            <a:avLst/>
+          </a:prstGeom>
+          <a:noFill/>
+          <a:ln/>
+        </p:spPr>
+        <p:txBody>
+          <a:bodyPr wrap="square" lIns="0" tIns="0" rIns="0" bIns="0" rtlCol="0" anchor="ctr"/>
+          <a:lstStyle/>
+          <a:p>
+            <a:pPr indent="0" marL="0">
+              <a:buNone/>
+            </a:pPr>
+            <a:r>
+              <a:rPr lang="en-US" sz="4000" b="1" dirty="0">
+                <a:solidFill>
+                  <a:srgbClr val="FFFFFF"/>
+                </a:solidFill>
+                <a:latin typeface="Calibri" pitchFamily="34" charset="0"/>
+                <a:ea typeface="Calibri" pitchFamily="34" charset="-122"/>
+                <a:cs typeface="Calibri" pitchFamily="34" charset="-120"/>
+              </a:rPr>
+              <a:t>감사합니다</a:t>
+            </a:r>
+            <a:endParaRPr lang="en-US" sz="4000" dirty="0"/>
+          </a:p>
+        </p:txBody>
+      </p:sp>
+      <p:sp>
+        <p:nvSpPr>
+          <p:cNvPr id="4" name="Text 2"/>
+          <p:cNvSpPr txBox="1"/>
+          <p:nvPr/>
+        </p:nvSpPr>
+        <p:spPr>
+          <a:xfrm>
+            <a:off x="777240" y="3520440"/>
+            <a:ext cx="10058400" cy="411480"/>
+          </a:xfrm>
+          <a:prstGeom prst="rect">
+            <a:avLst/>
+          </a:prstGeom>
+          <a:noFill/>
+          <a:ln/>
+        </p:spPr>
+        <p:txBody>
+          <a:bodyPr wrap="square" lIns="0" tIns="0" rIns="0" bIns="0" rtlCol="0" anchor="ctr"/>
+          <a:lstStyle/>
+          <a:p>
+            <a:pPr indent="0" marL="0">
+              <a:buNone/>
+            </a:pPr>
+            <a:r>
+              <a:rPr lang="en-US" sz="1700" dirty="0">
+                <a:solidFill>
+                  <a:srgbClr val="C7D4EA"/>
+                </a:solidFill>
+                <a:latin typeface="Calibri" pitchFamily="34" charset="0"/>
+                <a:ea typeface="Calibri" pitchFamily="34" charset="-122"/>
+                <a:cs typeface="Calibri" pitchFamily="34" charset="-120"/>
+              </a:rPr>
+              <a:t>여덟 단계를 자동화한 것이 아니라, 판단이 쌓이는 회로를 만들었습니다.</a:t>
+            </a:r>
+            <a:endParaRPr lang="en-US" sz="1700" dirty="0"/>
+          </a:p>
+        </p:txBody>
+      </p:sp>
+      <p:sp>
+        <p:nvSpPr>
+          <p:cNvPr id="5" name="Shape 3"/>
           <p:cNvSpPr/>
           <p:nvPr/>
         </p:nvSpPr>
         <p:spPr>
           <a:xfrm>
-            <a:off x="6172200" y="1783080"/>
-            <a:ext cx="5120640" cy="1234440"/>
-          </a:xfrm>
-          <a:prstGeom prst="roundRect">
-            <a:avLst>
-              <a:gd name="adj" fmla="val 5926"/>
-            </a:avLst>
+            <a:off x="777240" y="4206240"/>
+            <a:ext cx="1005840" cy="32004"/>
+          </a:xfrm>
+          <a:prstGeom prst="rect">
+            <a:avLst/>
           </a:prstGeom>
           <a:solidFill>
-            <a:srgbClr val="FFFFFF"/>
-          </a:solidFill>
-          <a:ln w="12700">
-            <a:solidFill>
-              <a:srgbClr val="E6E9EF"/>
-            </a:solidFill>
-            <a:prstDash val="solid"/>
-          </a:ln>
-        </p:spPr>
-      </p:sp>
-      <p:sp>
-        <p:nvSpPr>
-          <p:cNvPr id="10" name="Shape 8"/>
-          <p:cNvSpPr/>
-          <p:nvPr/>
-        </p:nvSpPr>
-        <p:spPr>
-          <a:xfrm>
-            <a:off x="6446520" y="2057400"/>
-            <a:ext cx="310896" cy="310896"/>
-          </a:xfrm>
-          <a:prstGeom prst="ellipse">
-            <a:avLst/>
-          </a:prstGeom>
-          <a:solidFill>
-            <a:srgbClr val="E7EEFD"/>
+            <a:srgbClr val="1A61EA"/>
           </a:solidFill>
           <a:ln w="12700">
             <a:solidFill>
@@ -7076,532 +7419,77 @@
       </p:sp>
       <p:sp>
         <p:nvSpPr>
-          <p:cNvPr id="11" name="Text 9"/>
-          <p:cNvSpPr txBox="1"/>
-          <p:nvPr/>
-        </p:nvSpPr>
-        <p:spPr>
-          <a:xfrm>
-            <a:off x="6446520" y="2093976"/>
-            <a:ext cx="310896" cy="237744"/>
-          </a:xfrm>
-          <a:prstGeom prst="rect">
-            <a:avLst/>
-          </a:prstGeom>
-          <a:noFill/>
-          <a:ln/>
-        </p:spPr>
-        <p:txBody>
-          <a:bodyPr wrap="square" lIns="0" tIns="0" rIns="0" bIns="0" rtlCol="0" anchor="ctr"/>
-          <a:lstStyle/>
-          <a:p>
-            <a:pPr algn="ctr" indent="0" marL="0">
-              <a:buNone/>
-            </a:pPr>
-            <a:r>
-              <a:rPr lang="en-US" sz="1200" b="1" dirty="0">
-                <a:solidFill>
-                  <a:srgbClr val="1A61EA"/>
-                </a:solidFill>
-                <a:latin typeface="Calibri" pitchFamily="34" charset="0"/>
-                <a:ea typeface="Calibri" pitchFamily="34" charset="-122"/>
-                <a:cs typeface="Calibri" pitchFamily="34" charset="-120"/>
-              </a:rPr>
-              <a:t>2</a:t>
-            </a:r>
-            <a:endParaRPr lang="en-US" sz="1200" dirty="0"/>
-          </a:p>
-        </p:txBody>
-      </p:sp>
-      <p:sp>
-        <p:nvSpPr>
-          <p:cNvPr id="12" name="Text 10"/>
-          <p:cNvSpPr txBox="1"/>
-          <p:nvPr/>
-        </p:nvSpPr>
-        <p:spPr>
-          <a:xfrm>
-            <a:off x="6885432" y="2039112"/>
-            <a:ext cx="4114800" cy="274320"/>
-          </a:xfrm>
-          <a:prstGeom prst="rect">
-            <a:avLst/>
-          </a:prstGeom>
-          <a:noFill/>
-          <a:ln/>
-        </p:spPr>
-        <p:txBody>
-          <a:bodyPr wrap="square" lIns="0" tIns="0" rIns="0" bIns="0" rtlCol="0" anchor="ctr"/>
-          <a:lstStyle/>
-          <a:p>
-            <a:pPr indent="0" marL="0">
-              <a:buNone/>
-            </a:pPr>
-            <a:r>
-              <a:rPr lang="en-US" sz="1450" b="1" dirty="0">
-                <a:solidFill>
-                  <a:srgbClr val="0B1220"/>
-                </a:solidFill>
-                <a:latin typeface="Calibri" pitchFamily="34" charset="0"/>
-                <a:ea typeface="Calibri" pitchFamily="34" charset="-122"/>
-                <a:cs typeface="Calibri" pitchFamily="34" charset="-120"/>
-              </a:rPr>
-              <a:t>판단 로그</a:t>
-            </a:r>
-            <a:endParaRPr lang="en-US" sz="1450" dirty="0"/>
-          </a:p>
-        </p:txBody>
-      </p:sp>
-      <p:sp>
-        <p:nvSpPr>
-          <p:cNvPr id="13" name="Text 11"/>
-          <p:cNvSpPr txBox="1"/>
-          <p:nvPr/>
-        </p:nvSpPr>
-        <p:spPr>
-          <a:xfrm>
-            <a:off x="6885432" y="2350008"/>
-            <a:ext cx="4114800" cy="548640"/>
-          </a:xfrm>
-          <a:prstGeom prst="rect">
-            <a:avLst/>
-          </a:prstGeom>
-          <a:noFill/>
-          <a:ln/>
-        </p:spPr>
-        <p:txBody>
-          <a:bodyPr wrap="square" lIns="0" tIns="0" rIns="0" bIns="0" rtlCol="0" anchor="ctr"/>
-          <a:lstStyle/>
-          <a:p>
-            <a:pPr indent="0" marL="0">
-              <a:lnSpc>
-                <a:spcPts val="1700"/>
-              </a:lnSpc>
-              <a:buNone/>
-            </a:pPr>
-            <a:r>
-              <a:rPr lang="en-US" sz="1200" dirty="0">
-                <a:solidFill>
-                  <a:srgbClr val="6E7A8A"/>
-                </a:solidFill>
-                <a:latin typeface="Calibri" pitchFamily="34" charset="0"/>
-                <a:ea typeface="Calibri" pitchFamily="34" charset="-122"/>
-                <a:cs typeface="Calibri" pitchFamily="34" charset="-120"/>
-              </a:rPr>
-              <a:t>모든 결정이 누가·언제·왜와 함께 남고, 사람의 결정과 시스템의 실행이 구분됩니다.</a:t>
-            </a:r>
-            <a:endParaRPr lang="en-US" sz="1200" dirty="0"/>
-          </a:p>
-        </p:txBody>
-      </p:sp>
-      <p:sp>
-        <p:nvSpPr>
-          <p:cNvPr id="14" name="Shape 12"/>
-          <p:cNvSpPr/>
-          <p:nvPr/>
-        </p:nvSpPr>
-        <p:spPr>
-          <a:xfrm>
-            <a:off x="777240" y="3246120"/>
-            <a:ext cx="5120640" cy="1234440"/>
-          </a:xfrm>
-          <a:prstGeom prst="roundRect">
-            <a:avLst>
-              <a:gd name="adj" fmla="val 5926"/>
-            </a:avLst>
-          </a:prstGeom>
-          <a:solidFill>
-            <a:srgbClr val="FFFFFF"/>
-          </a:solidFill>
-          <a:ln w="12700">
-            <a:solidFill>
-              <a:srgbClr val="E6E9EF"/>
-            </a:solidFill>
-            <a:prstDash val="solid"/>
-          </a:ln>
-        </p:spPr>
-      </p:sp>
-      <p:sp>
-        <p:nvSpPr>
-          <p:cNvPr id="15" name="Shape 13"/>
-          <p:cNvSpPr/>
-          <p:nvPr/>
-        </p:nvSpPr>
-        <p:spPr>
-          <a:xfrm>
-            <a:off x="1051560" y="3520440"/>
-            <a:ext cx="310896" cy="310896"/>
-          </a:xfrm>
-          <a:prstGeom prst="ellipse">
-            <a:avLst/>
-          </a:prstGeom>
-          <a:solidFill>
-            <a:srgbClr val="E7EEFD"/>
-          </a:solidFill>
-          <a:ln w="12700">
-            <a:solidFill>
-              <a:srgbClr val="333333"/>
-            </a:solidFill>
-            <a:prstDash val="solid"/>
-          </a:ln>
-        </p:spPr>
-      </p:sp>
-      <p:sp>
-        <p:nvSpPr>
-          <p:cNvPr id="16" name="Text 14"/>
-          <p:cNvSpPr txBox="1"/>
-          <p:nvPr/>
-        </p:nvSpPr>
-        <p:spPr>
-          <a:xfrm>
-            <a:off x="1051560" y="3557016"/>
-            <a:ext cx="310896" cy="237744"/>
-          </a:xfrm>
-          <a:prstGeom prst="rect">
-            <a:avLst/>
-          </a:prstGeom>
-          <a:noFill/>
-          <a:ln/>
-        </p:spPr>
-        <p:txBody>
-          <a:bodyPr wrap="square" lIns="0" tIns="0" rIns="0" bIns="0" rtlCol="0" anchor="ctr"/>
-          <a:lstStyle/>
-          <a:p>
-            <a:pPr algn="ctr" indent="0" marL="0">
-              <a:buNone/>
-            </a:pPr>
-            <a:r>
-              <a:rPr lang="en-US" sz="1200" b="1" dirty="0">
-                <a:solidFill>
-                  <a:srgbClr val="1A61EA"/>
-                </a:solidFill>
-                <a:latin typeface="Calibri" pitchFamily="34" charset="0"/>
-                <a:ea typeface="Calibri" pitchFamily="34" charset="-122"/>
-                <a:cs typeface="Calibri" pitchFamily="34" charset="-120"/>
-              </a:rPr>
-              <a:t>3</a:t>
-            </a:r>
-            <a:endParaRPr lang="en-US" sz="1200" dirty="0"/>
-          </a:p>
-        </p:txBody>
-      </p:sp>
-      <p:sp>
-        <p:nvSpPr>
-          <p:cNvPr id="17" name="Text 15"/>
-          <p:cNvSpPr txBox="1"/>
-          <p:nvPr/>
-        </p:nvSpPr>
-        <p:spPr>
-          <a:xfrm>
-            <a:off x="1490472" y="3502152"/>
-            <a:ext cx="4114800" cy="274320"/>
-          </a:xfrm>
-          <a:prstGeom prst="rect">
-            <a:avLst/>
-          </a:prstGeom>
-          <a:noFill/>
-          <a:ln/>
-        </p:spPr>
-        <p:txBody>
-          <a:bodyPr wrap="square" lIns="0" tIns="0" rIns="0" bIns="0" rtlCol="0" anchor="ctr"/>
-          <a:lstStyle/>
-          <a:p>
-            <a:pPr indent="0" marL="0">
-              <a:buNone/>
-            </a:pPr>
-            <a:r>
-              <a:rPr lang="en-US" sz="1450" b="1" dirty="0">
-                <a:solidFill>
-                  <a:srgbClr val="0B1220"/>
-                </a:solidFill>
-                <a:latin typeface="Calibri" pitchFamily="34" charset="0"/>
-                <a:ea typeface="Calibri" pitchFamily="34" charset="-122"/>
-                <a:cs typeface="Calibri" pitchFamily="34" charset="-120"/>
-              </a:rPr>
-              <a:t>추적성</a:t>
-            </a:r>
-            <a:endParaRPr lang="en-US" sz="1450" dirty="0"/>
-          </a:p>
-        </p:txBody>
-      </p:sp>
-      <p:sp>
-        <p:nvSpPr>
-          <p:cNvPr id="18" name="Text 16"/>
-          <p:cNvSpPr txBox="1"/>
-          <p:nvPr/>
-        </p:nvSpPr>
-        <p:spPr>
-          <a:xfrm>
-            <a:off x="1490472" y="3813048"/>
-            <a:ext cx="4114800" cy="548640"/>
-          </a:xfrm>
-          <a:prstGeom prst="rect">
-            <a:avLst/>
-          </a:prstGeom>
-          <a:noFill/>
-          <a:ln/>
-        </p:spPr>
-        <p:txBody>
-          <a:bodyPr wrap="square" lIns="0" tIns="0" rIns="0" bIns="0" rtlCol="0" anchor="ctr"/>
-          <a:lstStyle/>
-          <a:p>
-            <a:pPr indent="0" marL="0">
-              <a:lnSpc>
-                <a:spcPts val="1700"/>
-              </a:lnSpc>
-              <a:buNone/>
-            </a:pPr>
-            <a:r>
-              <a:rPr lang="en-US" sz="1200" dirty="0">
-                <a:solidFill>
-                  <a:srgbClr val="6E7A8A"/>
-                </a:solidFill>
-                <a:latin typeface="Calibri" pitchFamily="34" charset="0"/>
-                <a:ea typeface="Calibri" pitchFamily="34" charset="-122"/>
-                <a:cs typeface="Calibri" pitchFamily="34" charset="-120"/>
-              </a:rPr>
-              <a:t>추천 → 콘텐츠 → 발행 → 문의가 하나의 식별자로 이어집니다.</a:t>
-            </a:r>
-            <a:endParaRPr lang="en-US" sz="1200" dirty="0"/>
-          </a:p>
-        </p:txBody>
-      </p:sp>
-      <p:sp>
-        <p:nvSpPr>
-          <p:cNvPr id="19" name="Shape 17"/>
-          <p:cNvSpPr/>
-          <p:nvPr/>
-        </p:nvSpPr>
-        <p:spPr>
-          <a:xfrm>
-            <a:off x="6172200" y="3246120"/>
-            <a:ext cx="5120640" cy="1234440"/>
-          </a:xfrm>
-          <a:prstGeom prst="roundRect">
-            <a:avLst>
-              <a:gd name="adj" fmla="val 5926"/>
-            </a:avLst>
-          </a:prstGeom>
-          <a:solidFill>
-            <a:srgbClr val="FFFFFF"/>
-          </a:solidFill>
-          <a:ln w="12700">
-            <a:solidFill>
-              <a:srgbClr val="E6E9EF"/>
-            </a:solidFill>
-            <a:prstDash val="solid"/>
-          </a:ln>
-        </p:spPr>
-      </p:sp>
-      <p:sp>
-        <p:nvSpPr>
-          <p:cNvPr id="20" name="Shape 18"/>
-          <p:cNvSpPr/>
-          <p:nvPr/>
-        </p:nvSpPr>
-        <p:spPr>
-          <a:xfrm>
-            <a:off x="6446520" y="3520440"/>
-            <a:ext cx="310896" cy="310896"/>
-          </a:xfrm>
-          <a:prstGeom prst="ellipse">
-            <a:avLst/>
-          </a:prstGeom>
-          <a:solidFill>
-            <a:srgbClr val="E7EEFD"/>
-          </a:solidFill>
-          <a:ln w="12700">
-            <a:solidFill>
-              <a:srgbClr val="333333"/>
-            </a:solidFill>
-            <a:prstDash val="solid"/>
-          </a:ln>
-        </p:spPr>
-      </p:sp>
-      <p:sp>
-        <p:nvSpPr>
-          <p:cNvPr id="21" name="Text 19"/>
-          <p:cNvSpPr txBox="1"/>
-          <p:nvPr/>
-        </p:nvSpPr>
-        <p:spPr>
-          <a:xfrm>
-            <a:off x="6446520" y="3557016"/>
-            <a:ext cx="310896" cy="237744"/>
-          </a:xfrm>
-          <a:prstGeom prst="rect">
-            <a:avLst/>
-          </a:prstGeom>
-          <a:noFill/>
-          <a:ln/>
-        </p:spPr>
-        <p:txBody>
-          <a:bodyPr wrap="square" lIns="0" tIns="0" rIns="0" bIns="0" rtlCol="0" anchor="ctr"/>
-          <a:lstStyle/>
-          <a:p>
-            <a:pPr algn="ctr" indent="0" marL="0">
-              <a:buNone/>
-            </a:pPr>
-            <a:r>
-              <a:rPr lang="en-US" sz="1200" b="1" dirty="0">
-                <a:solidFill>
-                  <a:srgbClr val="1A61EA"/>
-                </a:solidFill>
-                <a:latin typeface="Calibri" pitchFamily="34" charset="0"/>
-                <a:ea typeface="Calibri" pitchFamily="34" charset="-122"/>
-                <a:cs typeface="Calibri" pitchFamily="34" charset="-120"/>
-              </a:rPr>
-              <a:t>4</a:t>
-            </a:r>
-            <a:endParaRPr lang="en-US" sz="1200" dirty="0"/>
-          </a:p>
-        </p:txBody>
-      </p:sp>
-      <p:sp>
-        <p:nvSpPr>
-          <p:cNvPr id="22" name="Text 20"/>
-          <p:cNvSpPr txBox="1"/>
-          <p:nvPr/>
-        </p:nvSpPr>
-        <p:spPr>
-          <a:xfrm>
-            <a:off x="6885432" y="3502152"/>
-            <a:ext cx="4114800" cy="274320"/>
-          </a:xfrm>
-          <a:prstGeom prst="rect">
-            <a:avLst/>
-          </a:prstGeom>
-          <a:noFill/>
-          <a:ln/>
-        </p:spPr>
-        <p:txBody>
-          <a:bodyPr wrap="square" lIns="0" tIns="0" rIns="0" bIns="0" rtlCol="0" anchor="ctr"/>
-          <a:lstStyle/>
-          <a:p>
-            <a:pPr indent="0" marL="0">
-              <a:buNone/>
-            </a:pPr>
-            <a:r>
-              <a:rPr lang="en-US" sz="1450" b="1" dirty="0">
-                <a:solidFill>
-                  <a:srgbClr val="0B1220"/>
-                </a:solidFill>
-                <a:latin typeface="Calibri" pitchFamily="34" charset="0"/>
-                <a:ea typeface="Calibri" pitchFamily="34" charset="-122"/>
-                <a:cs typeface="Calibri" pitchFamily="34" charset="-120"/>
-              </a:rPr>
-              <a:t>오류 대응</a:t>
-            </a:r>
-            <a:endParaRPr lang="en-US" sz="1450" dirty="0"/>
-          </a:p>
-        </p:txBody>
-      </p:sp>
-      <p:sp>
-        <p:nvSpPr>
-          <p:cNvPr id="23" name="Text 21"/>
-          <p:cNvSpPr txBox="1"/>
-          <p:nvPr/>
-        </p:nvSpPr>
-        <p:spPr>
-          <a:xfrm>
-            <a:off x="6885432" y="3813048"/>
-            <a:ext cx="4114800" cy="548640"/>
-          </a:xfrm>
-          <a:prstGeom prst="rect">
-            <a:avLst/>
-          </a:prstGeom>
-          <a:noFill/>
-          <a:ln/>
-        </p:spPr>
-        <p:txBody>
-          <a:bodyPr wrap="square" lIns="0" tIns="0" rIns="0" bIns="0" rtlCol="0" anchor="ctr"/>
-          <a:lstStyle/>
-          <a:p>
-            <a:pPr indent="0" marL="0">
-              <a:lnSpc>
-                <a:spcPts val="1700"/>
-              </a:lnSpc>
-              <a:buNone/>
-            </a:pPr>
-            <a:r>
-              <a:rPr lang="en-US" sz="1200" dirty="0">
-                <a:solidFill>
-                  <a:srgbClr val="6E7A8A"/>
-                </a:solidFill>
-                <a:latin typeface="Calibri" pitchFamily="34" charset="0"/>
-                <a:ea typeface="Calibri" pitchFamily="34" charset="-122"/>
-                <a:cs typeface="Calibri" pitchFamily="34" charset="-120"/>
-              </a:rPr>
-              <a:t>텔레그램 장애 시 대시보드로 처리하고, 생성 실패 시 주제를 되돌리며, 실패도 로그에 남깁니다.</a:t>
-            </a:r>
-            <a:endParaRPr lang="en-US" sz="1200" dirty="0"/>
-          </a:p>
-        </p:txBody>
-      </p:sp>
-      <p:sp>
-        <p:nvSpPr>
-          <p:cNvPr id="24" name="Shape 22"/>
-          <p:cNvSpPr/>
-          <p:nvPr/>
-        </p:nvSpPr>
-        <p:spPr>
-          <a:xfrm>
-            <a:off x="777240" y="4892040"/>
-            <a:ext cx="10607040" cy="960120"/>
-          </a:xfrm>
-          <a:prstGeom prst="roundRect">
-            <a:avLst>
-              <a:gd name="adj" fmla="val 7619"/>
-            </a:avLst>
-          </a:prstGeom>
-          <a:solidFill>
-            <a:srgbClr val="FFFFFF"/>
-          </a:solidFill>
-          <a:ln w="12700">
-            <a:solidFill>
-              <a:srgbClr val="E6E9EF"/>
-            </a:solidFill>
-            <a:prstDash val="solid"/>
-          </a:ln>
-        </p:spPr>
-      </p:sp>
-      <p:sp>
-        <p:nvSpPr>
-          <p:cNvPr id="25" name="Text 23"/>
-          <p:cNvSpPr txBox="1"/>
-          <p:nvPr/>
-        </p:nvSpPr>
-        <p:spPr>
-          <a:xfrm>
-            <a:off x="1143000" y="5102352"/>
-            <a:ext cx="9875520" cy="640080"/>
-          </a:xfrm>
-          <a:prstGeom prst="rect">
-            <a:avLst/>
-          </a:prstGeom>
-          <a:noFill/>
-          <a:ln/>
-        </p:spPr>
-        <p:txBody>
-          <a:bodyPr wrap="square" lIns="0" tIns="0" rIns="0" bIns="0" rtlCol="0" anchor="ctr"/>
-          <a:lstStyle/>
-          <a:p>
-            <a:pPr indent="0" marL="0">
-              <a:lnSpc>
-                <a:spcPts val="1800"/>
-              </a:lnSpc>
+          <p:cNvPr id="6" name="Text 4"/>
+          <p:cNvSpPr txBox="1"/>
+          <p:nvPr/>
+        </p:nvSpPr>
+        <p:spPr>
+          <a:xfrm>
+            <a:off x="777240" y="4407408"/>
+            <a:ext cx="10058400" cy="274320"/>
+          </a:xfrm>
+          <a:prstGeom prst="rect">
+            <a:avLst/>
+          </a:prstGeom>
+          <a:noFill/>
+          <a:ln/>
+        </p:spPr>
+        <p:txBody>
+          <a:bodyPr wrap="square" lIns="0" tIns="0" rIns="0" bIns="0" rtlCol="0" anchor="ctr"/>
+          <a:lstStyle/>
+          <a:p>
+            <a:pPr indent="0" marL="0">
+              <a:buNone/>
+            </a:pPr>
+            <a:r>
+              <a:rPr lang="en-US" sz="1350" dirty="0">
+                <a:solidFill>
+                  <a:srgbClr val="8FA3C4"/>
+                </a:solidFill>
+                <a:latin typeface="Calibri" pitchFamily="34" charset="0"/>
+                <a:ea typeface="Calibri" pitchFamily="34" charset="-122"/>
+                <a:cs typeface="Calibri" pitchFamily="34" charset="-120"/>
+              </a:rPr>
+              <a:t>도입에 필요한 것 — 문의 폼에 유입 경로 파라미터 한 줄, 승인자 계정 등록, 링크드인 토큰 연결</a:t>
+            </a:r>
+            <a:endParaRPr lang="en-US" sz="1350" dirty="0"/>
+          </a:p>
+        </p:txBody>
+      </p:sp>
+      <p:sp>
+        <p:nvSpPr>
+          <p:cNvPr id="7" name="Text 5"/>
+          <p:cNvSpPr txBox="1"/>
+          <p:nvPr/>
+        </p:nvSpPr>
+        <p:spPr>
+          <a:xfrm>
+            <a:off x="777240" y="4754880"/>
+            <a:ext cx="7315200" cy="274320"/>
+          </a:xfrm>
+          <a:prstGeom prst="rect">
+            <a:avLst/>
+          </a:prstGeom>
+          <a:noFill/>
+          <a:ln/>
+        </p:spPr>
+        <p:txBody>
+          <a:bodyPr wrap="square" lIns="0" tIns="0" rIns="0" bIns="0" rtlCol="0" anchor="ctr"/>
+          <a:lstStyle/>
+          <a:p>
+            <a:pPr indent="0" marL="0">
               <a:buNone/>
             </a:pPr>
             <a:r>
               <a:rPr lang="en-US" sz="1250" dirty="0">
                 <a:solidFill>
-                  <a:srgbClr val="38445A"/>
-                </a:solidFill>
-                <a:latin typeface="Calibri" pitchFamily="34" charset="0"/>
-                <a:ea typeface="Calibri" pitchFamily="34" charset="-122"/>
-                <a:cs typeface="Calibri" pitchFamily="34" charset="-120"/>
-              </a:rPr>
-              <a:t>정직하게 덧붙이면 — 생성물은 아직 블라인드 테스트를 통과하지 못합니다. 지적된 결함(문장마다 흔들리는 어미)을 지표로 만들어 전환률을 78.9%에서 0%로 낮췄습니다. 그래서 승인 게이트가 설계의 중심에 있습니다.</a:t>
+                  <a:srgbClr val="6B7F9E"/>
+                </a:solidFill>
+                <a:latin typeface="Calibri" pitchFamily="34" charset="0"/>
+                <a:ea typeface="Calibri" pitchFamily="34" charset="-122"/>
+                <a:cs typeface="Calibri" pitchFamily="34" charset="-120"/>
+              </a:rPr>
+              <a:t>marketingbot.vercel.app</a:t>
             </a:r>
             <a:endParaRPr lang="en-US" sz="1250" dirty="0"/>
           </a:p>
@@ -7672,7 +7560,7 @@
                 <a:ea typeface="Calibri" pitchFamily="34" charset="-122"/>
                 <a:cs typeface="Calibri" pitchFamily="34" charset="-120"/>
               </a:rPr>
-              <a:t>SCOPE</a:t>
+              <a:t>참고 자료 · Q&amp;A용</a:t>
             </a:r>
             <a:endParaRPr lang="en-US" sz="1100" dirty="0"/>
           </a:p>
@@ -7711,7 +7599,7 @@
                 <a:ea typeface="Calibri" pitchFamily="34" charset="-122"/>
                 <a:cs typeface="Calibri" pitchFamily="34" charset="-120"/>
               </a:rPr>
-              <a:t>Functionalities &amp; Limitations</a:t>
+              <a:t>점수 채택 기준</a:t>
             </a:r>
             <a:endParaRPr lang="en-US" sz="3000" dirty="0"/>
           </a:p>
@@ -7719,18 +7607,57 @@
       </p:sp>
       <p:sp>
         <p:nvSpPr>
-          <p:cNvPr id="4" name="Shape 2"/>
+          <p:cNvPr id="4" name="Text 2"/>
+          <p:cNvSpPr txBox="1"/>
+          <p:nvPr/>
+        </p:nvSpPr>
+        <p:spPr>
+          <a:xfrm>
+            <a:off x="777240" y="1243584"/>
+            <a:ext cx="10241280" cy="365760"/>
+          </a:xfrm>
+          <a:prstGeom prst="rect">
+            <a:avLst/>
+          </a:prstGeom>
+          <a:noFill/>
+          <a:ln/>
+        </p:spPr>
+        <p:txBody>
+          <a:bodyPr wrap="square" lIns="0" tIns="0" rIns="0" bIns="0" rtlCol="0" anchor="ctr"/>
+          <a:lstStyle/>
+          <a:p>
+            <a:pPr indent="0" marL="0">
+              <a:buNone/>
+            </a:pPr>
+            <a:r>
+              <a:rPr lang="en-US" sz="1400" dirty="0">
+                <a:solidFill>
+                  <a:srgbClr val="6E7A8A"/>
+                </a:solidFill>
+                <a:latin typeface="Calibri" pitchFamily="34" charset="0"/>
+                <a:ea typeface="Calibri" pitchFamily="34" charset="-122"/>
+                <a:cs typeface="Calibri" pitchFamily="34" charset="-120"/>
+              </a:rPr>
+              <a:t>이 점수는 저희가 정한 이상적인 글이 아니라, 코드프레소가 실제 발행한 글 46편에서 역산한 기준입니다</a:t>
+            </a:r>
+            <a:endParaRPr lang="en-US" sz="1400" dirty="0"/>
+          </a:p>
+        </p:txBody>
+      </p:sp>
+      <p:sp>
+        <p:nvSpPr>
+          <p:cNvPr id="5" name="Shape 3"/>
           <p:cNvSpPr/>
           <p:nvPr/>
         </p:nvSpPr>
         <p:spPr>
           <a:xfrm>
-            <a:off x="777240" y="2011680"/>
-            <a:ext cx="10607040" cy="786384"/>
+            <a:off x="777240" y="1965960"/>
+            <a:ext cx="10607040" cy="868680"/>
           </a:xfrm>
           <a:prstGeom prst="roundRect">
             <a:avLst>
-              <a:gd name="adj" fmla="val 9302"/>
+              <a:gd name="adj" fmla="val 8421"/>
             </a:avLst>
           </a:prstGeom>
           <a:solidFill>
@@ -7746,26 +7673,338 @@
       </p:sp>
       <p:sp>
         <p:nvSpPr>
-          <p:cNvPr id="5" name="Shape 3"/>
+          <p:cNvPr id="6" name="Text 4"/>
+          <p:cNvSpPr txBox="1"/>
+          <p:nvPr/>
+        </p:nvSpPr>
+        <p:spPr>
+          <a:xfrm>
+            <a:off x="1097280" y="2157984"/>
+            <a:ext cx="2377440" cy="219456"/>
+          </a:xfrm>
+          <a:prstGeom prst="rect">
+            <a:avLst/>
+          </a:prstGeom>
+          <a:noFill/>
+          <a:ln/>
+        </p:spPr>
+        <p:txBody>
+          <a:bodyPr wrap="square" lIns="0" tIns="0" rIns="0" bIns="0" rtlCol="0" anchor="ctr"/>
+          <a:lstStyle/>
+          <a:p>
+            <a:pPr indent="0" marL="0">
+              <a:buNone/>
+            </a:pPr>
+            <a:r>
+              <a:rPr lang="en-US" sz="1100" dirty="0">
+                <a:solidFill>
+                  <a:srgbClr val="6E7A8A"/>
+                </a:solidFill>
+                <a:latin typeface="Calibri" pitchFamily="34" charset="0"/>
+                <a:ea typeface="Calibri" pitchFamily="34" charset="-122"/>
+                <a:cs typeface="Calibri" pitchFamily="34" charset="-120"/>
+              </a:rPr>
+              <a:t>문장 평균 길이</a:t>
+            </a:r>
+            <a:endParaRPr lang="en-US" sz="1100" dirty="0"/>
+          </a:p>
+        </p:txBody>
+      </p:sp>
+      <p:sp>
+        <p:nvSpPr>
+          <p:cNvPr id="7" name="Text 5"/>
+          <p:cNvSpPr txBox="1"/>
+          <p:nvPr/>
+        </p:nvSpPr>
+        <p:spPr>
+          <a:xfrm>
+            <a:off x="1097280" y="2395728"/>
+            <a:ext cx="2377440" cy="274320"/>
+          </a:xfrm>
+          <a:prstGeom prst="rect">
+            <a:avLst/>
+          </a:prstGeom>
+          <a:noFill/>
+          <a:ln/>
+        </p:spPr>
+        <p:txBody>
+          <a:bodyPr wrap="square" lIns="0" tIns="0" rIns="0" bIns="0" rtlCol="0" anchor="ctr"/>
+          <a:lstStyle/>
+          <a:p>
+            <a:pPr indent="0" marL="0">
+              <a:buNone/>
+            </a:pPr>
+            <a:r>
+              <a:rPr lang="en-US" sz="1500" b="1" dirty="0">
+                <a:solidFill>
+                  <a:srgbClr val="0B1220"/>
+                </a:solidFill>
+                <a:latin typeface="Calibri" pitchFamily="34" charset="0"/>
+                <a:ea typeface="Calibri" pitchFamily="34" charset="-122"/>
+                <a:cs typeface="Calibri" pitchFamily="34" charset="-120"/>
+              </a:rPr>
+              <a:t>46.9자</a:t>
+            </a:r>
+            <a:endParaRPr lang="en-US" sz="1500" dirty="0"/>
+          </a:p>
+        </p:txBody>
+      </p:sp>
+      <p:sp>
+        <p:nvSpPr>
+          <p:cNvPr id="8" name="Text 6"/>
+          <p:cNvSpPr txBox="1"/>
+          <p:nvPr/>
+        </p:nvSpPr>
+        <p:spPr>
+          <a:xfrm>
+            <a:off x="3703320" y="2157984"/>
+            <a:ext cx="2377440" cy="219456"/>
+          </a:xfrm>
+          <a:prstGeom prst="rect">
+            <a:avLst/>
+          </a:prstGeom>
+          <a:noFill/>
+          <a:ln/>
+        </p:spPr>
+        <p:txBody>
+          <a:bodyPr wrap="square" lIns="0" tIns="0" rIns="0" bIns="0" rtlCol="0" anchor="ctr"/>
+          <a:lstStyle/>
+          <a:p>
+            <a:pPr indent="0" marL="0">
+              <a:buNone/>
+            </a:pPr>
+            <a:r>
+              <a:rPr lang="en-US" sz="1100" dirty="0">
+                <a:solidFill>
+                  <a:srgbClr val="6E7A8A"/>
+                </a:solidFill>
+                <a:latin typeface="Calibri" pitchFamily="34" charset="0"/>
+                <a:ea typeface="Calibri" pitchFamily="34" charset="-122"/>
+                <a:cs typeface="Calibri" pitchFamily="34" charset="-120"/>
+              </a:rPr>
+              <a:t>어미 전환률 중앙값</a:t>
+            </a:r>
+            <a:endParaRPr lang="en-US" sz="1100" dirty="0"/>
+          </a:p>
+        </p:txBody>
+      </p:sp>
+      <p:sp>
+        <p:nvSpPr>
+          <p:cNvPr id="9" name="Text 7"/>
+          <p:cNvSpPr txBox="1"/>
+          <p:nvPr/>
+        </p:nvSpPr>
+        <p:spPr>
+          <a:xfrm>
+            <a:off x="3703320" y="2395728"/>
+            <a:ext cx="2377440" cy="274320"/>
+          </a:xfrm>
+          <a:prstGeom prst="rect">
+            <a:avLst/>
+          </a:prstGeom>
+          <a:noFill/>
+          <a:ln/>
+        </p:spPr>
+        <p:txBody>
+          <a:bodyPr wrap="square" lIns="0" tIns="0" rIns="0" bIns="0" rtlCol="0" anchor="ctr"/>
+          <a:lstStyle/>
+          <a:p>
+            <a:pPr indent="0" marL="0">
+              <a:buNone/>
+            </a:pPr>
+            <a:r>
+              <a:rPr lang="en-US" sz="1500" b="1" dirty="0">
+                <a:solidFill>
+                  <a:srgbClr val="0B1220"/>
+                </a:solidFill>
+                <a:latin typeface="Calibri" pitchFamily="34" charset="0"/>
+                <a:ea typeface="Calibri" pitchFamily="34" charset="-122"/>
+                <a:cs typeface="Calibri" pitchFamily="34" charset="-120"/>
+              </a:rPr>
+              <a:t>10.4%</a:t>
+            </a:r>
+            <a:endParaRPr lang="en-US" sz="1500" dirty="0"/>
+          </a:p>
+        </p:txBody>
+      </p:sp>
+      <p:sp>
+        <p:nvSpPr>
+          <p:cNvPr id="10" name="Text 8"/>
+          <p:cNvSpPr txBox="1"/>
+          <p:nvPr/>
+        </p:nvSpPr>
+        <p:spPr>
+          <a:xfrm>
+            <a:off x="6309360" y="2157984"/>
+            <a:ext cx="2377440" cy="219456"/>
+          </a:xfrm>
+          <a:prstGeom prst="rect">
+            <a:avLst/>
+          </a:prstGeom>
+          <a:noFill/>
+          <a:ln/>
+        </p:spPr>
+        <p:txBody>
+          <a:bodyPr wrap="square" lIns="0" tIns="0" rIns="0" bIns="0" rtlCol="0" anchor="ctr"/>
+          <a:lstStyle/>
+          <a:p>
+            <a:pPr indent="0" marL="0">
+              <a:buNone/>
+            </a:pPr>
+            <a:r>
+              <a:rPr lang="en-US" sz="1100" dirty="0">
+                <a:solidFill>
+                  <a:srgbClr val="6E7A8A"/>
+                </a:solidFill>
+                <a:latin typeface="Calibri" pitchFamily="34" charset="0"/>
+                <a:ea typeface="Calibri" pitchFamily="34" charset="-122"/>
+                <a:cs typeface="Calibri" pitchFamily="34" charset="-120"/>
+              </a:rPr>
+              <a:t>브랜드 언급</a:t>
+            </a:r>
+            <a:endParaRPr lang="en-US" sz="1100" dirty="0"/>
+          </a:p>
+        </p:txBody>
+      </p:sp>
+      <p:sp>
+        <p:nvSpPr>
+          <p:cNvPr id="11" name="Text 9"/>
+          <p:cNvSpPr txBox="1"/>
+          <p:nvPr/>
+        </p:nvSpPr>
+        <p:spPr>
+          <a:xfrm>
+            <a:off x="6309360" y="2395728"/>
+            <a:ext cx="2377440" cy="274320"/>
+          </a:xfrm>
+          <a:prstGeom prst="rect">
+            <a:avLst/>
+          </a:prstGeom>
+          <a:noFill/>
+          <a:ln/>
+        </p:spPr>
+        <p:txBody>
+          <a:bodyPr wrap="square" lIns="0" tIns="0" rIns="0" bIns="0" rtlCol="0" anchor="ctr"/>
+          <a:lstStyle/>
+          <a:p>
+            <a:pPr indent="0" marL="0">
+              <a:buNone/>
+            </a:pPr>
+            <a:r>
+              <a:rPr lang="en-US" sz="1500" b="1" dirty="0">
+                <a:solidFill>
+                  <a:srgbClr val="0B1220"/>
+                </a:solidFill>
+                <a:latin typeface="Calibri" pitchFamily="34" charset="0"/>
+                <a:ea typeface="Calibri" pitchFamily="34" charset="-122"/>
+                <a:cs typeface="Calibri" pitchFamily="34" charset="-120"/>
+              </a:rPr>
+              <a:t>1.09회 / 1,000자</a:t>
+            </a:r>
+            <a:endParaRPr lang="en-US" sz="1500" dirty="0"/>
+          </a:p>
+        </p:txBody>
+      </p:sp>
+      <p:sp>
+        <p:nvSpPr>
+          <p:cNvPr id="12" name="Text 10"/>
+          <p:cNvSpPr txBox="1"/>
+          <p:nvPr/>
+        </p:nvSpPr>
+        <p:spPr>
+          <a:xfrm>
+            <a:off x="8915400" y="2157984"/>
+            <a:ext cx="2377440" cy="219456"/>
+          </a:xfrm>
+          <a:prstGeom prst="rect">
+            <a:avLst/>
+          </a:prstGeom>
+          <a:noFill/>
+          <a:ln/>
+        </p:spPr>
+        <p:txBody>
+          <a:bodyPr wrap="square" lIns="0" tIns="0" rIns="0" bIns="0" rtlCol="0" anchor="ctr"/>
+          <a:lstStyle/>
+          <a:p>
+            <a:pPr indent="0" marL="0">
+              <a:buNone/>
+            </a:pPr>
+            <a:r>
+              <a:rPr lang="en-US" sz="1100" dirty="0">
+                <a:solidFill>
+                  <a:srgbClr val="6E7A8A"/>
+                </a:solidFill>
+                <a:latin typeface="Calibri" pitchFamily="34" charset="0"/>
+                <a:ea typeface="Calibri" pitchFamily="34" charset="-122"/>
+                <a:cs typeface="Calibri" pitchFamily="34" charset="-120"/>
+              </a:rPr>
+              <a:t>수치 인용</a:t>
+            </a:r>
+            <a:endParaRPr lang="en-US" sz="1100" dirty="0"/>
+          </a:p>
+        </p:txBody>
+      </p:sp>
+      <p:sp>
+        <p:nvSpPr>
+          <p:cNvPr id="13" name="Text 11"/>
+          <p:cNvSpPr txBox="1"/>
+          <p:nvPr/>
+        </p:nvSpPr>
+        <p:spPr>
+          <a:xfrm>
+            <a:off x="8915400" y="2395728"/>
+            <a:ext cx="2377440" cy="274320"/>
+          </a:xfrm>
+          <a:prstGeom prst="rect">
+            <a:avLst/>
+          </a:prstGeom>
+          <a:noFill/>
+          <a:ln/>
+        </p:spPr>
+        <p:txBody>
+          <a:bodyPr wrap="square" lIns="0" tIns="0" rIns="0" bIns="0" rtlCol="0" anchor="ctr"/>
+          <a:lstStyle/>
+          <a:p>
+            <a:pPr indent="0" marL="0">
+              <a:buNone/>
+            </a:pPr>
+            <a:r>
+              <a:rPr lang="en-US" sz="1500" b="1" dirty="0">
+                <a:solidFill>
+                  <a:srgbClr val="0B1220"/>
+                </a:solidFill>
+                <a:latin typeface="Calibri" pitchFamily="34" charset="0"/>
+                <a:ea typeface="Calibri" pitchFamily="34" charset="-122"/>
+                <a:cs typeface="Calibri" pitchFamily="34" charset="-120"/>
+              </a:rPr>
+              <a:t>1.26회 / 1,000자</a:t>
+            </a:r>
+            <a:endParaRPr lang="en-US" sz="1500" dirty="0"/>
+          </a:p>
+        </p:txBody>
+      </p:sp>
+      <p:sp>
+        <p:nvSpPr>
+          <p:cNvPr id="14" name="Shape 12"/>
           <p:cNvSpPr/>
           <p:nvPr/>
         </p:nvSpPr>
         <p:spPr>
           <a:xfrm>
-            <a:off x="1069848" y="2231136"/>
-            <a:ext cx="1371600" cy="347472"/>
+            <a:off x="777240" y="3063240"/>
+            <a:ext cx="10607040" cy="1554480"/>
           </a:xfrm>
           <a:prstGeom prst="roundRect">
             <a:avLst>
-              <a:gd name="adj" fmla="val 15789"/>
+              <a:gd name="adj" fmla="val 4706"/>
             </a:avLst>
           </a:prstGeom>
           <a:solidFill>
-            <a:srgbClr val="E8F3EE"/>
+            <a:srgbClr val="FFFFFF"/>
           </a:solidFill>
           <a:ln w="12700">
             <a:solidFill>
-              <a:srgbClr val="333333"/>
+              <a:srgbClr val="1A61EA"/>
             </a:solidFill>
             <a:prstDash val="solid"/>
           </a:ln>
@@ -7773,96 +8012,119 @@
       </p:sp>
       <p:sp>
         <p:nvSpPr>
-          <p:cNvPr id="6" name="Text 4"/>
-          <p:cNvSpPr txBox="1"/>
-          <p:nvPr/>
-        </p:nvSpPr>
-        <p:spPr>
-          <a:xfrm>
-            <a:off x="1069848" y="2286000"/>
-            <a:ext cx="1371600" cy="237744"/>
-          </a:xfrm>
-          <a:prstGeom prst="rect">
-            <a:avLst/>
-          </a:prstGeom>
-          <a:noFill/>
-          <a:ln/>
-        </p:spPr>
-        <p:txBody>
-          <a:bodyPr wrap="square" lIns="0" tIns="0" rIns="0" bIns="0" rtlCol="0" anchor="ctr"/>
-          <a:lstStyle/>
-          <a:p>
-            <a:pPr algn="ctr" indent="0" marL="0">
-              <a:buNone/>
-            </a:pPr>
-            <a:r>
-              <a:rPr lang="en-US" sz="1150" b="1" dirty="0">
-                <a:solidFill>
-                  <a:srgbClr val="1E8E63"/>
-                </a:solidFill>
-                <a:latin typeface="Calibri" pitchFamily="34" charset="0"/>
-                <a:ea typeface="Calibri" pitchFamily="34" charset="-122"/>
-                <a:cs typeface="Calibri" pitchFamily="34" charset="-120"/>
-              </a:rPr>
-              <a:t>실제 구현</a:t>
-            </a:r>
-            <a:endParaRPr lang="en-US" sz="1150" dirty="0"/>
-          </a:p>
-        </p:txBody>
-      </p:sp>
-      <p:sp>
-        <p:nvSpPr>
-          <p:cNvPr id="7" name="Text 5"/>
-          <p:cNvSpPr txBox="1"/>
-          <p:nvPr/>
-        </p:nvSpPr>
-        <p:spPr>
-          <a:xfrm>
-            <a:off x="2651760" y="2267712"/>
-            <a:ext cx="8412480" cy="292608"/>
-          </a:xfrm>
-          <a:prstGeom prst="rect">
-            <a:avLst/>
-          </a:prstGeom>
-          <a:noFill/>
-          <a:ln/>
-        </p:spPr>
-        <p:txBody>
-          <a:bodyPr wrap="square" lIns="0" tIns="0" rIns="0" bIns="0" rtlCol="0" anchor="ctr"/>
-          <a:lstStyle/>
-          <a:p>
-            <a:pPr indent="0" marL="0">
-              <a:buNone/>
-            </a:pPr>
-            <a:r>
-              <a:rPr lang="en-US" sz="1350" dirty="0">
-                <a:solidFill>
-                  <a:srgbClr val="0B1220"/>
-                </a:solidFill>
-                <a:latin typeface="Calibri" pitchFamily="34" charset="0"/>
-                <a:ea typeface="Calibri" pitchFamily="34" charset="-122"/>
-                <a:cs typeface="Calibri" pitchFamily="34" charset="-120"/>
-              </a:rPr>
-              <a:t>아이디어 · 기획 · 원고 · 성과 취합 · 데이터 축적</a:t>
-            </a:r>
-            <a:endParaRPr lang="en-US" sz="1350" dirty="0"/>
-          </a:p>
-        </p:txBody>
-      </p:sp>
-      <p:sp>
-        <p:nvSpPr>
-          <p:cNvPr id="8" name="Shape 6"/>
+          <p:cNvPr id="15" name="Text 13"/>
+          <p:cNvSpPr txBox="1"/>
+          <p:nvPr/>
+        </p:nvSpPr>
+        <p:spPr>
+          <a:xfrm>
+            <a:off x="1188720" y="3291840"/>
+            <a:ext cx="7315200" cy="310896"/>
+          </a:xfrm>
+          <a:prstGeom prst="rect">
+            <a:avLst/>
+          </a:prstGeom>
+          <a:noFill/>
+          <a:ln/>
+        </p:spPr>
+        <p:txBody>
+          <a:bodyPr wrap="square" lIns="0" tIns="0" rIns="0" bIns="0" rtlCol="0" anchor="ctr"/>
+          <a:lstStyle/>
+          <a:p>
+            <a:pPr indent="0" marL="0">
+              <a:buNone/>
+            </a:pPr>
+            <a:r>
+              <a:rPr lang="en-US" sz="1900" b="1" dirty="0">
+                <a:solidFill>
+                  <a:srgbClr val="1A61EA"/>
+                </a:solidFill>
+                <a:latin typeface="Calibri" pitchFamily="34" charset="0"/>
+                <a:ea typeface="Calibri" pitchFamily="34" charset="-122"/>
+                <a:cs typeface="Calibri" pitchFamily="34" charset="-120"/>
+              </a:rPr>
+              <a:t>기준을 고칠 때마다 통과해야 하는 관문</a:t>
+            </a:r>
+            <a:endParaRPr lang="en-US" sz="1900" dirty="0"/>
+          </a:p>
+        </p:txBody>
+      </p:sp>
+      <p:sp>
+        <p:nvSpPr>
+          <p:cNvPr id="16" name="Text 14"/>
+          <p:cNvSpPr txBox="1"/>
+          <p:nvPr/>
+        </p:nvSpPr>
+        <p:spPr>
+          <a:xfrm>
+            <a:off x="1188720" y="3703320"/>
+            <a:ext cx="9875520" cy="777240"/>
+          </a:xfrm>
+          <a:prstGeom prst="rect">
+            <a:avLst/>
+          </a:prstGeom>
+          <a:noFill/>
+          <a:ln/>
+        </p:spPr>
+        <p:txBody>
+          <a:bodyPr wrap="square" lIns="0" tIns="0" rIns="0" bIns="0" rtlCol="0" anchor="ctr"/>
+          <a:lstStyle/>
+          <a:p>
+            <a:pPr indent="0" marL="0">
+              <a:lnSpc>
+                <a:spcPts val="2200"/>
+              </a:lnSpc>
+              <a:buNone/>
+            </a:pPr>
+            <a:r>
+              <a:rPr lang="en-US" sz="1400" dirty="0">
+                <a:solidFill>
+                  <a:srgbClr val="38445A"/>
+                </a:solidFill>
+                <a:latin typeface="Calibri" pitchFamily="34" charset="0"/>
+                <a:ea typeface="Calibri" pitchFamily="34" charset="-122"/>
+                <a:cs typeface="Calibri" pitchFamily="34" charset="-120"/>
+              </a:rPr>
+              <a:t>수정한 채점 기준으로 그 46편을 다시 채점해 중앙값 92점이 유지되어야 채택하고, 그러지 못하면 폐기합니다.</a:t>
+            </a:r>
+            <a:endParaRPr lang="en-US" sz="1400" dirty="0"/>
+          </a:p>
+          <a:p>
+            <a:pPr indent="0" marL="0">
+              <a:lnSpc>
+                <a:spcPts val="2200"/>
+              </a:lnSpc>
+              <a:buNone/>
+            </a:pPr>
+            <a:r>
+              <a:rPr lang="en-US" sz="1400" dirty="0">
+                <a:solidFill>
+                  <a:srgbClr val="38445A"/>
+                </a:solidFill>
+                <a:latin typeface="Calibri" pitchFamily="34" charset="0"/>
+                <a:ea typeface="Calibri" pitchFamily="34" charset="-122"/>
+                <a:cs typeface="Calibri" pitchFamily="34" charset="-120"/>
+              </a:rPr>
+              <a:t>실제로 네 차례 폐기하거나 고쳤습니다. 저희 결과에 유리하도록 맞춘 지표가 아니라, 고객사의 글로 검증한 지표입니다.</a:t>
+            </a:r>
+            <a:endParaRPr lang="en-US" sz="1400" dirty="0"/>
+          </a:p>
+        </p:txBody>
+      </p:sp>
+      <p:sp>
+        <p:nvSpPr>
+          <p:cNvPr id="17" name="Shape 15"/>
           <p:cNvSpPr/>
           <p:nvPr/>
         </p:nvSpPr>
         <p:spPr>
           <a:xfrm>
-            <a:off x="777240" y="2971800"/>
-            <a:ext cx="10607040" cy="786384"/>
+            <a:off x="777240" y="4846320"/>
+            <a:ext cx="10607040" cy="1143000"/>
           </a:xfrm>
           <a:prstGeom prst="roundRect">
             <a:avLst>
-              <a:gd name="adj" fmla="val 9302"/>
+              <a:gd name="adj" fmla="val 6400"/>
             </a:avLst>
           </a:prstGeom>
           <a:solidFill>
@@ -7878,96 +8140,30 @@
       </p:sp>
       <p:sp>
         <p:nvSpPr>
-          <p:cNvPr id="9" name="Shape 7"/>
-          <p:cNvSpPr/>
-          <p:nvPr/>
-        </p:nvSpPr>
-        <p:spPr>
-          <a:xfrm>
-            <a:off x="1069848" y="3191256"/>
-            <a:ext cx="1371600" cy="347472"/>
-          </a:xfrm>
-          <a:prstGeom prst="roundRect">
-            <a:avLst>
-              <a:gd name="adj" fmla="val 15789"/>
-            </a:avLst>
-          </a:prstGeom>
-          <a:solidFill>
-            <a:srgbClr val="FDF3E3"/>
-          </a:solidFill>
-          <a:ln w="12700">
-            <a:solidFill>
-              <a:srgbClr val="333333"/>
-            </a:solidFill>
-            <a:prstDash val="solid"/>
-          </a:ln>
-        </p:spPr>
-      </p:sp>
-      <p:sp>
-        <p:nvSpPr>
-          <p:cNvPr id="10" name="Text 8"/>
-          <p:cNvSpPr txBox="1"/>
-          <p:nvPr/>
-        </p:nvSpPr>
-        <p:spPr>
-          <a:xfrm>
-            <a:off x="1069848" y="3246120"/>
-            <a:ext cx="1371600" cy="237744"/>
-          </a:xfrm>
-          <a:prstGeom prst="rect">
-            <a:avLst/>
-          </a:prstGeom>
-          <a:noFill/>
-          <a:ln/>
-        </p:spPr>
-        <p:txBody>
-          <a:bodyPr wrap="square" lIns="0" tIns="0" rIns="0" bIns="0" rtlCol="0" anchor="ctr"/>
-          <a:lstStyle/>
-          <a:p>
-            <a:pPr algn="ctr" indent="0" marL="0">
-              <a:buNone/>
-            </a:pPr>
-            <a:r>
-              <a:rPr lang="en-US" sz="1150" b="1" dirty="0">
-                <a:solidFill>
-                  <a:srgbClr val="92580F"/>
-                </a:solidFill>
-                <a:latin typeface="Calibri" pitchFamily="34" charset="0"/>
-                <a:ea typeface="Calibri" pitchFamily="34" charset="-122"/>
-                <a:cs typeface="Calibri" pitchFamily="34" charset="-120"/>
-              </a:rPr>
-              <a:t>부분 구현</a:t>
-            </a:r>
-            <a:endParaRPr lang="en-US" sz="1150" dirty="0"/>
-          </a:p>
-        </p:txBody>
-      </p:sp>
-      <p:sp>
-        <p:nvSpPr>
-          <p:cNvPr id="11" name="Text 9"/>
-          <p:cNvSpPr txBox="1"/>
-          <p:nvPr/>
-        </p:nvSpPr>
-        <p:spPr>
-          <a:xfrm>
-            <a:off x="2651760" y="3227832"/>
-            <a:ext cx="8412480" cy="292608"/>
-          </a:xfrm>
-          <a:prstGeom prst="rect">
-            <a:avLst/>
-          </a:prstGeom>
-          <a:noFill/>
-          <a:ln/>
-        </p:spPr>
-        <p:txBody>
-          <a:bodyPr wrap="square" lIns="0" tIns="0" rIns="0" bIns="0" rtlCol="0" anchor="ctr"/>
-          <a:lstStyle/>
-          <a:p>
-            <a:pPr indent="0" marL="0">
-              <a:buNone/>
-            </a:pPr>
-            <a:r>
-              <a:rPr lang="en-US" sz="1350" dirty="0">
+          <p:cNvPr id="18" name="Text 16"/>
+          <p:cNvSpPr txBox="1"/>
+          <p:nvPr/>
+        </p:nvSpPr>
+        <p:spPr>
+          <a:xfrm>
+            <a:off x="1188720" y="5029200"/>
+            <a:ext cx="4572000" cy="256032"/>
+          </a:xfrm>
+          <a:prstGeom prst="rect">
+            <a:avLst/>
+          </a:prstGeom>
+          <a:noFill/>
+          <a:ln/>
+        </p:spPr>
+        <p:txBody>
+          <a:bodyPr wrap="square" lIns="0" tIns="0" rIns="0" bIns="0" rtlCol="0" anchor="ctr"/>
+          <a:lstStyle/>
+          <a:p>
+            <a:pPr indent="0" marL="0">
+              <a:buNone/>
+            </a:pPr>
+            <a:r>
+              <a:rPr lang="en-US" sz="1350" b="1" dirty="0">
                 <a:solidFill>
                   <a:srgbClr val="0B1220"/>
                 </a:solidFill>
@@ -7975,7 +8171,7 @@
                 <a:ea typeface="Calibri" pitchFamily="34" charset="-122"/>
                 <a:cs typeface="Calibri" pitchFamily="34" charset="-120"/>
               </a:rPr>
-              <a:t>편집(이미지 제외) · 업로드(외부 채널은 큐까지)</a:t>
+              <a:t>폐기한 지표의 예</a:t>
             </a:r>
             <a:endParaRPr lang="en-US" sz="1350" dirty="0"/>
           </a:p>
@@ -7983,84 +8179,33 @@
       </p:sp>
       <p:sp>
         <p:nvSpPr>
-          <p:cNvPr id="12" name="Shape 10"/>
-          <p:cNvSpPr/>
-          <p:nvPr/>
-        </p:nvSpPr>
-        <p:spPr>
-          <a:xfrm>
-            <a:off x="777240" y="3931920"/>
-            <a:ext cx="10607040" cy="786384"/>
-          </a:xfrm>
-          <a:prstGeom prst="roundRect">
-            <a:avLst>
-              <a:gd name="adj" fmla="val 9302"/>
-            </a:avLst>
-          </a:prstGeom>
-          <a:solidFill>
-            <a:srgbClr val="FFFFFF"/>
-          </a:solidFill>
-          <a:ln w="12700">
-            <a:solidFill>
-              <a:srgbClr val="E6E9EF"/>
-            </a:solidFill>
-            <a:prstDash val="solid"/>
-          </a:ln>
-        </p:spPr>
-      </p:sp>
-      <p:sp>
-        <p:nvSpPr>
-          <p:cNvPr id="13" name="Shape 11"/>
-          <p:cNvSpPr/>
-          <p:nvPr/>
-        </p:nvSpPr>
-        <p:spPr>
-          <a:xfrm>
-            <a:off x="1069848" y="4151376"/>
-            <a:ext cx="1371600" cy="347472"/>
-          </a:xfrm>
-          <a:prstGeom prst="roundRect">
-            <a:avLst>
-              <a:gd name="adj" fmla="val 15789"/>
-            </a:avLst>
-          </a:prstGeom>
-          <a:solidFill>
-            <a:srgbClr val="F0F2F6"/>
-          </a:solidFill>
-          <a:ln w="12700">
-            <a:solidFill>
-              <a:srgbClr val="333333"/>
-            </a:solidFill>
-            <a:prstDash val="solid"/>
-          </a:ln>
-        </p:spPr>
-      </p:sp>
-      <p:sp>
-        <p:nvSpPr>
-          <p:cNvPr id="14" name="Text 12"/>
-          <p:cNvSpPr txBox="1"/>
-          <p:nvPr/>
-        </p:nvSpPr>
-        <p:spPr>
-          <a:xfrm>
-            <a:off x="1069848" y="4206240"/>
-            <a:ext cx="1371600" cy="237744"/>
-          </a:xfrm>
-          <a:prstGeom prst="rect">
-            <a:avLst/>
-          </a:prstGeom>
-          <a:noFill/>
-          <a:ln/>
-        </p:spPr>
-        <p:txBody>
-          <a:bodyPr wrap="square" lIns="0" tIns="0" rIns="0" bIns="0" rtlCol="0" anchor="ctr"/>
-          <a:lstStyle/>
-          <a:p>
-            <a:pPr algn="ctr" indent="0" marL="0">
-              <a:buNone/>
-            </a:pPr>
-            <a:r>
-              <a:rPr lang="en-US" sz="1150" b="1" dirty="0">
+          <p:cNvPr id="19" name="Text 17"/>
+          <p:cNvSpPr txBox="1"/>
+          <p:nvPr/>
+        </p:nvSpPr>
+        <p:spPr>
+          <a:xfrm>
+            <a:off x="1188720" y="5340096"/>
+            <a:ext cx="9875520" cy="548640"/>
+          </a:xfrm>
+          <a:prstGeom prst="rect">
+            <a:avLst/>
+          </a:prstGeom>
+          <a:noFill/>
+          <a:ln/>
+        </p:spPr>
+        <p:txBody>
+          <a:bodyPr wrap="square" lIns="0" tIns="0" rIns="0" bIns="0" rtlCol="0" anchor="ctr"/>
+          <a:lstStyle/>
+          <a:p>
+            <a:pPr indent="0" marL="0">
+              <a:lnSpc>
+                <a:spcPts val="1800"/>
+              </a:lnSpc>
+              <a:buNone/>
+            </a:pPr>
+            <a:r>
+              <a:rPr lang="en-US" sz="1250" dirty="0">
                 <a:solidFill>
                   <a:srgbClr val="6E7A8A"/>
                 </a:solidFill>
@@ -8068,90 +8213,9 @@
                 <a:ea typeface="Calibri" pitchFamily="34" charset="-122"/>
                 <a:cs typeface="Calibri" pitchFamily="34" charset="-120"/>
               </a:rPr>
-              <a:t>설계만</a:t>
-            </a:r>
-            <a:endParaRPr lang="en-US" sz="1150" dirty="0"/>
-          </a:p>
-        </p:txBody>
-      </p:sp>
-      <p:sp>
-        <p:nvSpPr>
-          <p:cNvPr id="15" name="Text 13"/>
-          <p:cNvSpPr txBox="1"/>
-          <p:nvPr/>
-        </p:nvSpPr>
-        <p:spPr>
-          <a:xfrm>
-            <a:off x="2651760" y="4187952"/>
-            <a:ext cx="8412480" cy="292608"/>
-          </a:xfrm>
-          <a:prstGeom prst="rect">
-            <a:avLst/>
-          </a:prstGeom>
-          <a:noFill/>
-          <a:ln/>
-        </p:spPr>
-        <p:txBody>
-          <a:bodyPr wrap="square" lIns="0" tIns="0" rIns="0" bIns="0" rtlCol="0" anchor="ctr"/>
-          <a:lstStyle/>
-          <a:p>
-            <a:pPr indent="0" marL="0">
-              <a:buNone/>
-            </a:pPr>
-            <a:r>
-              <a:rPr lang="en-US" sz="1350" dirty="0">
-                <a:solidFill>
-                  <a:srgbClr val="0B1220"/>
-                </a:solidFill>
-                <a:latin typeface="Calibri" pitchFamily="34" charset="0"/>
-                <a:ea typeface="Calibri" pitchFamily="34" charset="-122"/>
-                <a:cs typeface="Calibri" pitchFamily="34" charset="-120"/>
-              </a:rPr>
-              <a:t>SNS 확산 — 채널별 포맷 변환</a:t>
-            </a:r>
-            <a:endParaRPr lang="en-US" sz="1350" dirty="0"/>
-          </a:p>
-        </p:txBody>
-      </p:sp>
-      <p:sp>
-        <p:nvSpPr>
-          <p:cNvPr id="16" name="Text 14"/>
-          <p:cNvSpPr txBox="1"/>
-          <p:nvPr/>
-        </p:nvSpPr>
-        <p:spPr>
-          <a:xfrm>
-            <a:off x="777240" y="5120640"/>
-            <a:ext cx="10424160" cy="548640"/>
-          </a:xfrm>
-          <a:prstGeom prst="rect">
-            <a:avLst/>
-          </a:prstGeom>
-          <a:noFill/>
-          <a:ln/>
-        </p:spPr>
-        <p:txBody>
-          <a:bodyPr wrap="square" lIns="0" tIns="0" rIns="0" bIns="0" rtlCol="0" anchor="ctr"/>
-          <a:lstStyle/>
-          <a:p>
-            <a:pPr indent="0" marL="0">
-              <a:lnSpc>
-                <a:spcPts val="2000"/>
-              </a:lnSpc>
-              <a:buNone/>
-            </a:pPr>
-            <a:r>
-              <a:rPr lang="en-US" sz="1300" dirty="0">
-                <a:solidFill>
-                  <a:srgbClr val="38445A"/>
-                </a:solidFill>
-                <a:latin typeface="Calibri" pitchFamily="34" charset="0"/>
-                <a:ea typeface="Calibri" pitchFamily="34" charset="-122"/>
-                <a:cs typeface="Calibri" pitchFamily="34" charset="-120"/>
-              </a:rPr>
-              <a:t>링크드인 실제 발행만 못 했습니다. 조직 페이지 발행에는 별도 승인이 필요한데, 저희가 받은 실데이터의 출처가 바로 그 API입니다 — 코드프레소는 이미 권한을 갖고 있습니다.</a:t>
-            </a:r>
-            <a:endParaRPr lang="en-US" sz="1300" dirty="0"/>
+              <a:t>“자사 글은 굵은 글씨를 쓰지 않는다”는 신호로 30점 차이를 만들었지만, 원본을 다시 확인하니 실제로는 1,000자당 9.73회 사용하고 있었습니다. 저희 수집 과정이 만든 착시였고, 그 신호는 폐기했습니다.</a:t>
+            </a:r>
+            <a:endParaRPr lang="en-US" sz="1250" dirty="0"/>
           </a:p>
         </p:txBody>
       </p:sp>

</xml_diff>